<commit_message>
workshop: deck — add the 4-levers / lever-mix-by-vertical slides
Address that harness evolution covers prompts/tools/memory/compaction, not just
deterministic code; which lever wins depends on model strength x vertical
bottleneck. 8B retail is below the capability floor (baseline=evolved=0.00).

Co-Authored-By: Claude Opus 4.8 (1M context) <noreply@anthropic.com>
</commit_message>
<xml_diff>
--- a/workshop/harness-evolution-workshop.pptx
+++ b/workshop/harness-evolution-workshop.pptx
@@ -21,6 +21,8 @@
     <p:sldId id="269" r:id="rId20"/>
     <p:sldId id="270" r:id="rId21"/>
     <p:sldId id="271" r:id="rId22"/>
+    <p:sldId id="272" r:id="rId23"/>
+    <p:sldId id="273" r:id="rId24"/>
   </p:sldIdLst>
   <p:sldSz cx="12191695" cy="6858000" type="screen4x3"/>
   <p:notesSz cx="6858000" cy="9144000"/>
@@ -3281,7 +3283,7 @@
                 </a:solidFill>
                 <a:latin typeface="Arial"/>
               </a:rPr>
-              <a:t>Vertical-specific harnesses</a:t>
+              <a:t>So: evolve the dimension your vertical is bottlenecked on</a:t>
             </a:r>
           </a:p>
         </p:txBody>
@@ -3310,6 +3312,54 @@
           <a:p>
             <a:pPr algn="l">
               <a:spcAft>
+                <a:spcPts val="1400"/>
+              </a:spcAft>
+            </a:pPr>
+            <a:r>
+              <a:rPr sz="2100" b="0" i="1">
+                <a:solidFill>
+                  <a:srgbClr val="7C5CFF"/>
+                </a:solidFill>
+                <a:latin typeface="Arial"/>
+              </a:rPr>
+              <a:t>“Prompt dominance scales inversely with base-model strength.” — HarnessX paper</a:t>
+            </a:r>
+          </a:p>
+          <a:p>
+            <a:pPr algn="l">
+              <a:spcAft>
+                <a:spcPts val="1000"/>
+              </a:spcAft>
+            </a:pPr>
+            <a:r>
+              <a:rPr sz="1800" b="0" i="0">
+                <a:solidFill>
+                  <a:srgbClr val="141824"/>
+                </a:solidFill>
+                <a:latin typeface="Arial"/>
+              </a:rPr>
+              <a:t>•  Legal / retail reliability (frozen/weak model) → deterministic code dominates.</a:t>
+            </a:r>
+          </a:p>
+          <a:p>
+            <a:pPr algn="l">
+              <a:spcAft>
+                <a:spcPts val="1000"/>
+              </a:spcAft>
+            </a:pPr>
+            <a:r>
+              <a:rPr sz="1800" b="0" i="0">
+                <a:solidFill>
+                  <a:srgbClr val="141824"/>
+                </a:solidFill>
+                <a:latin typeface="Arial"/>
+              </a:rPr>
+              <a:t>•  LoCoMo long-context → memory + compaction. GAIA retrieval → tools. Sonnet → prompts.</a:t>
+            </a:r>
+          </a:p>
+          <a:p>
+            <a:pPr algn="l">
+              <a:spcAft>
                 <a:spcPts val="600"/>
               </a:spcAft>
             </a:pPr>
@@ -3320,55 +3370,7 @@
                 </a:solidFill>
                 <a:latin typeface="Arial"/>
               </a:rPr>
-              <a:t>τ²-Bench = real business verticals: retail · airline · telecom.</a:t>
-            </a:r>
-          </a:p>
-          <a:p>
-            <a:pPr algn="l">
-              <a:spcAft>
-                <a:spcPts val="1000"/>
-              </a:spcAft>
-            </a:pPr>
-            <a:r>
-              <a:rPr sz="1800" b="0" i="0">
-                <a:solidFill>
-                  <a:srgbClr val="141824"/>
-                </a:solidFill>
-                <a:latin typeface="Arial"/>
-              </a:rPr>
-              <a:t>•  Evolve each independently — database tasks need different processors than pure-logic puzzles.</a:t>
-            </a:r>
-          </a:p>
-          <a:p>
-            <a:pPr algn="l">
-              <a:spcAft>
-                <a:spcPts val="1000"/>
-              </a:spcAft>
-            </a:pPr>
-            <a:r>
-              <a:rPr sz="1800" b="0" i="0">
-                <a:solidFill>
-                  <a:srgbClr val="141824"/>
-                </a:solidFill>
-                <a:latin typeface="Arial"/>
-              </a:rPr>
-              <a:t>•  Reference (retail, Qwen3.5-27B agent): 0.807 → 0.965, 18/22 badcases fixed.</a:t>
-            </a:r>
-          </a:p>
-          <a:p>
-            <a:pPr algn="l">
-              <a:spcAft>
-                <a:spcPts val="1000"/>
-              </a:spcAft>
-            </a:pPr>
-            <a:r>
-              <a:rPr sz="1800" b="0" i="0">
-                <a:solidFill>
-                  <a:srgbClr val="141824"/>
-                </a:solidFill>
-                <a:latin typeface="Arial"/>
-              </a:rPr>
-              <a:t>•  Elsewhere: Database domain 0% → 53.8%.</a:t>
+              <a:t>This is the stronger thesis: not just a vertical-specific harness — the vertical-specific LEVER.</a:t>
             </a:r>
           </a:p>
         </p:txBody>
@@ -3433,23 +3435,7 @@
                 </a:solidFill>
                 <a:latin typeface="Arial"/>
               </a:rPr>
-              <a:t>Our reproduction — the “before”</a:t>
-            </a:r>
-          </a:p>
-          <a:p>
-            <a:pPr algn="l">
-              <a:spcAft>
-                <a:spcPts val="400"/>
-              </a:spcAft>
-            </a:pPr>
-            <a:r>
-              <a:rPr sz="1700" b="0" i="0">
-                <a:solidFill>
-                  <a:srgbClr val="666C7A"/>
-                </a:solidFill>
-                <a:latin typeface="Arial"/>
-              </a:rPr>
-              <a:t>τ²-Bench retail · same frozen model throughout</a:t>
+              <a:t>Inverse scaling</a:t>
             </a:r>
           </a:p>
         </p:txBody>
@@ -3488,7 +3474,7 @@
                 </a:solidFill>
                 <a:latin typeface="Arial"/>
               </a:rPr>
-              <a:t>Vanilla harness (harness_config_base.yaml): system prompt + token budget. That's it.</a:t>
+              <a:t>The weakest model gains the most.</a:t>
             </a:r>
           </a:p>
           <a:p>
@@ -3504,7 +3490,7 @@
                 </a:solidFill>
                 <a:latin typeface="Arial"/>
               </a:rPr>
-              <a:t>•  No loop detection. No parse retry. No tool correction. No tool filtering.</a:t>
+              <a:t>•  ALFWorld Qwen3.5-9B: 53 → 97 (+44)   vs   Sonnet: 83.6 → 94.8 (+11.2)</a:t>
             </a:r>
           </a:p>
           <a:p>
@@ -3520,7 +3506,7 @@
                 </a:solidFill>
                 <a:latin typeface="Arial"/>
               </a:rPr>
-              <a:t>•  Frozen local model: qwen3:8b via llama.cpp (M5 Pro, 48 GB).</a:t>
+              <a:t>•  Harness evolution makes small / cheap models punch up.</a:t>
             </a:r>
           </a:p>
           <a:p>
@@ -3536,23 +3522,7 @@
                 </a:solidFill>
                 <a:latin typeface="Arial"/>
               </a:rPr>
-              <a:t>•  Local retail baseline (5 tasks): 0.00 (0/5, retail) avg reward — every task failed.</a:t>
-            </a:r>
-          </a:p>
-          <a:p>
-            <a:pPr algn="l">
-              <a:spcAft>
-                <a:spcPts val="1000"/>
-              </a:spcAft>
-            </a:pPr>
-            <a:r>
-              <a:rPr sz="1800" b="0" i="0">
-                <a:solidFill>
-                  <a:srgbClr val="141824"/>
-                </a:solidFill>
-                <a:latin typeface="Arial"/>
-              </a:rPr>
-              <a:t>•  Task 2 looped 7+ minutes with no progress (nothing to stop it).</a:t>
+              <a:t>•  Caveat: a capability floor exists — below it, evolution can't compound.</a:t>
             </a:r>
           </a:p>
         </p:txBody>
@@ -3617,7 +3587,7 @@
                 </a:solidFill>
                 <a:latin typeface="Arial"/>
               </a:rPr>
-              <a:t>The “after” — what the meta-agent added</a:t>
+              <a:t>Vertical-specific harnesses</a:t>
             </a:r>
           </a:p>
         </p:txBody>
@@ -3656,7 +3626,7 @@
                 </a:solidFill>
                 <a:latin typeface="Arial"/>
               </a:rPr>
-              <a:t>6 deterministic processors, 0 prompt edits:</a:t>
+              <a:t>τ²-Bench = real business verticals: retail · airline · telecom.</a:t>
             </a:r>
           </a:p>
           <a:p>
@@ -3672,7 +3642,7 @@
                 </a:solidFill>
                 <a:latin typeface="Arial"/>
               </a:rPr>
-              <a:t>•  LoopDetection · ParseRetry · ToolCallCorrection · ToolFailureGuard</a:t>
+              <a:t>•  Evolve each independently — database tasks need different processors than pure-logic puzzles.</a:t>
             </a:r>
           </a:p>
           <a:p>
@@ -3688,7 +3658,7 @@
                 </a:solidFill>
                 <a:latin typeface="Arial"/>
               </a:rPr>
-              <a:t>•  PhaseAwareToolFilter (read-only until step 2 — no premature writes)</a:t>
+              <a:t>•  Reference (retail, Qwen3.5-27B agent): 0.807 → 0.965, 18/22 badcases fixed.</a:t>
             </a:r>
           </a:p>
           <a:p>
@@ -3704,39 +3674,7 @@
                 </a:solidFill>
                 <a:latin typeface="Arial"/>
               </a:rPr>
-              <a:t>•  StopGuard (+8pp on retail alone) · IRMA policy hints</a:t>
-            </a:r>
-          </a:p>
-          <a:p>
-            <a:pPr algn="l">
-              <a:spcAft>
-                <a:spcPts val="1000"/>
-              </a:spcAft>
-            </a:pPr>
-            <a:r>
-              <a:rPr sz="1800" b="0" i="0">
-                <a:solidFill>
-                  <a:srgbClr val="141824"/>
-                </a:solidFill>
-                <a:latin typeface="Arial"/>
-              </a:rPr>
-              <a:t>•  Mechanism, same 8B: loops are caught in seconds, not minutes; no premature writes.</a:t>
-            </a:r>
-          </a:p>
-          <a:p>
-            <a:pPr algn="l">
-              <a:spcAft>
-                <a:spcPts val="600"/>
-              </a:spcAft>
-            </a:pPr>
-            <a:r>
-              <a:rPr sz="2000" b="1" i="0">
-                <a:solidFill>
-                  <a:srgbClr val="141824"/>
-                </a:solidFill>
-                <a:latin typeface="Arial"/>
-              </a:rPr>
-              <a:t>Reward lift shows above the capability floor — reference (27B): 0.807 → 0.965.</a:t>
+              <a:t>•  Elsewhere: Database domain 0% → 53.8%.</a:t>
             </a:r>
           </a:p>
         </p:txBody>
@@ -3801,7 +3739,23 @@
                 </a:solidFill>
                 <a:latin typeface="Arial"/>
               </a:rPr>
-              <a:t>An honest note on the local run</a:t>
+              <a:t>Our reproduction — the “before”</a:t>
+            </a:r>
+          </a:p>
+          <a:p>
+            <a:pPr algn="l">
+              <a:spcAft>
+                <a:spcPts val="400"/>
+              </a:spcAft>
+            </a:pPr>
+            <a:r>
+              <a:rPr sz="1700" b="0" i="0">
+                <a:solidFill>
+                  <a:srgbClr val="666C7A"/>
+                </a:solidFill>
+                <a:latin typeface="Arial"/>
+              </a:rPr>
+              <a:t>τ²-Bench retail · same frozen model throughout</a:t>
             </a:r>
           </a:p>
         </p:txBody>
@@ -3840,23 +3794,7 @@
                 </a:solidFill>
                 <a:latin typeface="Arial"/>
               </a:rPr>
-              <a:t>8B on retail sits near the capability floor — baseline 0.00, so little reward to recover.</a:t>
-            </a:r>
-          </a:p>
-          <a:p>
-            <a:pPr algn="l">
-              <a:spcAft>
-                <a:spcPts val="1400"/>
-              </a:spcAft>
-            </a:pPr>
-            <a:r>
-              <a:rPr sz="2100" b="0" i="1">
-                <a:solidFill>
-                  <a:srgbClr val="7C5CFF"/>
-                </a:solidFill>
-                <a:latin typeface="Arial"/>
-              </a:rPr>
-              <a:t>This mirrors the paper: “below a capability floor, evolution cannot compound.”</a:t>
+              <a:t>Vanilla harness (harness_config_base.yaml): system prompt + token budget. That's it.</a:t>
             </a:r>
           </a:p>
           <a:p>
@@ -3872,7 +3810,7 @@
                 </a:solidFill>
                 <a:latin typeface="Arial"/>
               </a:rPr>
-              <a:t>•  Where a weak model DOES gain hugely: ALFWorld 9B 53 → 97 (+44).</a:t>
+              <a:t>•  No loop detection. No parse retry. No tool correction. No tool filtering.</a:t>
             </a:r>
           </a:p>
           <a:p>
@@ -3888,7 +3826,39 @@
                 </a:solidFill>
                 <a:latin typeface="Arial"/>
               </a:rPr>
-              <a:t>•  The laptop deliverable is the METHOD + the deterministic-code config diff — both reproduce.</a:t>
+              <a:t>•  Frozen local model: qwen3:8b via llama.cpp (M5 Pro, 48 GB).</a:t>
+            </a:r>
+          </a:p>
+          <a:p>
+            <a:pPr algn="l">
+              <a:spcAft>
+                <a:spcPts val="1000"/>
+              </a:spcAft>
+            </a:pPr>
+            <a:r>
+              <a:rPr sz="1800" b="0" i="0">
+                <a:solidFill>
+                  <a:srgbClr val="141824"/>
+                </a:solidFill>
+                <a:latin typeface="Arial"/>
+              </a:rPr>
+              <a:t>•  Local retail baseline (5 tasks): 0.00 (0/5, retail) avg reward — every task failed.</a:t>
+            </a:r>
+          </a:p>
+          <a:p>
+            <a:pPr algn="l">
+              <a:spcAft>
+                <a:spcPts val="1000"/>
+              </a:spcAft>
+            </a:pPr>
+            <a:r>
+              <a:rPr sz="1800" b="0" i="0">
+                <a:solidFill>
+                  <a:srgbClr val="141824"/>
+                </a:solidFill>
+                <a:latin typeface="Arial"/>
+              </a:rPr>
+              <a:t>•  Task 2 looped 7+ minutes with no progress (nothing to stop it).</a:t>
             </a:r>
           </a:p>
         </p:txBody>
@@ -3953,7 +3923,7 @@
                 </a:solidFill>
                 <a:latin typeface="Arial"/>
               </a:rPr>
-              <a:t>The meta-agent is YOU (Claude Code)</a:t>
+              <a:t>The “after” — what the meta-agent added</a:t>
             </a:r>
           </a:p>
         </p:txBody>
@@ -3992,7 +3962,7 @@
                 </a:solidFill>
                 <a:latin typeface="Arial"/>
               </a:rPr>
-              <a:t>evolve() = an agent that reads traces and writes config. We used Claude Code directly.</a:t>
+              <a:t>6 deterministic processors, 0 prompt edits:</a:t>
             </a:r>
           </a:p>
           <a:p>
@@ -4008,7 +3978,7 @@
                 </a:solidFill>
                 <a:latin typeface="Arial"/>
               </a:rPr>
-              <a:t>•  read failure trajectories → diagnose the pattern → author a processor → re-eval → keep if it gates</a:t>
+              <a:t>•  LoopDetection · ParseRetry · ToolCallCorrection · ToolFailureGuard</a:t>
             </a:r>
           </a:p>
           <a:p>
@@ -4024,7 +3994,55 @@
                 </a:solidFill>
                 <a:latin typeface="Arial"/>
               </a:rPr>
-              <a:t>•  No RL training. No GPU. The loop runs on a laptop.</a:t>
+              <a:t>•  PhaseAwareToolFilter (read-only until step 2 — no premature writes)</a:t>
+            </a:r>
+          </a:p>
+          <a:p>
+            <a:pPr algn="l">
+              <a:spcAft>
+                <a:spcPts val="1000"/>
+              </a:spcAft>
+            </a:pPr>
+            <a:r>
+              <a:rPr sz="1800" b="0" i="0">
+                <a:solidFill>
+                  <a:srgbClr val="141824"/>
+                </a:solidFill>
+                <a:latin typeface="Arial"/>
+              </a:rPr>
+              <a:t>•  StopGuard (+8pp on retail alone) · IRMA policy hints</a:t>
+            </a:r>
+          </a:p>
+          <a:p>
+            <a:pPr algn="l">
+              <a:spcAft>
+                <a:spcPts val="1000"/>
+              </a:spcAft>
+            </a:pPr>
+            <a:r>
+              <a:rPr sz="1800" b="0" i="0">
+                <a:solidFill>
+                  <a:srgbClr val="141824"/>
+                </a:solidFill>
+                <a:latin typeface="Arial"/>
+              </a:rPr>
+              <a:t>•  Mechanism, same 8B: loops are caught in seconds, not minutes; no premature writes.</a:t>
+            </a:r>
+          </a:p>
+          <a:p>
+            <a:pPr algn="l">
+              <a:spcAft>
+                <a:spcPts val="600"/>
+              </a:spcAft>
+            </a:pPr>
+            <a:r>
+              <a:rPr sz="2000" b="1" i="0">
+                <a:solidFill>
+                  <a:srgbClr val="141824"/>
+                </a:solidFill>
+                <a:latin typeface="Arial"/>
+              </a:rPr>
+              <a:t>Reward lift shows above the capability floor — reference (27B): 0.807 → 0.965.</a:t>
             </a:r>
           </a:p>
         </p:txBody>
@@ -4089,7 +4107,7 @@
                 </a:solidFill>
                 <a:latin typeface="Arial"/>
               </a:rPr>
-              <a:t>Reproduce it</a:t>
+              <a:t>An honest note on the local run</a:t>
             </a:r>
           </a:p>
         </p:txBody>
@@ -4128,7 +4146,23 @@
                 </a:solidFill>
                 <a:latin typeface="Arial"/>
               </a:rPr>
-              <a:t>uv + Ollama + one fork.  make baseline → (Claude Code evolves) → make eval</a:t>
+              <a:t>8B on retail sits near the capability floor — baseline 0.00, so little reward to recover.</a:t>
+            </a:r>
+          </a:p>
+          <a:p>
+            <a:pPr algn="l">
+              <a:spcAft>
+                <a:spcPts val="1400"/>
+              </a:spcAft>
+            </a:pPr>
+            <a:r>
+              <a:rPr sz="2100" b="0" i="1">
+                <a:solidFill>
+                  <a:srgbClr val="7C5CFF"/>
+                </a:solidFill>
+                <a:latin typeface="Arial"/>
+              </a:rPr>
+              <a:t>This mirrors the paper: “below a capability floor, evolution cannot compound.”</a:t>
             </a:r>
           </a:p>
           <a:p>
@@ -4144,7 +4178,7 @@
                 </a:solidFill>
                 <a:latin typeface="Arial"/>
               </a:rPr>
-              <a:t>•  Gotcha we hit: LLAMA_API_KEY in your shell 401s all local inference — unset it.</a:t>
+              <a:t>•  Where a weak model DOES gain hugely: ALFWorld 9B 53 → 97 (+44).</a:t>
             </a:r>
           </a:p>
           <a:p>
@@ -4160,7 +4194,7 @@
                 </a:solidFill>
                 <a:latin typeface="Arial"/>
               </a:rPr>
-              <a:t>•  Fork: github.com/epuerta9/HarnessX  (branch workshop/harness-evolution)</a:t>
+              <a:t>•  The laptop deliverable is the METHOD + the deterministic-code config diff — both reproduce.</a:t>
             </a:r>
           </a:p>
         </p:txBody>
@@ -4174,6 +4208,278 @@
 </file>
 
 <file path=ppt/slides/slide16.xml><?xml version="1.0" encoding="utf-8"?>
+<p:sld xmlns:a="http://schemas.openxmlformats.org/drawingml/2006/main" xmlns:p="http://schemas.openxmlformats.org/presentationml/2006/main" xmlns:r="http://schemas.openxmlformats.org/officeDocument/2006/relationships">
+  <p:cSld>
+    <p:bg>
+      <p:bgPr>
+        <a:solidFill>
+          <a:srgbClr val="F7F7FB"/>
+        </a:solidFill>
+        <a:effectLst/>
+      </p:bgPr>
+    </p:bg>
+    <p:spTree>
+      <p:nvGrpSpPr>
+        <p:cNvPr id="1" name=""/>
+        <p:cNvGrpSpPr/>
+        <p:nvPr/>
+      </p:nvGrpSpPr>
+      <p:grpSpPr/>
+      <p:sp>
+        <p:nvSpPr>
+          <p:cNvPr id="2" name="TextBox 1"/>
+          <p:cNvSpPr txBox="1"/>
+          <p:nvPr/>
+        </p:nvSpPr>
+        <p:spPr>
+          <a:xfrm>
+            <a:off x="822960" y="640080"/>
+            <a:ext cx="10515600" cy="1188720"/>
+          </a:xfrm>
+          <a:prstGeom prst="rect">
+            <a:avLst/>
+          </a:prstGeom>
+          <a:noFill/>
+        </p:spPr>
+        <p:txBody>
+          <a:bodyPr wrap="square">
+            <a:spAutoFit/>
+          </a:bodyPr>
+          <a:lstStyle/>
+          <a:p>
+            <a:pPr algn="l">
+              <a:spcAft>
+                <a:spcPts val="800"/>
+              </a:spcAft>
+            </a:pPr>
+            <a:r>
+              <a:rPr sz="3400" b="1" i="0">
+                <a:solidFill>
+                  <a:srgbClr val="141824"/>
+                </a:solidFill>
+                <a:latin typeface="Arial"/>
+              </a:rPr>
+              <a:t>The meta-agent is YOU (Claude Code)</a:t>
+            </a:r>
+          </a:p>
+        </p:txBody>
+      </p:sp>
+      <p:sp>
+        <p:nvSpPr>
+          <p:cNvPr id="3" name="TextBox 2"/>
+          <p:cNvSpPr txBox="1"/>
+          <p:nvPr/>
+        </p:nvSpPr>
+        <p:spPr>
+          <a:xfrm>
+            <a:off x="868680" y="2148840"/>
+            <a:ext cx="10424160" cy="4297680"/>
+          </a:xfrm>
+          <a:prstGeom prst="rect">
+            <a:avLst/>
+          </a:prstGeom>
+          <a:noFill/>
+        </p:spPr>
+        <p:txBody>
+          <a:bodyPr wrap="square">
+            <a:spAutoFit/>
+          </a:bodyPr>
+          <a:lstStyle/>
+          <a:p>
+            <a:pPr algn="l">
+              <a:spcAft>
+                <a:spcPts val="600"/>
+              </a:spcAft>
+            </a:pPr>
+            <a:r>
+              <a:rPr sz="2000" b="1" i="0">
+                <a:solidFill>
+                  <a:srgbClr val="141824"/>
+                </a:solidFill>
+                <a:latin typeface="Arial"/>
+              </a:rPr>
+              <a:t>evolve() = an agent that reads traces and writes config. We used Claude Code directly.</a:t>
+            </a:r>
+          </a:p>
+          <a:p>
+            <a:pPr algn="l">
+              <a:spcAft>
+                <a:spcPts val="1000"/>
+              </a:spcAft>
+            </a:pPr>
+            <a:r>
+              <a:rPr sz="1800" b="0" i="0">
+                <a:solidFill>
+                  <a:srgbClr val="141824"/>
+                </a:solidFill>
+                <a:latin typeface="Arial"/>
+              </a:rPr>
+              <a:t>•  read failure trajectories → diagnose the pattern → author a processor → re-eval → keep if it gates</a:t>
+            </a:r>
+          </a:p>
+          <a:p>
+            <a:pPr algn="l">
+              <a:spcAft>
+                <a:spcPts val="1000"/>
+              </a:spcAft>
+            </a:pPr>
+            <a:r>
+              <a:rPr sz="1800" b="0" i="0">
+                <a:solidFill>
+                  <a:srgbClr val="141824"/>
+                </a:solidFill>
+                <a:latin typeface="Arial"/>
+              </a:rPr>
+              <a:t>•  No RL training. No GPU. The loop runs on a laptop.</a:t>
+            </a:r>
+          </a:p>
+        </p:txBody>
+      </p:sp>
+    </p:spTree>
+  </p:cSld>
+  <p:clrMapOvr>
+    <a:masterClrMapping/>
+  </p:clrMapOvr>
+</p:sld>
+</file>
+
+<file path=ppt/slides/slide17.xml><?xml version="1.0" encoding="utf-8"?>
+<p:sld xmlns:a="http://schemas.openxmlformats.org/drawingml/2006/main" xmlns:p="http://schemas.openxmlformats.org/presentationml/2006/main" xmlns:r="http://schemas.openxmlformats.org/officeDocument/2006/relationships">
+  <p:cSld>
+    <p:bg>
+      <p:bgPr>
+        <a:solidFill>
+          <a:srgbClr val="F7F7FB"/>
+        </a:solidFill>
+        <a:effectLst/>
+      </p:bgPr>
+    </p:bg>
+    <p:spTree>
+      <p:nvGrpSpPr>
+        <p:cNvPr id="1" name=""/>
+        <p:cNvGrpSpPr/>
+        <p:nvPr/>
+      </p:nvGrpSpPr>
+      <p:grpSpPr/>
+      <p:sp>
+        <p:nvSpPr>
+          <p:cNvPr id="2" name="TextBox 1"/>
+          <p:cNvSpPr txBox="1"/>
+          <p:nvPr/>
+        </p:nvSpPr>
+        <p:spPr>
+          <a:xfrm>
+            <a:off x="822960" y="640080"/>
+            <a:ext cx="10515600" cy="1188720"/>
+          </a:xfrm>
+          <a:prstGeom prst="rect">
+            <a:avLst/>
+          </a:prstGeom>
+          <a:noFill/>
+        </p:spPr>
+        <p:txBody>
+          <a:bodyPr wrap="square">
+            <a:spAutoFit/>
+          </a:bodyPr>
+          <a:lstStyle/>
+          <a:p>
+            <a:pPr algn="l">
+              <a:spcAft>
+                <a:spcPts val="800"/>
+              </a:spcAft>
+            </a:pPr>
+            <a:r>
+              <a:rPr sz="3400" b="1" i="0">
+                <a:solidFill>
+                  <a:srgbClr val="141824"/>
+                </a:solidFill>
+                <a:latin typeface="Arial"/>
+              </a:rPr>
+              <a:t>Reproduce it</a:t>
+            </a:r>
+          </a:p>
+        </p:txBody>
+      </p:sp>
+      <p:sp>
+        <p:nvSpPr>
+          <p:cNvPr id="3" name="TextBox 2"/>
+          <p:cNvSpPr txBox="1"/>
+          <p:nvPr/>
+        </p:nvSpPr>
+        <p:spPr>
+          <a:xfrm>
+            <a:off x="868680" y="2148840"/>
+            <a:ext cx="10424160" cy="4297680"/>
+          </a:xfrm>
+          <a:prstGeom prst="rect">
+            <a:avLst/>
+          </a:prstGeom>
+          <a:noFill/>
+        </p:spPr>
+        <p:txBody>
+          <a:bodyPr wrap="square">
+            <a:spAutoFit/>
+          </a:bodyPr>
+          <a:lstStyle/>
+          <a:p>
+            <a:pPr algn="l">
+              <a:spcAft>
+                <a:spcPts val="600"/>
+              </a:spcAft>
+            </a:pPr>
+            <a:r>
+              <a:rPr sz="2000" b="1" i="0">
+                <a:solidFill>
+                  <a:srgbClr val="141824"/>
+                </a:solidFill>
+                <a:latin typeface="Arial"/>
+              </a:rPr>
+              <a:t>uv + Ollama + one fork.  make baseline → (Claude Code evolves) → make eval</a:t>
+            </a:r>
+          </a:p>
+          <a:p>
+            <a:pPr algn="l">
+              <a:spcAft>
+                <a:spcPts val="1000"/>
+              </a:spcAft>
+            </a:pPr>
+            <a:r>
+              <a:rPr sz="1800" b="0" i="0">
+                <a:solidFill>
+                  <a:srgbClr val="141824"/>
+                </a:solidFill>
+                <a:latin typeface="Arial"/>
+              </a:rPr>
+              <a:t>•  Gotcha we hit: LLAMA_API_KEY in your shell 401s all local inference — unset it.</a:t>
+            </a:r>
+          </a:p>
+          <a:p>
+            <a:pPr algn="l">
+              <a:spcAft>
+                <a:spcPts val="1000"/>
+              </a:spcAft>
+            </a:pPr>
+            <a:r>
+              <a:rPr sz="1800" b="0" i="0">
+                <a:solidFill>
+                  <a:srgbClr val="141824"/>
+                </a:solidFill>
+                <a:latin typeface="Arial"/>
+              </a:rPr>
+              <a:t>•  Fork: github.com/epuerta9/HarnessX  (branch workshop/harness-evolution)</a:t>
+            </a:r>
+          </a:p>
+        </p:txBody>
+      </p:sp>
+    </p:spTree>
+  </p:cSld>
+  <p:clrMapOvr>
+    <a:masterClrMapping/>
+  </p:clrMapOvr>
+</p:sld>
+</file>
+
+<file path=ppt/slides/slide18.xml><?xml version="1.0" encoding="utf-8"?>
 <p:sld xmlns:a="http://schemas.openxmlformats.org/drawingml/2006/main" xmlns:p="http://schemas.openxmlformats.org/presentationml/2006/main" xmlns:r="http://schemas.openxmlformats.org/officeDocument/2006/relationships">
   <p:cSld>
     <p:bg>
@@ -5473,7 +5779,7 @@
                 </a:solidFill>
                 <a:latin typeface="Arial"/>
               </a:rPr>
-              <a:t>Inverse scaling</a:t>
+              <a:t>But it's not only code — 4 levers</a:t>
             </a:r>
           </a:p>
         </p:txBody>
@@ -5512,7 +5818,7 @@
                 </a:solidFill>
                 <a:latin typeface="Arial"/>
               </a:rPr>
-              <a:t>The weakest model gains the most.</a:t>
+              <a:t>The evolver edits the whole harness, not just processors:</a:t>
             </a:r>
           </a:p>
           <a:p>
@@ -5528,7 +5834,7 @@
                 </a:solidFill>
                 <a:latin typeface="Arial"/>
               </a:rPr>
-              <a:t>•  ALFWorld Qwen3.5-9B: 53 → 97 (+44)   vs   Sonnet: 83.6 → 94.8 (+11.2)</a:t>
+              <a:t>•  Instruction = prompts / guidance    ·    Action = tools / skills</a:t>
             </a:r>
           </a:p>
           <a:p>
@@ -5544,7 +5850,23 @@
                 </a:solidFill>
                 <a:latin typeface="Arial"/>
               </a:rPr>
-              <a:t>•  Harness evolution makes small / cheap models punch up.</a:t>
+              <a:t>•  Control = deterministic processors    ·    Configuration = memory, compaction, knobs</a:t>
+            </a:r>
+          </a:p>
+          <a:p>
+            <a:pPr algn="l">
+              <a:spcAft>
+                <a:spcPts val="600"/>
+              </a:spcAft>
+            </a:pPr>
+            <a:r>
+              <a:rPr sz="2000" b="1" i="0">
+                <a:solidFill>
+                  <a:srgbClr val="141824"/>
+                </a:solidFill>
+                <a:latin typeface="Arial"/>
+              </a:rPr>
+              <a:t>Which lever wins depends on your model + your vertical's bottleneck:</a:t>
             </a:r>
           </a:p>
           <a:p>
@@ -5560,7 +5882,7 @@
                 </a:solidFill>
                 <a:latin typeface="Arial"/>
               </a:rPr>
-              <a:t>•  Caveat: a capability floor exists — below it, evolution can't compound.</a:t>
+              <a:t>•  strong model → prompts   ·   weak model → control code   ·   long-context → memory/compaction   ·   retrieval → tools</a:t>
             </a:r>
           </a:p>
         </p:txBody>

</xml_diff>

<commit_message>
workshop: real benchmark lift — telecom vanilla 0.50 -> IRMA 0.75 (+50%)
qwen3:32b frozen, tau2 telecom, 4 mobile_data_issue tasks. IRMA PolicyHint
rescued the data_saver|user_abroad roaming task (0.0->1.0), no regressions.
Deck before/after slides now show the real numbers + why telecom (lenient
grading + cause<->lever alignment) worked where retail (strict) didn't.

Co-Authored-By: Claude Opus 4.8 (1M context) <noreply@anthropic.com>
</commit_message>
<xml_diff>
--- a/workshop/harness-evolution-workshop.pptx
+++ b/workshop/harness-evolution-workshop.pptx
@@ -3739,7 +3739,7 @@
                 </a:solidFill>
                 <a:latin typeface="Arial"/>
               </a:rPr>
-              <a:t>Our reproduction — the “before”</a:t>
+              <a:t>Our reproduction — a real lift (telecom)</a:t>
             </a:r>
           </a:p>
           <a:p>
@@ -3755,7 +3755,7 @@
                 </a:solidFill>
                 <a:latin typeface="Arial"/>
               </a:rPr>
-              <a:t>τ²-Bench retail · same frozen model throughout</a:t>
+              <a:t>same frozen model throughout · evolved the harness, not the weights</a:t>
             </a:r>
           </a:p>
         </p:txBody>
@@ -3794,7 +3794,7 @@
                 </a:solidFill>
                 <a:latin typeface="Arial"/>
               </a:rPr>
-              <a:t>Vanilla harness (harness_config_base.yaml): system prompt + token budget. That's it.</a:t>
+              <a:t>Frozen qwen3:32B (local, llama.cpp), τ²-Bench telecom, same 4 mobile_data_issue tasks.</a:t>
             </a:r>
           </a:p>
           <a:p>
@@ -3810,7 +3810,7 @@
                 </a:solidFill>
                 <a:latin typeface="Arial"/>
               </a:rPr>
-              <a:t>•  No loop detection. No parse retry. No tool correction. No tool filtering.</a:t>
+              <a:t>•  Vanilla harness (system prompt + token budget only):  avg reward = 0.500</a:t>
             </a:r>
           </a:p>
           <a:p>
@@ -3826,7 +3826,23 @@
                 </a:solidFill>
                 <a:latin typeface="Arial"/>
               </a:rPr>
-              <a:t>•  Frozen local model: qwen3:8b via llama.cpp (M5 Pro, 48 GB).</a:t>
+              <a:t>•  + IRMA PolicyHint (telecom policy alerts):            avg reward = 0.750</a:t>
+            </a:r>
+          </a:p>
+          <a:p>
+            <a:pPr algn="l">
+              <a:spcAft>
+                <a:spcPts val="600"/>
+              </a:spcAft>
+            </a:pPr>
+            <a:r>
+              <a:rPr sz="2000" b="1" i="0">
+                <a:solidFill>
+                  <a:srgbClr val="141824"/>
+                </a:solidFill>
+                <a:latin typeface="Arial"/>
+              </a:rPr>
+              <a:t>+0.25 absolute, +50% relative — zero model-weight changes, no regressions.</a:t>
             </a:r>
           </a:p>
           <a:p>
@@ -3842,23 +3858,7 @@
                 </a:solidFill>
                 <a:latin typeface="Arial"/>
               </a:rPr>
-              <a:t>•  Local retail baseline (5 tasks): 0.00 (0/5, retail) avg reward — every task failed.</a:t>
-            </a:r>
-          </a:p>
-          <a:p>
-            <a:pPr algn="l">
-              <a:spcAft>
-                <a:spcPts val="1000"/>
-              </a:spcAft>
-            </a:pPr>
-            <a:r>
-              <a:rPr sz="1800" b="0" i="0">
-                <a:solidFill>
-                  <a:srgbClr val="141824"/>
-                </a:solidFill>
-                <a:latin typeface="Arial"/>
-              </a:rPr>
-              <a:t>•  Task 2 looped 7+ minutes with no progress (nothing to stop it).</a:t>
+              <a:t>•  Mechanism: [POLICY ALERT] injected → agent calls enable_roaming → rescues the abroad task 0.0 → 1.0.</a:t>
             </a:r>
           </a:p>
         </p:txBody>
@@ -3923,7 +3923,7 @@
                 </a:solidFill>
                 <a:latin typeface="Arial"/>
               </a:rPr>
-              <a:t>The “after” — what the meta-agent added</a:t>
+              <a:t>Why telecom worked where retail didn't</a:t>
             </a:r>
           </a:p>
         </p:txBody>
@@ -3952,6 +3952,38 @@
           <a:p>
             <a:pPr algn="l">
               <a:spcAft>
+                <a:spcPts val="1000"/>
+              </a:spcAft>
+            </a:pPr>
+            <a:r>
+              <a:rPr sz="1800" b="0" i="0">
+                <a:solidFill>
+                  <a:srgbClr val="141824"/>
+                </a:solidFill>
+                <a:latin typeface="Arial"/>
+              </a:rPr>
+              <a:t>•  Retail = strict DB-equality grading → a Q4 local model scores ~0, nothing to lift.</a:t>
+            </a:r>
+          </a:p>
+          <a:p>
+            <a:pPr algn="l">
+              <a:spcAft>
+                <a:spcPts val="1000"/>
+              </a:spcAft>
+            </a:pPr>
+            <a:r>
+              <a:rPr sz="1800" b="0" i="0">
+                <a:solidFill>
+                  <a:srgbClr val="141824"/>
+                </a:solidFill>
+                <a:latin typeface="Arial"/>
+              </a:rPr>
+              <a:t>•  Telecom = lenient outcome-state grading → non-zero baseline the harness can move.</a:t>
+            </a:r>
+          </a:p>
+          <a:p>
+            <a:pPr algn="l">
+              <a:spcAft>
                 <a:spcPts val="600"/>
               </a:spcAft>
             </a:pPr>
@@ -3962,7 +3994,7 @@
                 </a:solidFill>
                 <a:latin typeface="Arial"/>
               </a:rPr>
-              <a:t>6 deterministic processors, 0 prompt edits:</a:t>
+              <a:t>Cause ↔ lever alignment: vanilla fails the roaming task; IRMA's rule targets exactly that.</a:t>
             </a:r>
           </a:p>
           <a:p>
@@ -3978,7 +4010,7 @@
                 </a:solidFill>
                 <a:latin typeface="Arial"/>
               </a:rPr>
-              <a:t>•  LoopDetection · ParseRetry · ToolCallCorrection · ToolFailureGuard</a:t>
+              <a:t>•  Not at ceiling: 32B solves easy tasks (1.0), fails user_abroad (0.0) — room for the harness.</a:t>
             </a:r>
           </a:p>
           <a:p>
@@ -3994,55 +4026,7 @@
                 </a:solidFill>
                 <a:latin typeface="Arial"/>
               </a:rPr>
-              <a:t>•  PhaseAwareToolFilter (read-only until step 2 — no premature writes)</a:t>
-            </a:r>
-          </a:p>
-          <a:p>
-            <a:pPr algn="l">
-              <a:spcAft>
-                <a:spcPts val="1000"/>
-              </a:spcAft>
-            </a:pPr>
-            <a:r>
-              <a:rPr sz="1800" b="0" i="0">
-                <a:solidFill>
-                  <a:srgbClr val="141824"/>
-                </a:solidFill>
-                <a:latin typeface="Arial"/>
-              </a:rPr>
-              <a:t>•  StopGuard (+8pp on retail alone) · IRMA policy hints</a:t>
-            </a:r>
-          </a:p>
-          <a:p>
-            <a:pPr algn="l">
-              <a:spcAft>
-                <a:spcPts val="1000"/>
-              </a:spcAft>
-            </a:pPr>
-            <a:r>
-              <a:rPr sz="1800" b="0" i="0">
-                <a:solidFill>
-                  <a:srgbClr val="141824"/>
-                </a:solidFill>
-                <a:latin typeface="Arial"/>
-              </a:rPr>
-              <a:t>•  Mechanism, same 8B: loops are caught in seconds, not minutes; no premature writes.</a:t>
-            </a:r>
-          </a:p>
-          <a:p>
-            <a:pPr algn="l">
-              <a:spcAft>
-                <a:spcPts val="600"/>
-              </a:spcAft>
-            </a:pPr>
-            <a:r>
-              <a:rPr sz="2000" b="1" i="0">
-                <a:solidFill>
-                  <a:srgbClr val="141824"/>
-                </a:solidFill>
-                <a:latin typeface="Arial"/>
-              </a:rPr>
-              <a:t>Reward lift shows above the capability floor — reference (27B): 0.807 → 0.965.</a:t>
+              <a:t>•  A weaker 8B agent would show a BIGGER gap — inverse scaling.</a:t>
             </a:r>
           </a:p>
         </p:txBody>
@@ -4107,7 +4091,7 @@
                 </a:solidFill>
                 <a:latin typeface="Arial"/>
               </a:rPr>
-              <a:t>An honest note on the local run</a:t>
+              <a:t>An honest note on reproducing the *number*</a:t>
             </a:r>
           </a:p>
         </p:txBody>
@@ -4146,23 +4130,7 @@
                 </a:solidFill>
                 <a:latin typeface="Arial"/>
               </a:rPr>
-              <a:t>8B on retail sits near the capability floor — baseline 0.00, so little reward to recover.</a:t>
-            </a:r>
-          </a:p>
-          <a:p>
-            <a:pPr algn="l">
-              <a:spcAft>
-                <a:spcPts val="1400"/>
-              </a:spcAft>
-            </a:pPr>
-            <a:r>
-              <a:rPr sz="2100" b="0" i="1">
-                <a:solidFill>
-                  <a:srgbClr val="7C5CFF"/>
-                </a:solidFill>
-                <a:latin typeface="Arial"/>
-              </a:rPr>
-              <a:t>This mirrors the paper: “below a capability floor, evolution cannot compound.”</a:t>
+              <a:t>The METHOD reproduces on a laptop: diagnose trace → pick lever → author component → measure.</a:t>
             </a:r>
           </a:p>
           <a:p>
@@ -4178,7 +4146,7 @@
                 </a:solidFill>
                 <a:latin typeface="Arial"/>
               </a:rPr>
-              <a:t>•  Where a weak model DOES gain hugely: ALFWorld 9B 53 → 97 (+44).</a:t>
+              <a:t>•  The benchmark + grading choice matters: pick a domain where the model has a non-zero baseline.</a:t>
             </a:r>
           </a:p>
           <a:p>
@@ -4194,7 +4162,23 @@
                 </a:solidFill>
                 <a:latin typeface="Arial"/>
               </a:rPr>
-              <a:t>•  The laptop deliverable is the METHOD + the deterministic-code config diff — both reproduce.</a:t>
+              <a:t>•  Small samples are noisy — one task hit an infra timeout; the paper uses 100+ tasks, pass^k, trials.</a:t>
+            </a:r>
+          </a:p>
+          <a:p>
+            <a:pPr algn="l">
+              <a:spcAft>
+                <a:spcPts val="1000"/>
+              </a:spcAft>
+            </a:pPr>
+            <a:r>
+              <a:rPr sz="1800" b="0" i="0">
+                <a:solidFill>
+                  <a:srgbClr val="141824"/>
+                </a:solidFill>
+                <a:latin typeface="Arial"/>
+              </a:rPr>
+              <a:t>•  Reference at scale (27B retail): 0.807 → 0.965. Our local telecom: 0.50 → 0.75.</a:t>
             </a:r>
           </a:p>
         </p:txBody>

</xml_diff>

<commit_message>
workshop: experiential hands-on lab (participants drive the evolve loop)
HANDS-ON.md: run baseline -> feel the failure in the trace -> invoke the
harness-evolver skill so YOUR Claude Code diagnoses + authors the fix -> measure.
Reference solution shown only after. Deck adds a 'you drive it' format slide.

Co-Authored-By: Claude Opus 4.8 (1M context) <noreply@anthropic.com>
</commit_message>
<xml_diff>
--- a/workshop/harness-evolution-workshop.pptx
+++ b/workshop/harness-evolution-workshop.pptx
@@ -23,6 +23,7 @@
     <p:sldId id="271" r:id="rId22"/>
     <p:sldId id="272" r:id="rId23"/>
     <p:sldId id="273" r:id="rId24"/>
+    <p:sldId id="274" r:id="rId25"/>
   </p:sldIdLst>
   <p:sldSz cx="12191695" cy="6858000" type="screen4x3"/>
   <p:notesSz cx="6858000" cy="9144000"/>
@@ -4243,7 +4244,7 @@
                 </a:solidFill>
                 <a:latin typeface="Arial"/>
               </a:rPr>
-              <a:t>The meta-agent is YOU (Claude Code)</a:t>
+              <a:t>How this workshop runs — you drive it</a:t>
             </a:r>
           </a:p>
         </p:txBody>
@@ -4282,7 +4283,7 @@
                 </a:solidFill>
                 <a:latin typeface="Arial"/>
               </a:rPr>
-              <a:t>evolve() = an agent that reads traces and writes config. We used Claude Code directly.</a:t>
+              <a:t>Not slide-watching. You run the loop on your laptop.</a:t>
             </a:r>
           </a:p>
           <a:p>
@@ -4298,7 +4299,7 @@
                 </a:solidFill>
                 <a:latin typeface="Arial"/>
               </a:rPr>
-              <a:t>•  read failure trajectories → diagnose the pattern → author a processor → re-eval → keep if it gates</a:t>
+              <a:t>•  1. Run the vanilla baseline → watch a frozen model FAIL a real benchmark task.</a:t>
             </a:r>
           </a:p>
           <a:p>
@@ -4314,7 +4315,55 @@
                 </a:solidFill>
                 <a:latin typeface="Arial"/>
               </a:rPr>
-              <a:t>•  No RL training. No GPU. The loop runs on a laptop.</a:t>
+              <a:t>•  2. Read the trace frontmatter → feel it's a harness failure, not a reasoning one.</a:t>
+            </a:r>
+          </a:p>
+          <a:p>
+            <a:pPr algn="l">
+              <a:spcAft>
+                <a:spcPts val="1000"/>
+              </a:spcAft>
+            </a:pPr>
+            <a:r>
+              <a:rPr sz="1800" b="0" i="0">
+                <a:solidFill>
+                  <a:srgbClr val="141824"/>
+                </a:solidFill>
+                <a:latin typeface="Arial"/>
+              </a:rPr>
+              <a:t>•  3. Invoke the harness-evolver skill → YOUR Claude Code diagnoses + authors a fix.</a:t>
+            </a:r>
+          </a:p>
+          <a:p>
+            <a:pPr algn="l">
+              <a:spcAft>
+                <a:spcPts val="1000"/>
+              </a:spcAft>
+            </a:pPr>
+            <a:r>
+              <a:rPr sz="1800" b="0" i="0">
+                <a:solidFill>
+                  <a:srgbClr val="141824"/>
+                </a:solidFill>
+                <a:latin typeface="Arial"/>
+              </a:rPr>
+              <a:t>•  4. make eval → see the number move. Loop until it lifts.</a:t>
+            </a:r>
+          </a:p>
+          <a:p>
+            <a:pPr algn="l">
+              <a:spcAft>
+                <a:spcPts val="600"/>
+              </a:spcAft>
+            </a:pPr>
+            <a:r>
+              <a:rPr sz="2000" b="1" i="0">
+                <a:solidFill>
+                  <a:srgbClr val="141824"/>
+                </a:solidFill>
+                <a:latin typeface="Arial"/>
+              </a:rPr>
+              <a:t>A reference solution is shipped — but try your own lever first.</a:t>
             </a:r>
           </a:p>
         </p:txBody>
@@ -4379,7 +4428,7 @@
                 </a:solidFill>
                 <a:latin typeface="Arial"/>
               </a:rPr>
-              <a:t>Reproduce it</a:t>
+              <a:t>The meta-agent is YOU (Claude Code)</a:t>
             </a:r>
           </a:p>
         </p:txBody>
@@ -4418,7 +4467,7 @@
                 </a:solidFill>
                 <a:latin typeface="Arial"/>
               </a:rPr>
-              <a:t>uv + Ollama + one fork.  make baseline → (Claude Code evolves) → make eval</a:t>
+              <a:t>evolve() = an agent that reads traces and writes config. We used Claude Code directly.</a:t>
             </a:r>
           </a:p>
           <a:p>
@@ -4434,7 +4483,7 @@
                 </a:solidFill>
                 <a:latin typeface="Arial"/>
               </a:rPr>
-              <a:t>•  Gotcha we hit: LLAMA_API_KEY in your shell 401s all local inference — unset it.</a:t>
+              <a:t>•  read failure trajectories → diagnose the pattern → author a processor → re-eval → keep if it gates</a:t>
             </a:r>
           </a:p>
           <a:p>
@@ -4450,7 +4499,7 @@
                 </a:solidFill>
                 <a:latin typeface="Arial"/>
               </a:rPr>
-              <a:t>•  Fork: github.com/epuerta9/HarnessX  (branch workshop/harness-evolution)</a:t>
+              <a:t>•  No RL training. No GPU. The loop runs on a laptop.</a:t>
             </a:r>
           </a:p>
         </p:txBody>
@@ -4464,6 +4513,142 @@
 </file>
 
 <file path=ppt/slides/slide18.xml><?xml version="1.0" encoding="utf-8"?>
+<p:sld xmlns:a="http://schemas.openxmlformats.org/drawingml/2006/main" xmlns:p="http://schemas.openxmlformats.org/presentationml/2006/main" xmlns:r="http://schemas.openxmlformats.org/officeDocument/2006/relationships">
+  <p:cSld>
+    <p:bg>
+      <p:bgPr>
+        <a:solidFill>
+          <a:srgbClr val="F7F7FB"/>
+        </a:solidFill>
+        <a:effectLst/>
+      </p:bgPr>
+    </p:bg>
+    <p:spTree>
+      <p:nvGrpSpPr>
+        <p:cNvPr id="1" name=""/>
+        <p:cNvGrpSpPr/>
+        <p:nvPr/>
+      </p:nvGrpSpPr>
+      <p:grpSpPr/>
+      <p:sp>
+        <p:nvSpPr>
+          <p:cNvPr id="2" name="TextBox 1"/>
+          <p:cNvSpPr txBox="1"/>
+          <p:nvPr/>
+        </p:nvSpPr>
+        <p:spPr>
+          <a:xfrm>
+            <a:off x="822960" y="640080"/>
+            <a:ext cx="10515600" cy="1188720"/>
+          </a:xfrm>
+          <a:prstGeom prst="rect">
+            <a:avLst/>
+          </a:prstGeom>
+          <a:noFill/>
+        </p:spPr>
+        <p:txBody>
+          <a:bodyPr wrap="square">
+            <a:spAutoFit/>
+          </a:bodyPr>
+          <a:lstStyle/>
+          <a:p>
+            <a:pPr algn="l">
+              <a:spcAft>
+                <a:spcPts val="800"/>
+              </a:spcAft>
+            </a:pPr>
+            <a:r>
+              <a:rPr sz="3400" b="1" i="0">
+                <a:solidFill>
+                  <a:srgbClr val="141824"/>
+                </a:solidFill>
+                <a:latin typeface="Arial"/>
+              </a:rPr>
+              <a:t>Reproduce it</a:t>
+            </a:r>
+          </a:p>
+        </p:txBody>
+      </p:sp>
+      <p:sp>
+        <p:nvSpPr>
+          <p:cNvPr id="3" name="TextBox 2"/>
+          <p:cNvSpPr txBox="1"/>
+          <p:nvPr/>
+        </p:nvSpPr>
+        <p:spPr>
+          <a:xfrm>
+            <a:off x="868680" y="2148840"/>
+            <a:ext cx="10424160" cy="4297680"/>
+          </a:xfrm>
+          <a:prstGeom prst="rect">
+            <a:avLst/>
+          </a:prstGeom>
+          <a:noFill/>
+        </p:spPr>
+        <p:txBody>
+          <a:bodyPr wrap="square">
+            <a:spAutoFit/>
+          </a:bodyPr>
+          <a:lstStyle/>
+          <a:p>
+            <a:pPr algn="l">
+              <a:spcAft>
+                <a:spcPts val="600"/>
+              </a:spcAft>
+            </a:pPr>
+            <a:r>
+              <a:rPr sz="2000" b="1" i="0">
+                <a:solidFill>
+                  <a:srgbClr val="141824"/>
+                </a:solidFill>
+                <a:latin typeface="Arial"/>
+              </a:rPr>
+              <a:t>uv + Ollama + one fork.  make baseline → (Claude Code evolves) → make eval</a:t>
+            </a:r>
+          </a:p>
+          <a:p>
+            <a:pPr algn="l">
+              <a:spcAft>
+                <a:spcPts val="1000"/>
+              </a:spcAft>
+            </a:pPr>
+            <a:r>
+              <a:rPr sz="1800" b="0" i="0">
+                <a:solidFill>
+                  <a:srgbClr val="141824"/>
+                </a:solidFill>
+                <a:latin typeface="Arial"/>
+              </a:rPr>
+              <a:t>•  Gotcha we hit: LLAMA_API_KEY in your shell 401s all local inference — unset it.</a:t>
+            </a:r>
+          </a:p>
+          <a:p>
+            <a:pPr algn="l">
+              <a:spcAft>
+                <a:spcPts val="1000"/>
+              </a:spcAft>
+            </a:pPr>
+            <a:r>
+              <a:rPr sz="1800" b="0" i="0">
+                <a:solidFill>
+                  <a:srgbClr val="141824"/>
+                </a:solidFill>
+                <a:latin typeface="Arial"/>
+              </a:rPr>
+              <a:t>•  Fork: github.com/epuerta9/HarnessX  (branch workshop/harness-evolution)</a:t>
+            </a:r>
+          </a:p>
+        </p:txBody>
+      </p:sp>
+    </p:spTree>
+  </p:cSld>
+  <p:clrMapOvr>
+    <a:masterClrMapping/>
+  </p:clrMapOvr>
+</p:sld>
+</file>
+
+<file path=ppt/slides/slide19.xml><?xml version="1.0" encoding="utf-8"?>
 <p:sld xmlns:a="http://schemas.openxmlformats.org/drawingml/2006/main" xmlns:p="http://schemas.openxmlformats.org/presentationml/2006/main" xmlns:r="http://schemas.openxmlformats.org/officeDocument/2006/relationships">
   <p:cSld>
     <p:bg>

</xml_diff>

<commit_message>
workshop: lever->result chart + RL/take-home slides
Add make_lever_chart.py (dumbbell: vanilla->evolved reward per experiment,
annotated with the lever) and slides framing harness evolution as RL (operational
mirror: config=state, edit=action, benchmark=reward, stronger-model=policy),
what our experiment proved of the paper, and the sharpened take-home (vertical
agents need a strong benchmark = the reward signal).

Co-Authored-By: Claude Opus 4.8 (1M context) <noreply@anthropic.com>
</commit_message>
<xml_diff>
--- a/workshop/harness-evolution-workshop.pptx
+++ b/workshop/harness-evolution-workshop.pptx
@@ -24,6 +24,9 @@
     <p:sldId id="272" r:id="rId23"/>
     <p:sldId id="273" r:id="rId24"/>
     <p:sldId id="274" r:id="rId25"/>
+    <p:sldId id="275" r:id="rId26"/>
+    <p:sldId id="276" r:id="rId27"/>
+    <p:sldId id="277" r:id="rId28"/>
   </p:sldIdLst>
   <p:sldSz cx="12191695" cy="6858000" type="screen4x3"/>
   <p:notesSz cx="6858000" cy="9144000"/>
@@ -4654,7 +4657,7 @@
     <p:bg>
       <p:bgPr>
         <a:solidFill>
-          <a:srgbClr val="141824"/>
+          <a:srgbClr val="F7F7FB"/>
         </a:solidFill>
         <a:effectLst/>
       </p:bgPr>
@@ -4675,7 +4678,7 @@
         <p:spPr>
           <a:xfrm>
             <a:off x="822960" y="640080"/>
-            <a:ext cx="10515600" cy="914400"/>
+            <a:ext cx="10515600" cy="1188720"/>
           </a:xfrm>
           <a:prstGeom prst="rect">
             <a:avLst/>
@@ -4694,13 +4697,13 @@
               </a:spcAft>
             </a:pPr>
             <a:r>
-              <a:rPr sz="3600" b="1" i="0">
-                <a:solidFill>
-                  <a:srgbClr val="FFFFFF"/>
-                </a:solidFill>
-                <a:latin typeface="Arial"/>
-              </a:rPr>
-              <a:t>Takeaways</a:t>
+              <a:rPr sz="3400" b="1" i="0">
+                <a:solidFill>
+                  <a:srgbClr val="141824"/>
+                </a:solidFill>
+                <a:latin typeface="Arial"/>
+              </a:rPr>
+              <a:t>Harness evolution IS reinforcement learning</a:t>
             </a:r>
           </a:p>
         </p:txBody>
@@ -4713,8 +4716,8 @@
         </p:nvSpPr>
         <p:spPr>
           <a:xfrm>
-            <a:off x="868680" y="1828800"/>
-            <a:ext cx="10515600" cy="4572000"/>
+            <a:off x="868680" y="2148840"/>
+            <a:ext cx="10424160" cy="4297680"/>
           </a:xfrm>
           <a:prstGeom prst="rect">
             <a:avLst/>
@@ -4729,81 +4732,81 @@
           <a:p>
             <a:pPr algn="l">
               <a:spcAft>
-                <a:spcPts val="1600"/>
+                <a:spcPts val="600"/>
               </a:spcAft>
             </a:pPr>
             <a:r>
               <a:rPr sz="2000" b="1" i="0">
                 <a:solidFill>
-                  <a:srgbClr val="22C55E"/>
-                </a:solidFill>
-                <a:latin typeface="Arial"/>
-              </a:rPr>
-              <a:t>1.  The harness, not just the model, determines agent performance.</a:t>
-            </a:r>
-          </a:p>
-          <a:p>
-            <a:pPr algn="l">
-              <a:spcAft>
-                <a:spcPts val="1600"/>
-              </a:spcAft>
-            </a:pPr>
-            <a:r>
-              <a:rPr sz="2000" b="0" i="0">
-                <a:solidFill>
-                  <a:srgbClr val="FFFFFF"/>
-                </a:solidFill>
-                <a:latin typeface="Arial"/>
-              </a:rPr>
-              <a:t>2.  Vertical-specific → evolve (or design) a vertical-specific harness.</a:t>
-            </a:r>
-          </a:p>
-          <a:p>
-            <a:pPr algn="l">
-              <a:spcAft>
-                <a:spcPts val="1600"/>
-              </a:spcAft>
-            </a:pPr>
-            <a:r>
-              <a:rPr sz="2000" b="0" i="0">
-                <a:solidFill>
-                  <a:srgbClr val="22C55E"/>
-                </a:solidFill>
-                <a:latin typeface="Arial"/>
-              </a:rPr>
-              <a:t>3.  The wins are mostly deterministic code — testable, portable, versionable.</a:t>
-            </a:r>
-          </a:p>
-          <a:p>
-            <a:pPr algn="l">
-              <a:spcAft>
-                <a:spcPts val="1600"/>
-              </a:spcAft>
-            </a:pPr>
-            <a:r>
-              <a:rPr sz="2000" b="0" i="0">
-                <a:solidFill>
-                  <a:srgbClr val="FFFFFF"/>
-                </a:solidFill>
-                <a:latin typeface="Arial"/>
-              </a:rPr>
-              <a:t>4.  Own your harness components: optimization tracks business-need drift.</a:t>
-            </a:r>
-          </a:p>
-          <a:p>
-            <a:pPr algn="l">
-              <a:spcAft>
-                <a:spcPts val="1600"/>
-              </a:spcAft>
-            </a:pPr>
-            <a:r>
-              <a:rPr sz="2000" b="0" i="0">
-                <a:solidFill>
-                  <a:srgbClr val="22C55E"/>
-                </a:solidFill>
-                <a:latin typeface="Arial"/>
-              </a:rPr>
-              <a:t>5.  Weakest models gain most — harness evolution is how small models punch up.</a:t>
+                  <a:srgbClr val="141824"/>
+                </a:solidFill>
+                <a:latin typeface="Arial"/>
+              </a:rPr>
+              <a:t>The “operational mirror” — with the model FROZEN:</a:t>
+            </a:r>
+          </a:p>
+          <a:p>
+            <a:pPr algn="l">
+              <a:spcAft>
+                <a:spcPts val="1000"/>
+              </a:spcAft>
+            </a:pPr>
+            <a:r>
+              <a:rPr sz="1800" b="0" i="0">
+                <a:solidFill>
+                  <a:srgbClr val="141824"/>
+                </a:solidFill>
+                <a:latin typeface="Arial"/>
+              </a:rPr>
+              <a:t>•  State = the HarnessConfig   ·   Action = pull one of the 4 levers</a:t>
+            </a:r>
+          </a:p>
+          <a:p>
+            <a:pPr algn="l">
+              <a:spcAft>
+                <a:spcPts val="1000"/>
+              </a:spcAft>
+            </a:pPr>
+            <a:r>
+              <a:rPr sz="1800" b="0" i="0">
+                <a:solidFill>
+                  <a:srgbClr val="141824"/>
+                </a:solidFill>
+                <a:latin typeface="Arial"/>
+              </a:rPr>
+              <a:t>•  Policy = a stronger model reading the traces (that's Claude Code)</a:t>
+            </a:r>
+          </a:p>
+          <a:p>
+            <a:pPr algn="l">
+              <a:spcAft>
+                <a:spcPts val="1000"/>
+              </a:spcAft>
+            </a:pPr>
+            <a:r>
+              <a:rPr sz="1800" b="0" i="0">
+                <a:solidFill>
+                  <a:srgbClr val="141824"/>
+                </a:solidFill>
+                <a:latin typeface="Arial"/>
+              </a:rPr>
+              <a:t>•  Reward = the benchmark score   ·   Rollout = re-run the task set   ·   Gate = keep if reward↑</a:t>
+            </a:r>
+          </a:p>
+          <a:p>
+            <a:pPr algn="l">
+              <a:spcAft>
+                <a:spcPts val="600"/>
+              </a:spcAft>
+            </a:pPr>
+            <a:r>
+              <a:rPr sz="2000" b="1" i="0">
+                <a:solidFill>
+                  <a:srgbClr val="141824"/>
+                </a:solidFill>
+                <a:latin typeface="Arial"/>
+              </a:rPr>
+              <a:t>Agentic RL = use a stronger model to read traces, pick the lever, re-run, keep what improves.</a:t>
             </a:r>
           </a:p>
         </p:txBody>
@@ -4956,6 +4959,486 @@
                 <a:latin typeface="Arial"/>
               </a:rPr>
               <a:t>The question isn't “which model” — it's “which harness.”</a:t>
+            </a:r>
+          </a:p>
+        </p:txBody>
+      </p:sp>
+    </p:spTree>
+  </p:cSld>
+  <p:clrMapOvr>
+    <a:masterClrMapping/>
+  </p:clrMapOvr>
+</p:sld>
+</file>
+
+<file path=ppt/slides/slide20.xml><?xml version="1.0" encoding="utf-8"?>
+<p:sld xmlns:a="http://schemas.openxmlformats.org/drawingml/2006/main" xmlns:p="http://schemas.openxmlformats.org/presentationml/2006/main" xmlns:r="http://schemas.openxmlformats.org/officeDocument/2006/relationships">
+  <p:cSld>
+    <p:bg>
+      <p:bgPr>
+        <a:solidFill>
+          <a:srgbClr val="F7F7FB"/>
+        </a:solidFill>
+        <a:effectLst/>
+      </p:bgPr>
+    </p:bg>
+    <p:spTree>
+      <p:nvGrpSpPr>
+        <p:cNvPr id="1" name=""/>
+        <p:cNvGrpSpPr/>
+        <p:nvPr/>
+      </p:nvGrpSpPr>
+      <p:grpSpPr/>
+      <p:sp>
+        <p:nvSpPr>
+          <p:cNvPr id="2" name="TextBox 1"/>
+          <p:cNvSpPr txBox="1"/>
+          <p:nvPr/>
+        </p:nvSpPr>
+        <p:spPr>
+          <a:xfrm>
+            <a:off x="822960" y="502920"/>
+            <a:ext cx="10515600" cy="914400"/>
+          </a:xfrm>
+          <a:prstGeom prst="rect">
+            <a:avLst/>
+          </a:prstGeom>
+          <a:noFill/>
+        </p:spPr>
+        <p:txBody>
+          <a:bodyPr wrap="square">
+            <a:spAutoFit/>
+          </a:bodyPr>
+          <a:lstStyle/>
+          <a:p>
+            <a:pPr algn="l">
+              <a:spcAft>
+                <a:spcPts val="800"/>
+              </a:spcAft>
+            </a:pPr>
+            <a:r>
+              <a:rPr sz="3000" b="1" i="0">
+                <a:solidFill>
+                  <a:srgbClr val="141824"/>
+                </a:solidFill>
+                <a:latin typeface="Arial"/>
+              </a:rPr>
+              <a:t>Which lever moved the number</a:t>
+            </a:r>
+          </a:p>
+        </p:txBody>
+      </p:sp>
+      <p:pic>
+        <p:nvPicPr>
+          <p:cNvPr id="3" name="Picture 2" descr="lever-result-chart.png"/>
+          <p:cNvPicPr>
+            <a:picLocks noChangeAspect="1"/>
+          </p:cNvPicPr>
+          <p:nvPr/>
+        </p:nvPicPr>
+        <p:blipFill>
+          <a:blip r:embed="rId2"/>
+          <a:stretch>
+            <a:fillRect/>
+          </a:stretch>
+        </p:blipFill>
+        <p:spPr>
+          <a:xfrm>
+            <a:off x="1249527" y="1737360"/>
+            <a:ext cx="9692640" cy="3673000"/>
+          </a:xfrm>
+          <a:prstGeom prst="rect">
+            <a:avLst/>
+          </a:prstGeom>
+        </p:spPr>
+      </p:pic>
+      <p:sp>
+        <p:nvSpPr>
+          <p:cNvPr id="4" name="TextBox 3"/>
+          <p:cNvSpPr txBox="1"/>
+          <p:nvPr/>
+        </p:nvSpPr>
+        <p:spPr>
+          <a:xfrm>
+            <a:off x="822960" y="6126480"/>
+            <a:ext cx="10515600" cy="548640"/>
+          </a:xfrm>
+          <a:prstGeom prst="rect">
+            <a:avLst/>
+          </a:prstGeom>
+          <a:noFill/>
+        </p:spPr>
+        <p:txBody>
+          <a:bodyPr wrap="square">
+            <a:spAutoFit/>
+          </a:bodyPr>
+          <a:lstStyle/>
+          <a:p>
+            <a:pPr algn="ctr">
+              <a:spcAft>
+                <a:spcPts val="800"/>
+              </a:spcAft>
+            </a:pPr>
+            <a:r>
+              <a:rPr sz="1300" b="0" i="0">
+                <a:solidFill>
+                  <a:srgbClr val="666C7A"/>
+                </a:solidFill>
+                <a:latin typeface="Arial"/>
+              </a:rPr>
+              <a:t>Same frozen model. The lever lifts the score only when the benchmark gives a signal AND the failure matches the lever.</a:t>
+            </a:r>
+          </a:p>
+        </p:txBody>
+      </p:sp>
+    </p:spTree>
+  </p:cSld>
+  <p:clrMapOvr>
+    <a:masterClrMapping/>
+  </p:clrMapOvr>
+</p:sld>
+</file>
+
+<file path=ppt/slides/slide21.xml><?xml version="1.0" encoding="utf-8"?>
+<p:sld xmlns:a="http://schemas.openxmlformats.org/drawingml/2006/main" xmlns:p="http://schemas.openxmlformats.org/presentationml/2006/main" xmlns:r="http://schemas.openxmlformats.org/officeDocument/2006/relationships">
+  <p:cSld>
+    <p:bg>
+      <p:bgPr>
+        <a:solidFill>
+          <a:srgbClr val="F7F7FB"/>
+        </a:solidFill>
+        <a:effectLst/>
+      </p:bgPr>
+    </p:bg>
+    <p:spTree>
+      <p:nvGrpSpPr>
+        <p:cNvPr id="1" name=""/>
+        <p:cNvGrpSpPr/>
+        <p:nvPr/>
+      </p:nvGrpSpPr>
+      <p:grpSpPr/>
+      <p:sp>
+        <p:nvSpPr>
+          <p:cNvPr id="2" name="TextBox 1"/>
+          <p:cNvSpPr txBox="1"/>
+          <p:nvPr/>
+        </p:nvSpPr>
+        <p:spPr>
+          <a:xfrm>
+            <a:off x="822960" y="640080"/>
+            <a:ext cx="10515600" cy="1188720"/>
+          </a:xfrm>
+          <a:prstGeom prst="rect">
+            <a:avLst/>
+          </a:prstGeom>
+          <a:noFill/>
+        </p:spPr>
+        <p:txBody>
+          <a:bodyPr wrap="square">
+            <a:spAutoFit/>
+          </a:bodyPr>
+          <a:lstStyle/>
+          <a:p>
+            <a:pPr algn="l">
+              <a:spcAft>
+                <a:spcPts val="800"/>
+              </a:spcAft>
+            </a:pPr>
+            <a:r>
+              <a:rPr sz="3400" b="1" i="0">
+                <a:solidFill>
+                  <a:srgbClr val="141824"/>
+                </a:solidFill>
+                <a:latin typeface="Arial"/>
+              </a:rPr>
+              <a:t>Did we prove the paper? (partly — yes)</a:t>
+            </a:r>
+          </a:p>
+        </p:txBody>
+      </p:sp>
+      <p:sp>
+        <p:nvSpPr>
+          <p:cNvPr id="3" name="TextBox 2"/>
+          <p:cNvSpPr txBox="1"/>
+          <p:nvPr/>
+        </p:nvSpPr>
+        <p:spPr>
+          <a:xfrm>
+            <a:off x="868680" y="2148840"/>
+            <a:ext cx="10424160" cy="4297680"/>
+          </a:xfrm>
+          <a:prstGeom prst="rect">
+            <a:avLst/>
+          </a:prstGeom>
+          <a:noFill/>
+        </p:spPr>
+        <p:txBody>
+          <a:bodyPr wrap="square">
+            <a:spAutoFit/>
+          </a:bodyPr>
+          <a:lstStyle/>
+          <a:p>
+            <a:pPr algn="l">
+              <a:spcAft>
+                <a:spcPts val="1000"/>
+              </a:spcAft>
+            </a:pPr>
+            <a:r>
+              <a:rPr sz="1800" b="0" i="0">
+                <a:solidFill>
+                  <a:srgbClr val="141824"/>
+                </a:solidFill>
+                <a:latin typeface="Arial"/>
+              </a:rPr>
+              <a:t>•  ✓ A FROZEN model's benchmark score rose via a harness edit alone (telecom 0.50 → 0.75).</a:t>
+            </a:r>
+          </a:p>
+          <a:p>
+            <a:pPr algn="l">
+              <a:spcAft>
+                <a:spcPts val="1000"/>
+              </a:spcAft>
+            </a:pPr>
+            <a:r>
+              <a:rPr sz="1800" b="0" i="0">
+                <a:solidFill>
+                  <a:srgbClr val="141824"/>
+                </a:solidFill>
+                <a:latin typeface="Arial"/>
+              </a:rPr>
+              <a:t>•  ✓ The moat is the infrastructure — we diagnosed + evolved purely off typed processors + structured traces.</a:t>
+            </a:r>
+          </a:p>
+          <a:p>
+            <a:pPr algn="l">
+              <a:spcAft>
+                <a:spcPts val="1000"/>
+              </a:spcAft>
+            </a:pPr>
+            <a:r>
+              <a:rPr sz="1800" b="0" i="0">
+                <a:solidFill>
+                  <a:srgbClr val="141824"/>
+                </a:solidFill>
+                <a:latin typeface="Arial"/>
+              </a:rPr>
+              <a:t>•  ✓ Lever mix is context-dependent — IRMA worked on telecom, did nothing on retail (grading mismatch).</a:t>
+            </a:r>
+          </a:p>
+          <a:p>
+            <a:pPr algn="l">
+              <a:spcAft>
+                <a:spcPts val="1000"/>
+              </a:spcAft>
+            </a:pPr>
+            <a:r>
+              <a:rPr sz="1800" b="0" i="0">
+                <a:solidFill>
+                  <a:srgbClr val="141824"/>
+                </a:solidFill>
+                <a:latin typeface="Arial"/>
+              </a:rPr>
+              <a:t>•  ✓ Ceiling/floor effects — 32B at ceiling on easy tasks; strict retail grading = effective floor.</a:t>
+            </a:r>
+          </a:p>
+          <a:p>
+            <a:pPr algn="l">
+              <a:spcAft>
+                <a:spcPts val="600"/>
+              </a:spcAft>
+            </a:pPr>
+            <a:r>
+              <a:rPr sz="2000" b="1" i="0">
+                <a:solidFill>
+                  <a:srgbClr val="141824"/>
+                </a:solidFill>
+                <a:latin typeface="Arial"/>
+              </a:rPr>
+              <a:t>Not reproduced (needs scale): +14.5% magnitudes, multi-round + the 3 RL pathologies, AEGIS, co-evolution.</a:t>
+            </a:r>
+          </a:p>
+        </p:txBody>
+      </p:sp>
+    </p:spTree>
+  </p:cSld>
+  <p:clrMapOvr>
+    <a:masterClrMapping/>
+  </p:clrMapOvr>
+</p:sld>
+</file>
+
+<file path=ppt/slides/slide22.xml><?xml version="1.0" encoding="utf-8"?>
+<p:sld xmlns:a="http://schemas.openxmlformats.org/drawingml/2006/main" xmlns:p="http://schemas.openxmlformats.org/presentationml/2006/main" xmlns:r="http://schemas.openxmlformats.org/officeDocument/2006/relationships">
+  <p:cSld>
+    <p:bg>
+      <p:bgPr>
+        <a:solidFill>
+          <a:srgbClr val="141824"/>
+        </a:solidFill>
+        <a:effectLst/>
+      </p:bgPr>
+    </p:bg>
+    <p:spTree>
+      <p:nvGrpSpPr>
+        <p:cNvPr id="1" name=""/>
+        <p:cNvGrpSpPr/>
+        <p:nvPr/>
+      </p:nvGrpSpPr>
+      <p:grpSpPr/>
+      <p:sp>
+        <p:nvSpPr>
+          <p:cNvPr id="2" name="TextBox 1"/>
+          <p:cNvSpPr txBox="1"/>
+          <p:nvPr/>
+        </p:nvSpPr>
+        <p:spPr>
+          <a:xfrm>
+            <a:off x="822960" y="640080"/>
+            <a:ext cx="10515600" cy="914400"/>
+          </a:xfrm>
+          <a:prstGeom prst="rect">
+            <a:avLst/>
+          </a:prstGeom>
+          <a:noFill/>
+        </p:spPr>
+        <p:txBody>
+          <a:bodyPr wrap="square">
+            <a:spAutoFit/>
+          </a:bodyPr>
+          <a:lstStyle/>
+          <a:p>
+            <a:pPr algn="l">
+              <a:spcAft>
+                <a:spcPts val="800"/>
+              </a:spcAft>
+            </a:pPr>
+            <a:r>
+              <a:rPr sz="3600" b="1" i="0">
+                <a:solidFill>
+                  <a:srgbClr val="FFFFFF"/>
+                </a:solidFill>
+                <a:latin typeface="Arial"/>
+              </a:rPr>
+              <a:t>Takeaways</a:t>
+            </a:r>
+          </a:p>
+        </p:txBody>
+      </p:sp>
+      <p:sp>
+        <p:nvSpPr>
+          <p:cNvPr id="3" name="TextBox 2"/>
+          <p:cNvSpPr txBox="1"/>
+          <p:nvPr/>
+        </p:nvSpPr>
+        <p:spPr>
+          <a:xfrm>
+            <a:off x="868680" y="1828800"/>
+            <a:ext cx="10515600" cy="4572000"/>
+          </a:xfrm>
+          <a:prstGeom prst="rect">
+            <a:avLst/>
+          </a:prstGeom>
+          <a:noFill/>
+        </p:spPr>
+        <p:txBody>
+          <a:bodyPr wrap="square">
+            <a:spAutoFit/>
+          </a:bodyPr>
+          <a:lstStyle/>
+          <a:p>
+            <a:pPr algn="l">
+              <a:spcAft>
+                <a:spcPts val="1600"/>
+              </a:spcAft>
+            </a:pPr>
+            <a:r>
+              <a:rPr sz="2000" b="1" i="0">
+                <a:solidFill>
+                  <a:srgbClr val="22C55E"/>
+                </a:solidFill>
+                <a:latin typeface="Arial"/>
+              </a:rPr>
+              <a:t>1.  The harness, not just the model, determines REALIZED agent performance.</a:t>
+            </a:r>
+          </a:p>
+          <a:p>
+            <a:pPr algn="l">
+              <a:spcAft>
+                <a:spcPts val="1600"/>
+              </a:spcAft>
+            </a:pPr>
+            <a:r>
+              <a:rPr sz="2000" b="0" i="0">
+                <a:solidFill>
+                  <a:srgbClr val="FFFFFF"/>
+                </a:solidFill>
+                <a:latin typeface="Arial"/>
+              </a:rPr>
+              <a:t>2.  We improved a frozen model's benchmark score by evolving the harness alone (0.50 → 0.75).</a:t>
+            </a:r>
+          </a:p>
+          <a:p>
+            <a:pPr algn="l">
+              <a:spcAft>
+                <a:spcPts val="1600"/>
+              </a:spcAft>
+            </a:pPr>
+            <a:r>
+              <a:rPr sz="2000" b="0" i="0">
+                <a:solidFill>
+                  <a:srgbClr val="22C55E"/>
+                </a:solidFill>
+                <a:latin typeface="Arial"/>
+              </a:rPr>
+              <a:t>3.  Vertical agents need a STRONG BENCHMARK to evolve against — it's the reward signal.</a:t>
+            </a:r>
+          </a:p>
+          <a:p>
+            <a:pPr algn="l">
+              <a:spcAft>
+                <a:spcPts val="1600"/>
+              </a:spcAft>
+            </a:pPr>
+            <a:r>
+              <a:rPr sz="2000" b="0" i="0">
+                <a:solidFill>
+                  <a:srgbClr val="FFFFFF"/>
+                </a:solidFill>
+                <a:latin typeface="Arial"/>
+              </a:rPr>
+              <a:t>4.  Off-the-shelf model + off-the-shelf harness plateaus: nothing tells you which lever to move.</a:t>
+            </a:r>
+          </a:p>
+          <a:p>
+            <a:pPr algn="l">
+              <a:spcAft>
+                <a:spcPts val="1600"/>
+              </a:spcAft>
+            </a:pPr>
+            <a:r>
+              <a:rPr sz="2000" b="0" i="0">
+                <a:solidFill>
+                  <a:srgbClr val="22C55E"/>
+                </a:solidFill>
+                <a:latin typeface="Arial"/>
+              </a:rPr>
+              <a:t>5.  Agentic RL: a stronger model reads traces → picks the lever → re-runs → keeps what improves.</a:t>
+            </a:r>
+          </a:p>
+          <a:p>
+            <a:pPr algn="l">
+              <a:spcAft>
+                <a:spcPts val="1600"/>
+              </a:spcAft>
+            </a:pPr>
+            <a:r>
+              <a:rPr sz="2000" b="0" i="0">
+                <a:solidFill>
+                  <a:srgbClr val="FFFFFF"/>
+                </a:solidFill>
+                <a:latin typeface="Arial"/>
+              </a:rPr>
+              <a:t>6.  This is how you squeeze a cheap, frozen model to punch up on YOUR problem.</a:t>
             </a:r>
           </a:p>
         </p:txBody>

</xml_diff>

<commit_message>
workshop: deck ablation slide + HANDS-ON attribution step
Co-Authored-By: Claude Opus 4.8 (1M context) <noreply@anthropic.com>
</commit_message>
<xml_diff>
--- a/workshop/harness-evolution-workshop.pptx
+++ b/workshop/harness-evolution-workshop.pptx
@@ -27,6 +27,7 @@
     <p:sldId id="275" r:id="rId26"/>
     <p:sldId id="276" r:id="rId27"/>
     <p:sldId id="277" r:id="rId28"/>
+    <p:sldId id="278" r:id="rId29"/>
   </p:sldIdLst>
   <p:sldSz cx="12191695" cy="6858000" type="screen4x3"/>
   <p:notesSz cx="6858000" cy="9144000"/>
@@ -5151,7 +5152,7 @@
                 </a:solidFill>
                 <a:latin typeface="Arial"/>
               </a:rPr>
-              <a:t>Did we prove the paper? (partly — yes)</a:t>
+              <a:t>Which component makes the biggest difference?</a:t>
             </a:r>
           </a:p>
         </p:txBody>
@@ -5180,6 +5181,22 @@
           <a:p>
             <a:pPr algn="l">
               <a:spcAft>
+                <a:spcPts val="600"/>
+              </a:spcAft>
+            </a:pPr>
+            <a:r>
+              <a:rPr sz="2000" b="1" i="0">
+                <a:solidFill>
+                  <a:srgbClr val="141824"/>
+                </a:solidFill>
+                <a:latin typeface="Arial"/>
+              </a:rPr>
+              <a:t>Ablation: run vanilla / control-only / IRMA-only / full on the SAME tasks.</a:t>
+            </a:r>
+          </a:p>
+          <a:p>
+            <a:pPr algn="l">
+              <a:spcAft>
                 <a:spcPts val="1000"/>
               </a:spcAft>
             </a:pPr>
@@ -5190,7 +5207,7 @@
                 </a:solidFill>
                 <a:latin typeface="Arial"/>
               </a:rPr>
-              <a:t>•  ✓ A FROZEN model's benchmark score rose via a harness edit alone (telecom 0.50 → 0.75).</a:t>
+              <a:t>•  Single-trial trap: variance (±0.25) is as big as the effect — the same config scores 0.50 OR 0.75 by luck.</a:t>
             </a:r>
           </a:p>
           <a:p>
@@ -5206,7 +5223,7 @@
                 </a:solidFill>
                 <a:latin typeface="Arial"/>
               </a:rPr>
-              <a:t>•  ✓ The moat is the infrastructure — we diagnosed + evolved purely off typed processors + structured traces.</a:t>
+              <a:t>•  So you CANNOT rank components from one run. Attribution is statistical, not anecdotal.</a:t>
             </a:r>
           </a:p>
           <a:p>
@@ -5222,7 +5239,23 @@
                 </a:solidFill>
                 <a:latin typeface="Arial"/>
               </a:rPr>
-              <a:t>•  ✓ Lever mix is context-dependent — IRMA worked on telecom, did nothing on retail (grading mismatch).</a:t>
+              <a:t>•  Fix: multiple trials (pass^k) + task-level check + leave-one-out to kill inert processors.</a:t>
+            </a:r>
+          </a:p>
+          <a:p>
+            <a:pPr algn="l">
+              <a:spcAft>
+                <a:spcPts val="600"/>
+              </a:spcAft>
+            </a:pPr>
+            <a:r>
+              <a:rPr sz="2000" b="1" i="0">
+                <a:solidFill>
+                  <a:srgbClr val="141824"/>
+                </a:solidFill>
+                <a:latin typeface="Arial"/>
+              </a:rPr>
+              <a:t>Task-level signal: IRMA's roaming alert rescues the roaming task; control processors are inert here.</a:t>
             </a:r>
           </a:p>
           <a:p>
@@ -5238,23 +5271,7 @@
                 </a:solidFill>
                 <a:latin typeface="Arial"/>
               </a:rPr>
-              <a:t>•  ✓ Ceiling/floor effects — 32B at ceiling on easy tasks; strict retail grading = effective floor.</a:t>
-            </a:r>
-          </a:p>
-          <a:p>
-            <a:pPr algn="l">
-              <a:spcAft>
-                <a:spcPts val="600"/>
-              </a:spcAft>
-            </a:pPr>
-            <a:r>
-              <a:rPr sz="2000" b="1" i="0">
-                <a:solidFill>
-                  <a:srgbClr val="141824"/>
-                </a:solidFill>
-                <a:latin typeface="Arial"/>
-              </a:rPr>
-              <a:t>Not reproduced (needs scale): +14.5% magnitudes, multi-round + the 3 RL pathologies, AEGIS, co-evolution.</a:t>
+              <a:t>•  Reproducible in one command:  bash workshop/ablate.sh</a:t>
             </a:r>
           </a:p>
         </p:txBody>
@@ -5268,6 +5285,174 @@
 </file>
 
 <file path=ppt/slides/slide22.xml><?xml version="1.0" encoding="utf-8"?>
+<p:sld xmlns:a="http://schemas.openxmlformats.org/drawingml/2006/main" xmlns:p="http://schemas.openxmlformats.org/presentationml/2006/main" xmlns:r="http://schemas.openxmlformats.org/officeDocument/2006/relationships">
+  <p:cSld>
+    <p:bg>
+      <p:bgPr>
+        <a:solidFill>
+          <a:srgbClr val="F7F7FB"/>
+        </a:solidFill>
+        <a:effectLst/>
+      </p:bgPr>
+    </p:bg>
+    <p:spTree>
+      <p:nvGrpSpPr>
+        <p:cNvPr id="1" name=""/>
+        <p:cNvGrpSpPr/>
+        <p:nvPr/>
+      </p:nvGrpSpPr>
+      <p:grpSpPr/>
+      <p:sp>
+        <p:nvSpPr>
+          <p:cNvPr id="2" name="TextBox 1"/>
+          <p:cNvSpPr txBox="1"/>
+          <p:nvPr/>
+        </p:nvSpPr>
+        <p:spPr>
+          <a:xfrm>
+            <a:off x="822960" y="640080"/>
+            <a:ext cx="10515600" cy="1188720"/>
+          </a:xfrm>
+          <a:prstGeom prst="rect">
+            <a:avLst/>
+          </a:prstGeom>
+          <a:noFill/>
+        </p:spPr>
+        <p:txBody>
+          <a:bodyPr wrap="square">
+            <a:spAutoFit/>
+          </a:bodyPr>
+          <a:lstStyle/>
+          <a:p>
+            <a:pPr algn="l">
+              <a:spcAft>
+                <a:spcPts val="800"/>
+              </a:spcAft>
+            </a:pPr>
+            <a:r>
+              <a:rPr sz="3400" b="1" i="0">
+                <a:solidFill>
+                  <a:srgbClr val="141824"/>
+                </a:solidFill>
+                <a:latin typeface="Arial"/>
+              </a:rPr>
+              <a:t>Did we prove the paper? (partly — yes)</a:t>
+            </a:r>
+          </a:p>
+        </p:txBody>
+      </p:sp>
+      <p:sp>
+        <p:nvSpPr>
+          <p:cNvPr id="3" name="TextBox 2"/>
+          <p:cNvSpPr txBox="1"/>
+          <p:nvPr/>
+        </p:nvSpPr>
+        <p:spPr>
+          <a:xfrm>
+            <a:off x="868680" y="2148840"/>
+            <a:ext cx="10424160" cy="4297680"/>
+          </a:xfrm>
+          <a:prstGeom prst="rect">
+            <a:avLst/>
+          </a:prstGeom>
+          <a:noFill/>
+        </p:spPr>
+        <p:txBody>
+          <a:bodyPr wrap="square">
+            <a:spAutoFit/>
+          </a:bodyPr>
+          <a:lstStyle/>
+          <a:p>
+            <a:pPr algn="l">
+              <a:spcAft>
+                <a:spcPts val="1000"/>
+              </a:spcAft>
+            </a:pPr>
+            <a:r>
+              <a:rPr sz="1800" b="0" i="0">
+                <a:solidFill>
+                  <a:srgbClr val="141824"/>
+                </a:solidFill>
+                <a:latin typeface="Arial"/>
+              </a:rPr>
+              <a:t>•  ✓ A FROZEN model's benchmark score rose via a harness edit alone (telecom 0.50 → 0.75).</a:t>
+            </a:r>
+          </a:p>
+          <a:p>
+            <a:pPr algn="l">
+              <a:spcAft>
+                <a:spcPts val="1000"/>
+              </a:spcAft>
+            </a:pPr>
+            <a:r>
+              <a:rPr sz="1800" b="0" i="0">
+                <a:solidFill>
+                  <a:srgbClr val="141824"/>
+                </a:solidFill>
+                <a:latin typeface="Arial"/>
+              </a:rPr>
+              <a:t>•  ✓ The moat is the infrastructure — we diagnosed + evolved purely off typed processors + structured traces.</a:t>
+            </a:r>
+          </a:p>
+          <a:p>
+            <a:pPr algn="l">
+              <a:spcAft>
+                <a:spcPts val="1000"/>
+              </a:spcAft>
+            </a:pPr>
+            <a:r>
+              <a:rPr sz="1800" b="0" i="0">
+                <a:solidFill>
+                  <a:srgbClr val="141824"/>
+                </a:solidFill>
+                <a:latin typeface="Arial"/>
+              </a:rPr>
+              <a:t>•  ✓ Lever mix is context-dependent — IRMA worked on telecom, did nothing on retail (grading mismatch).</a:t>
+            </a:r>
+          </a:p>
+          <a:p>
+            <a:pPr algn="l">
+              <a:spcAft>
+                <a:spcPts val="1000"/>
+              </a:spcAft>
+            </a:pPr>
+            <a:r>
+              <a:rPr sz="1800" b="0" i="0">
+                <a:solidFill>
+                  <a:srgbClr val="141824"/>
+                </a:solidFill>
+                <a:latin typeface="Arial"/>
+              </a:rPr>
+              <a:t>•  ✓ Ceiling/floor effects — 32B at ceiling on easy tasks; strict retail grading = effective floor.</a:t>
+            </a:r>
+          </a:p>
+          <a:p>
+            <a:pPr algn="l">
+              <a:spcAft>
+                <a:spcPts val="600"/>
+              </a:spcAft>
+            </a:pPr>
+            <a:r>
+              <a:rPr sz="2000" b="1" i="0">
+                <a:solidFill>
+                  <a:srgbClr val="141824"/>
+                </a:solidFill>
+                <a:latin typeface="Arial"/>
+              </a:rPr>
+              <a:t>Not reproduced (needs scale): +14.5% magnitudes, multi-round + the 3 RL pathologies, AEGIS, co-evolution.</a:t>
+            </a:r>
+          </a:p>
+        </p:txBody>
+      </p:sp>
+    </p:spTree>
+  </p:cSld>
+  <p:clrMapOvr>
+    <a:masterClrMapping/>
+  </p:clrMapOvr>
+</p:sld>
+</file>
+
+<file path=ppt/slides/slide23.xml><?xml version="1.0" encoding="utf-8"?>
 <p:sld xmlns:a="http://schemas.openxmlformats.org/drawingml/2006/main" xmlns:p="http://schemas.openxmlformats.org/presentationml/2006/main" xmlns:r="http://schemas.openxmlformats.org/officeDocument/2006/relationships">
   <p:cSld>
     <p:bg>

</xml_diff>

<commit_message>
workshop: multi-trial attribution — IRMA +0.167, control procs inert (-0.083)
3-trial ablation clears the single-trial noise: PolicyHint (IRMA) drives the
telecom lift; the 5 control processors contribute nothing (leave-one-out would
drop them). Adds make_attribution_chart.py (reads the ablation runs) + deck slide.

Co-Authored-By: Claude Opus 4.8 (1M context) <noreply@anthropic.com>
</commit_message>
<xml_diff>
--- a/workshop/harness-evolution-workshop.pptx
+++ b/workshop/harness-evolution-workshop.pptx
@@ -28,6 +28,7 @@
     <p:sldId id="276" r:id="rId27"/>
     <p:sldId id="277" r:id="rId28"/>
     <p:sldId id="278" r:id="rId29"/>
+    <p:sldId id="279" r:id="rId30"/>
   </p:sldIdLst>
   <p:sldSz cx="12191695" cy="6858000" type="screen4x3"/>
   <p:notesSz cx="6858000" cy="9144000"/>
@@ -5310,8 +5311,8 @@
         </p:nvSpPr>
         <p:spPr>
           <a:xfrm>
-            <a:off x="822960" y="640080"/>
-            <a:ext cx="10515600" cy="1188720"/>
+            <a:off x="822960" y="502920"/>
+            <a:ext cx="10515600" cy="914400"/>
           </a:xfrm>
           <a:prstGeom prst="rect">
             <a:avLst/>
@@ -5330,27 +5331,51 @@
               </a:spcAft>
             </a:pPr>
             <a:r>
-              <a:rPr sz="3400" b="1" i="0">
-                <a:solidFill>
-                  <a:srgbClr val="141824"/>
-                </a:solidFill>
-                <a:latin typeface="Arial"/>
-              </a:rPr>
-              <a:t>Did we prove the paper? (partly — yes)</a:t>
-            </a:r>
-          </a:p>
-        </p:txBody>
-      </p:sp>
-      <p:sp>
-        <p:nvSpPr>
-          <p:cNvPr id="3" name="TextBox 2"/>
+              <a:rPr sz="3000" b="1" i="0">
+                <a:solidFill>
+                  <a:srgbClr val="141824"/>
+                </a:solidFill>
+                <a:latin typeface="Arial"/>
+              </a:rPr>
+              <a:t>Attribution (3 trials): one component did the work</a:t>
+            </a:r>
+          </a:p>
+        </p:txBody>
+      </p:sp>
+      <p:pic>
+        <p:nvPicPr>
+          <p:cNvPr id="3" name="Picture 2" descr="attribution-chart.png"/>
+          <p:cNvPicPr>
+            <a:picLocks noChangeAspect="1"/>
+          </p:cNvPicPr>
+          <p:nvPr/>
+        </p:nvPicPr>
+        <p:blipFill>
+          <a:blip r:embed="rId2"/>
+          <a:stretch>
+            <a:fillRect/>
+          </a:stretch>
+        </p:blipFill>
+        <p:spPr>
+          <a:xfrm>
+            <a:off x="1249527" y="1737360"/>
+            <a:ext cx="9692640" cy="3264889"/>
+          </a:xfrm>
+          <a:prstGeom prst="rect">
+            <a:avLst/>
+          </a:prstGeom>
+        </p:spPr>
+      </p:pic>
+      <p:sp>
+        <p:nvSpPr>
+          <p:cNvPr id="4" name="TextBox 3"/>
           <p:cNvSpPr txBox="1"/>
           <p:nvPr/>
         </p:nvSpPr>
         <p:spPr>
           <a:xfrm>
-            <a:off x="868680" y="2148840"/>
-            <a:ext cx="10424160" cy="4297680"/>
+            <a:off x="822960" y="6126480"/>
+            <a:ext cx="10515600" cy="548640"/>
           </a:xfrm>
           <a:prstGeom prst="rect">
             <a:avLst/>
@@ -5363,83 +5388,19 @@
           </a:bodyPr>
           <a:lstStyle/>
           <a:p>
-            <a:pPr algn="l">
-              <a:spcAft>
-                <a:spcPts val="1000"/>
-              </a:spcAft>
-            </a:pPr>
-            <a:r>
-              <a:rPr sz="1800" b="0" i="0">
-                <a:solidFill>
-                  <a:srgbClr val="141824"/>
-                </a:solidFill>
-                <a:latin typeface="Arial"/>
-              </a:rPr>
-              <a:t>•  ✓ A FROZEN model's benchmark score rose via a harness edit alone (telecom 0.50 → 0.75).</a:t>
-            </a:r>
-          </a:p>
-          <a:p>
-            <a:pPr algn="l">
-              <a:spcAft>
-                <a:spcPts val="1000"/>
-              </a:spcAft>
-            </a:pPr>
-            <a:r>
-              <a:rPr sz="1800" b="0" i="0">
-                <a:solidFill>
-                  <a:srgbClr val="141824"/>
-                </a:solidFill>
-                <a:latin typeface="Arial"/>
-              </a:rPr>
-              <a:t>•  ✓ The moat is the infrastructure — we diagnosed + evolved purely off typed processors + structured traces.</a:t>
-            </a:r>
-          </a:p>
-          <a:p>
-            <a:pPr algn="l">
-              <a:spcAft>
-                <a:spcPts val="1000"/>
-              </a:spcAft>
-            </a:pPr>
-            <a:r>
-              <a:rPr sz="1800" b="0" i="0">
-                <a:solidFill>
-                  <a:srgbClr val="141824"/>
-                </a:solidFill>
-                <a:latin typeface="Arial"/>
-              </a:rPr>
-              <a:t>•  ✓ Lever mix is context-dependent — IRMA worked on telecom, did nothing on retail (grading mismatch).</a:t>
-            </a:r>
-          </a:p>
-          <a:p>
-            <a:pPr algn="l">
-              <a:spcAft>
-                <a:spcPts val="1000"/>
-              </a:spcAft>
-            </a:pPr>
-            <a:r>
-              <a:rPr sz="1800" b="0" i="0">
-                <a:solidFill>
-                  <a:srgbClr val="141824"/>
-                </a:solidFill>
-                <a:latin typeface="Arial"/>
-              </a:rPr>
-              <a:t>•  ✓ Ceiling/floor effects — 32B at ceiling on easy tasks; strict retail grading = effective floor.</a:t>
-            </a:r>
-          </a:p>
-          <a:p>
-            <a:pPr algn="l">
-              <a:spcAft>
-                <a:spcPts val="600"/>
-              </a:spcAft>
-            </a:pPr>
-            <a:r>
-              <a:rPr sz="2000" b="1" i="0">
-                <a:solidFill>
-                  <a:srgbClr val="141824"/>
-                </a:solidFill>
-                <a:latin typeface="Arial"/>
-              </a:rPr>
-              <a:t>Not reproduced (needs scale): +14.5% magnitudes, multi-round + the 3 RL pathologies, AEGIS, co-evolution.</a:t>
+            <a:pPr algn="ctr">
+              <a:spcAft>
+                <a:spcPts val="800"/>
+              </a:spcAft>
+            </a:pPr>
+            <a:r>
+              <a:rPr sz="1300" b="0" i="0">
+                <a:solidFill>
+                  <a:srgbClr val="666C7A"/>
+                </a:solidFill>
+                <a:latin typeface="Arial"/>
+              </a:rPr>
+              <a:t>Multi-trial averaging clears the noise: IRMA (+0.167) drives the lift; the 5 control processors are inert (−0.083). Leave-one-out would drop them.</a:t>
             </a:r>
           </a:p>
         </p:txBody>
@@ -5453,6 +5414,174 @@
 </file>
 
 <file path=ppt/slides/slide23.xml><?xml version="1.0" encoding="utf-8"?>
+<p:sld xmlns:a="http://schemas.openxmlformats.org/drawingml/2006/main" xmlns:p="http://schemas.openxmlformats.org/presentationml/2006/main" xmlns:r="http://schemas.openxmlformats.org/officeDocument/2006/relationships">
+  <p:cSld>
+    <p:bg>
+      <p:bgPr>
+        <a:solidFill>
+          <a:srgbClr val="F7F7FB"/>
+        </a:solidFill>
+        <a:effectLst/>
+      </p:bgPr>
+    </p:bg>
+    <p:spTree>
+      <p:nvGrpSpPr>
+        <p:cNvPr id="1" name=""/>
+        <p:cNvGrpSpPr/>
+        <p:nvPr/>
+      </p:nvGrpSpPr>
+      <p:grpSpPr/>
+      <p:sp>
+        <p:nvSpPr>
+          <p:cNvPr id="2" name="TextBox 1"/>
+          <p:cNvSpPr txBox="1"/>
+          <p:nvPr/>
+        </p:nvSpPr>
+        <p:spPr>
+          <a:xfrm>
+            <a:off x="822960" y="640080"/>
+            <a:ext cx="10515600" cy="1188720"/>
+          </a:xfrm>
+          <a:prstGeom prst="rect">
+            <a:avLst/>
+          </a:prstGeom>
+          <a:noFill/>
+        </p:spPr>
+        <p:txBody>
+          <a:bodyPr wrap="square">
+            <a:spAutoFit/>
+          </a:bodyPr>
+          <a:lstStyle/>
+          <a:p>
+            <a:pPr algn="l">
+              <a:spcAft>
+                <a:spcPts val="800"/>
+              </a:spcAft>
+            </a:pPr>
+            <a:r>
+              <a:rPr sz="3400" b="1" i="0">
+                <a:solidFill>
+                  <a:srgbClr val="141824"/>
+                </a:solidFill>
+                <a:latin typeface="Arial"/>
+              </a:rPr>
+              <a:t>Did we prove the paper? (partly — yes)</a:t>
+            </a:r>
+          </a:p>
+        </p:txBody>
+      </p:sp>
+      <p:sp>
+        <p:nvSpPr>
+          <p:cNvPr id="3" name="TextBox 2"/>
+          <p:cNvSpPr txBox="1"/>
+          <p:nvPr/>
+        </p:nvSpPr>
+        <p:spPr>
+          <a:xfrm>
+            <a:off x="868680" y="2148840"/>
+            <a:ext cx="10424160" cy="4297680"/>
+          </a:xfrm>
+          <a:prstGeom prst="rect">
+            <a:avLst/>
+          </a:prstGeom>
+          <a:noFill/>
+        </p:spPr>
+        <p:txBody>
+          <a:bodyPr wrap="square">
+            <a:spAutoFit/>
+          </a:bodyPr>
+          <a:lstStyle/>
+          <a:p>
+            <a:pPr algn="l">
+              <a:spcAft>
+                <a:spcPts val="1000"/>
+              </a:spcAft>
+            </a:pPr>
+            <a:r>
+              <a:rPr sz="1800" b="0" i="0">
+                <a:solidFill>
+                  <a:srgbClr val="141824"/>
+                </a:solidFill>
+                <a:latin typeface="Arial"/>
+              </a:rPr>
+              <a:t>•  ✓ A FROZEN model's benchmark score rose via a harness edit alone (telecom 0.50 → 0.75).</a:t>
+            </a:r>
+          </a:p>
+          <a:p>
+            <a:pPr algn="l">
+              <a:spcAft>
+                <a:spcPts val="1000"/>
+              </a:spcAft>
+            </a:pPr>
+            <a:r>
+              <a:rPr sz="1800" b="0" i="0">
+                <a:solidFill>
+                  <a:srgbClr val="141824"/>
+                </a:solidFill>
+                <a:latin typeface="Arial"/>
+              </a:rPr>
+              <a:t>•  ✓ The moat is the infrastructure — we diagnosed + evolved purely off typed processors + structured traces.</a:t>
+            </a:r>
+          </a:p>
+          <a:p>
+            <a:pPr algn="l">
+              <a:spcAft>
+                <a:spcPts val="1000"/>
+              </a:spcAft>
+            </a:pPr>
+            <a:r>
+              <a:rPr sz="1800" b="0" i="0">
+                <a:solidFill>
+                  <a:srgbClr val="141824"/>
+                </a:solidFill>
+                <a:latin typeface="Arial"/>
+              </a:rPr>
+              <a:t>•  ✓ Lever mix is context-dependent — IRMA worked on telecom, did nothing on retail (grading mismatch).</a:t>
+            </a:r>
+          </a:p>
+          <a:p>
+            <a:pPr algn="l">
+              <a:spcAft>
+                <a:spcPts val="1000"/>
+              </a:spcAft>
+            </a:pPr>
+            <a:r>
+              <a:rPr sz="1800" b="0" i="0">
+                <a:solidFill>
+                  <a:srgbClr val="141824"/>
+                </a:solidFill>
+                <a:latin typeface="Arial"/>
+              </a:rPr>
+              <a:t>•  ✓ Ceiling/floor effects — 32B at ceiling on easy tasks; strict retail grading = effective floor.</a:t>
+            </a:r>
+          </a:p>
+          <a:p>
+            <a:pPr algn="l">
+              <a:spcAft>
+                <a:spcPts val="600"/>
+              </a:spcAft>
+            </a:pPr>
+            <a:r>
+              <a:rPr sz="2000" b="1" i="0">
+                <a:solidFill>
+                  <a:srgbClr val="141824"/>
+                </a:solidFill>
+                <a:latin typeface="Arial"/>
+              </a:rPr>
+              <a:t>Not reproduced (needs scale): +14.5% magnitudes, multi-round + the 3 RL pathologies, AEGIS, co-evolution.</a:t>
+            </a:r>
+          </a:p>
+        </p:txBody>
+      </p:sp>
+    </p:spTree>
+  </p:cSld>
+  <p:clrMapOvr>
+    <a:masterClrMapping/>
+  </p:clrMapOvr>
+</p:sld>
+</file>
+
+<file path=ppt/slides/slide24.xml><?xml version="1.0" encoding="utf-8"?>
 <p:sld xmlns:a="http://schemas.openxmlformats.org/drawingml/2006/main" xmlns:p="http://schemas.openxmlformats.org/presentationml/2006/main" xmlns:r="http://schemas.openxmlformats.org/officeDocument/2006/relationships">
   <p:cSld>
     <p:bg>

</xml_diff>

<commit_message>
workshop: reasoning-lever result — GSM8K 0.65 -> 0.97 (frozen 8B)
Reflect scaffold (visible re-derive + self-check) lifts GSM8K 0.65->0.975 and
CRT 0.53->0.73, same frozen model. First reflect run scored 0.45 due to a
token-truncation plumbing bug (16 unparseable) — fixed to visible reasoning.
Adds reasoning chart + deck slides (crutch-vs-capability + the GSM8K lift).

Co-Authored-By: Claude Opus 4.8 (1M context) <noreply@anthropic.com>
</commit_message>
<xml_diff>
--- a/workshop/harness-evolution-workshop.pptx
+++ b/workshop/harness-evolution-workshop.pptx
@@ -29,6 +29,8 @@
     <p:sldId id="277" r:id="rId28"/>
     <p:sldId id="278" r:id="rId29"/>
     <p:sldId id="279" r:id="rId30"/>
+    <p:sldId id="280" r:id="rId31"/>
+    <p:sldId id="281" r:id="rId32"/>
   </p:sldIdLst>
   <p:sldSz cx="12191695" cy="6858000" type="screen4x3"/>
   <p:notesSz cx="6858000" cy="9144000"/>
@@ -5582,6 +5584,302 @@
 </file>
 
 <file path=ppt/slides/slide24.xml><?xml version="1.0" encoding="utf-8"?>
+<p:sld xmlns:a="http://schemas.openxmlformats.org/drawingml/2006/main" xmlns:p="http://schemas.openxmlformats.org/presentationml/2006/main" xmlns:r="http://schemas.openxmlformats.org/officeDocument/2006/relationships">
+  <p:cSld>
+    <p:bg>
+      <p:bgPr>
+        <a:solidFill>
+          <a:srgbClr val="F7F7FB"/>
+        </a:solidFill>
+        <a:effectLst/>
+      </p:bgPr>
+    </p:bg>
+    <p:spTree>
+      <p:nvGrpSpPr>
+        <p:cNvPr id="1" name=""/>
+        <p:cNvGrpSpPr/>
+        <p:nvPr/>
+      </p:nvGrpSpPr>
+      <p:grpSpPr/>
+      <p:sp>
+        <p:nvSpPr>
+          <p:cNvPr id="2" name="TextBox 1"/>
+          <p:cNvSpPr txBox="1"/>
+          <p:nvPr/>
+        </p:nvSpPr>
+        <p:spPr>
+          <a:xfrm>
+            <a:off x="822960" y="640080"/>
+            <a:ext cx="10515600" cy="1188720"/>
+          </a:xfrm>
+          <a:prstGeom prst="rect">
+            <a:avLst/>
+          </a:prstGeom>
+          <a:noFill/>
+        </p:spPr>
+        <p:txBody>
+          <a:bodyPr wrap="square">
+            <a:spAutoFit/>
+          </a:bodyPr>
+          <a:lstStyle/>
+          <a:p>
+            <a:pPr algn="l">
+              <a:spcAft>
+                <a:spcPts val="800"/>
+              </a:spcAft>
+            </a:pPr>
+            <a:r>
+              <a:rPr sz="3400" b="1" i="0">
+                <a:solidFill>
+                  <a:srgbClr val="141824"/>
+                </a:solidFill>
+                <a:latin typeface="Arial"/>
+              </a:rPr>
+              <a:t>Crutch or capability? Two value props</a:t>
+            </a:r>
+          </a:p>
+        </p:txBody>
+      </p:sp>
+      <p:sp>
+        <p:nvSpPr>
+          <p:cNvPr id="3" name="TextBox 2"/>
+          <p:cNvSpPr txBox="1"/>
+          <p:nvPr/>
+        </p:nvSpPr>
+        <p:spPr>
+          <a:xfrm>
+            <a:off x="868680" y="2148840"/>
+            <a:ext cx="10424160" cy="4297680"/>
+          </a:xfrm>
+          <a:prstGeom prst="rect">
+            <a:avLst/>
+          </a:prstGeom>
+          <a:noFill/>
+        </p:spPr>
+        <p:txBody>
+          <a:bodyPr wrap="square">
+            <a:spAutoFit/>
+          </a:bodyPr>
+          <a:lstStyle/>
+          <a:p>
+            <a:pPr algn="l">
+              <a:spcAft>
+                <a:spcPts val="1000"/>
+              </a:spcAft>
+            </a:pPr>
+            <a:r>
+              <a:rPr sz="1800" b="0" i="0">
+                <a:solidFill>
+                  <a:srgbClr val="141824"/>
+                </a:solidFill>
+                <a:latin typeface="Arial"/>
+              </a:rPr>
+              <a:t>•  Deterministic Control fixes (roaming alert, ParseRetry) are a CRUTCH — they recover latent</a:t>
+            </a:r>
+          </a:p>
+          <a:p>
+            <a:pPr algn="l">
+              <a:spcAft>
+                <a:spcPts val="1000"/>
+              </a:spcAft>
+            </a:pPr>
+            <a:r>
+              <a:rPr sz="1800" b="0" i="0">
+                <a:solidFill>
+                  <a:srgbClr val="141824"/>
+                </a:solidFill>
+                <a:latin typeface="Arial"/>
+              </a:rPr>
+              <a:t>•  capability a frozen model failed to apply. Real, but capped at the model's ceiling.</a:t>
+            </a:r>
+          </a:p>
+          <a:p>
+            <a:pPr algn="l">
+              <a:spcAft>
+                <a:spcPts val="600"/>
+              </a:spcAft>
+            </a:pPr>
+            <a:r>
+              <a:rPr sz="2000" b="1" i="0">
+                <a:solidFill>
+                  <a:srgbClr val="141824"/>
+                </a:solidFill>
+                <a:latin typeface="Arial"/>
+              </a:rPr>
+              <a:t>Instruction (reasoning scaffolds) + Action (tools/skills) ADD realized capability — not plumbing.</a:t>
+            </a:r>
+          </a:p>
+          <a:p>
+            <a:pPr algn="l">
+              <a:spcAft>
+                <a:spcPts val="1000"/>
+              </a:spcAft>
+            </a:pPr>
+            <a:r>
+              <a:rPr sz="1800" b="0" i="0">
+                <a:solidFill>
+                  <a:srgbClr val="141824"/>
+                </a:solidFill>
+                <a:latin typeface="Arial"/>
+              </a:rPr>
+              <a:t>•  To raise the ceiling itself, you need loop 2: RL on the weights (co-evolution). Different game.</a:t>
+            </a:r>
+          </a:p>
+          <a:p>
+            <a:pPr algn="l">
+              <a:spcAft>
+                <a:spcPts val="600"/>
+              </a:spcAft>
+            </a:pPr>
+            <a:r>
+              <a:rPr sz="2000" b="1" i="0">
+                <a:solidFill>
+                  <a:srgbClr val="141824"/>
+                </a:solidFill>
+                <a:latin typeface="Arial"/>
+              </a:rPr>
+              <a:t>On a frozen model, the most capability-like levers are reasoning scaffolds + new tools.</a:t>
+            </a:r>
+          </a:p>
+        </p:txBody>
+      </p:sp>
+    </p:spTree>
+  </p:cSld>
+  <p:clrMapOvr>
+    <a:masterClrMapping/>
+  </p:clrMapOvr>
+</p:sld>
+</file>
+
+<file path=ppt/slides/slide25.xml><?xml version="1.0" encoding="utf-8"?>
+<p:sld xmlns:a="http://schemas.openxmlformats.org/drawingml/2006/main" xmlns:p="http://schemas.openxmlformats.org/presentationml/2006/main" xmlns:r="http://schemas.openxmlformats.org/officeDocument/2006/relationships">
+  <p:cSld>
+    <p:bg>
+      <p:bgPr>
+        <a:solidFill>
+          <a:srgbClr val="F7F7FB"/>
+        </a:solidFill>
+        <a:effectLst/>
+      </p:bgPr>
+    </p:bg>
+    <p:spTree>
+      <p:nvGrpSpPr>
+        <p:cNvPr id="1" name=""/>
+        <p:cNvGrpSpPr/>
+        <p:nvPr/>
+      </p:nvGrpSpPr>
+      <p:grpSpPr/>
+      <p:sp>
+        <p:nvSpPr>
+          <p:cNvPr id="2" name="TextBox 1"/>
+          <p:cNvSpPr txBox="1"/>
+          <p:nvPr/>
+        </p:nvSpPr>
+        <p:spPr>
+          <a:xfrm>
+            <a:off x="822960" y="502920"/>
+            <a:ext cx="10515600" cy="914400"/>
+          </a:xfrm>
+          <a:prstGeom prst="rect">
+            <a:avLst/>
+          </a:prstGeom>
+          <a:noFill/>
+        </p:spPr>
+        <p:txBody>
+          <a:bodyPr wrap="square">
+            <a:spAutoFit/>
+          </a:bodyPr>
+          <a:lstStyle/>
+          <a:p>
+            <a:pPr algn="l">
+              <a:spcAft>
+                <a:spcPts val="800"/>
+              </a:spcAft>
+            </a:pPr>
+            <a:r>
+              <a:rPr sz="3000" b="1" i="0">
+                <a:solidFill>
+                  <a:srgbClr val="141824"/>
+                </a:solidFill>
+                <a:latin typeface="Arial"/>
+              </a:rPr>
+              <a:t>The harness elicits latent reasoning (GSM8K)</a:t>
+            </a:r>
+          </a:p>
+        </p:txBody>
+      </p:sp>
+      <p:pic>
+        <p:nvPicPr>
+          <p:cNvPr id="3" name="Picture 2" descr="reasoning-chart.png"/>
+          <p:cNvPicPr>
+            <a:picLocks noChangeAspect="1"/>
+          </p:cNvPicPr>
+          <p:nvPr/>
+        </p:nvPicPr>
+        <p:blipFill>
+          <a:blip r:embed="rId2"/>
+          <a:stretch>
+            <a:fillRect/>
+          </a:stretch>
+        </p:blipFill>
+        <p:spPr>
+          <a:xfrm>
+            <a:off x="1249527" y="1737360"/>
+            <a:ext cx="9692640" cy="3060833"/>
+          </a:xfrm>
+          <a:prstGeom prst="rect">
+            <a:avLst/>
+          </a:prstGeom>
+        </p:spPr>
+      </p:pic>
+      <p:sp>
+        <p:nvSpPr>
+          <p:cNvPr id="4" name="TextBox 3"/>
+          <p:cNvSpPr txBox="1"/>
+          <p:nvPr/>
+        </p:nvSpPr>
+        <p:spPr>
+          <a:xfrm>
+            <a:off x="822960" y="6126480"/>
+            <a:ext cx="10515600" cy="548640"/>
+          </a:xfrm>
+          <a:prstGeom prst="rect">
+            <a:avLst/>
+          </a:prstGeom>
+          <a:noFill/>
+        </p:spPr>
+        <p:txBody>
+          <a:bodyPr wrap="square">
+            <a:spAutoFit/>
+          </a:bodyPr>
+          <a:lstStyle/>
+          <a:p>
+            <a:pPr algn="ctr">
+              <a:spcAft>
+                <a:spcPts val="800"/>
+              </a:spcAft>
+            </a:pPr>
+            <a:r>
+              <a:rPr sz="1300" b="0" i="0">
+                <a:solidFill>
+                  <a:srgbClr val="666C7A"/>
+                </a:solidFill>
+                <a:latin typeface="Arial"/>
+              </a:rPr>
+              <a:t>Same frozen qwen3:8B. A reflect scaffold (re-derive + self-check) lifts GSM8K 0.65 → 0.97 and CRT 0.53 → 0.73. Realized reasoning, not I/O.</a:t>
+            </a:r>
+          </a:p>
+        </p:txBody>
+      </p:sp>
+    </p:spTree>
+  </p:cSld>
+  <p:clrMapOvr>
+    <a:masterClrMapping/>
+  </p:clrMapOvr>
+</p:sld>
+</file>
+
+<file path=ppt/slides/slide26.xml><?xml version="1.0" encoding="utf-8"?>
 <p:sld xmlns:a="http://schemas.openxmlformats.org/drawingml/2006/main" xmlns:p="http://schemas.openxmlformats.org/presentationml/2006/main" xmlns:r="http://schemas.openxmlformats.org/officeDocument/2006/relationships">
   <p:cSld>
     <p:bg>

</xml_diff>

<commit_message>
workshop: Action-lever demo — private KB retrieval (can't -> can), 0.00 -> 1.00
Add action_demo/ (knowledge_base.json + questions.json + kb_agent.py): a frozen
model CANNOT know a private company's data (vanilla 0/12, all hallucinated); with
a kb_search tool it gets 12/12. Genuine capability addition, inherently vertical.
Add calculator tool + cot/action configs to reasoning_harness (finding: 8B does
4-digit arithmetic by hand at 100%, so a calc tool is redundant — knowledge, not
arithmetic, is the real can't). levers_spectrum_chart.py: Action(add)/Instruction
(reshape)/Control(crutch) on one axis. Deck + benchmark-design theme slide.

Co-Authored-By: Claude Opus 4.8 (1M context) <noreply@anthropic.com>
</commit_message>
<xml_diff>
--- a/workshop/harness-evolution-workshop.pptx
+++ b/workshop/harness-evolution-workshop.pptx
@@ -31,6 +31,9 @@
     <p:sldId id="279" r:id="rId30"/>
     <p:sldId id="280" r:id="rId31"/>
     <p:sldId id="281" r:id="rId32"/>
+    <p:sldId id="282" r:id="rId33"/>
+    <p:sldId id="283" r:id="rId34"/>
+    <p:sldId id="284" r:id="rId35"/>
   </p:sldIdLst>
   <p:sldSz cx="12191695" cy="6858000" type="screen4x3"/>
   <p:notesSz cx="6858000" cy="9144000"/>
@@ -4099,7 +4102,7 @@
                 </a:solidFill>
                 <a:latin typeface="Arial"/>
               </a:rPr>
-              <a:t>An honest note on reproducing the *number*</a:t>
+              <a:t>Designing the vertical benchmark is HALF the work</a:t>
             </a:r>
           </a:p>
         </p:txBody>
@@ -4138,7 +4141,7 @@
                 </a:solidFill>
                 <a:latin typeface="Arial"/>
               </a:rPr>
-              <a:t>The METHOD reproduces on a laptop: diagnose trace → pick lever → author component → measure.</a:t>
+              <a:t>The benchmark IS the reward function for agentic RL. No signal → no evolution.</a:t>
             </a:r>
           </a:p>
           <a:p>
@@ -4154,7 +4157,7 @@
                 </a:solidFill>
                 <a:latin typeface="Arial"/>
               </a:rPr>
-              <a:t>•  The benchmark + grading choice matters: pick a domain where the model has a non-zero baseline.</a:t>
+              <a:t>•  A benchmark you can evolve against needs:</a:t>
             </a:r>
           </a:p>
           <a:p>
@@ -4170,7 +4173,7 @@
                 </a:solidFill>
                 <a:latin typeface="Arial"/>
               </a:rPr>
-              <a:t>•  Small samples are noisy — one task hit an infra timeout; the paper uses 100+ tasks, pass^k, trials.</a:t>
+              <a:t>•    · a non-zero baseline (model not floored)   · room (not at ceiling)</a:t>
             </a:r>
           </a:p>
           <a:p>
@@ -4186,7 +4189,39 @@
                 </a:solidFill>
                 <a:latin typeface="Arial"/>
               </a:rPr>
-              <a:t>•  Reference at scale (27B retail): 0.807 → 0.965. Our local telecom: 0.50 → 0.75.</a:t>
+              <a:t>•    · a failure mode that matches a lever   · grading that gives a gradient (partial credit / enough tasks)</a:t>
+            </a:r>
+          </a:p>
+          <a:p>
+            <a:pPr algn="l">
+              <a:spcAft>
+                <a:spcPts val="1000"/>
+              </a:spcAft>
+            </a:pPr>
+            <a:r>
+              <a:rPr sz="1800" b="0" i="0">
+                <a:solidFill>
+                  <a:srgbClr val="141824"/>
+                </a:solidFill>
+                <a:latin typeface="Arial"/>
+              </a:rPr>
+              <a:t>•  Retail (strict DB) → 0.00 dead end.  Telecom (lenient) → moves.  GSM8K → clean gradient.</a:t>
+            </a:r>
+          </a:p>
+          <a:p>
+            <a:pPr algn="l">
+              <a:spcAft>
+                <a:spcPts val="600"/>
+              </a:spcAft>
+            </a:pPr>
+            <a:r>
+              <a:rPr sz="2000" b="1" i="0">
+                <a:solidFill>
+                  <a:srgbClr val="141824"/>
+                </a:solidFill>
+                <a:latin typeface="Arial"/>
+              </a:rPr>
+              <a:t>Vertical agents need vertical benchmarks — co-design the harness AND the benchmark together.</a:t>
             </a:r>
           </a:p>
         </p:txBody>
@@ -4251,7 +4286,7 @@
                 </a:solidFill>
                 <a:latin typeface="Arial"/>
               </a:rPr>
-              <a:t>How this workshop runs — you drive it</a:t>
+              <a:t>An honest note on reproducing the *number*</a:t>
             </a:r>
           </a:p>
         </p:txBody>
@@ -4290,7 +4325,7 @@
                 </a:solidFill>
                 <a:latin typeface="Arial"/>
               </a:rPr>
-              <a:t>Not slide-watching. You run the loop on your laptop.</a:t>
+              <a:t>The METHOD reproduces on a laptop: diagnose trace → pick lever → author component → measure.</a:t>
             </a:r>
           </a:p>
           <a:p>
@@ -4306,7 +4341,7 @@
                 </a:solidFill>
                 <a:latin typeface="Arial"/>
               </a:rPr>
-              <a:t>•  1. Run the vanilla baseline → watch a frozen model FAIL a real benchmark task.</a:t>
+              <a:t>•  The benchmark + grading choice matters: pick a domain where the model has a non-zero baseline.</a:t>
             </a:r>
           </a:p>
           <a:p>
@@ -4322,7 +4357,7 @@
                 </a:solidFill>
                 <a:latin typeface="Arial"/>
               </a:rPr>
-              <a:t>•  2. Read the trace frontmatter → feel it's a harness failure, not a reasoning one.</a:t>
+              <a:t>•  Small samples are noisy — one task hit an infra timeout; the paper uses 100+ tasks, pass^k, trials.</a:t>
             </a:r>
           </a:p>
           <a:p>
@@ -4338,39 +4373,7 @@
                 </a:solidFill>
                 <a:latin typeface="Arial"/>
               </a:rPr>
-              <a:t>•  3. Invoke the harness-evolver skill → YOUR Claude Code diagnoses + authors a fix.</a:t>
-            </a:r>
-          </a:p>
-          <a:p>
-            <a:pPr algn="l">
-              <a:spcAft>
-                <a:spcPts val="1000"/>
-              </a:spcAft>
-            </a:pPr>
-            <a:r>
-              <a:rPr sz="1800" b="0" i="0">
-                <a:solidFill>
-                  <a:srgbClr val="141824"/>
-                </a:solidFill>
-                <a:latin typeface="Arial"/>
-              </a:rPr>
-              <a:t>•  4. make eval → see the number move. Loop until it lifts.</a:t>
-            </a:r>
-          </a:p>
-          <a:p>
-            <a:pPr algn="l">
-              <a:spcAft>
-                <a:spcPts val="600"/>
-              </a:spcAft>
-            </a:pPr>
-            <a:r>
-              <a:rPr sz="2000" b="1" i="0">
-                <a:solidFill>
-                  <a:srgbClr val="141824"/>
-                </a:solidFill>
-                <a:latin typeface="Arial"/>
-              </a:rPr>
-              <a:t>A reference solution is shipped — but try your own lever first.</a:t>
+              <a:t>•  Reference at scale (27B retail): 0.807 → 0.965. Our local telecom: 0.50 → 0.75.</a:t>
             </a:r>
           </a:p>
         </p:txBody>
@@ -4435,7 +4438,7 @@
                 </a:solidFill>
                 <a:latin typeface="Arial"/>
               </a:rPr>
-              <a:t>The meta-agent is YOU (Claude Code)</a:t>
+              <a:t>How this workshop runs — you drive it</a:t>
             </a:r>
           </a:p>
         </p:txBody>
@@ -4474,7 +4477,7 @@
                 </a:solidFill>
                 <a:latin typeface="Arial"/>
               </a:rPr>
-              <a:t>evolve() = an agent that reads traces and writes config. We used Claude Code directly.</a:t>
+              <a:t>Not slide-watching. You run the loop on your laptop.</a:t>
             </a:r>
           </a:p>
           <a:p>
@@ -4490,7 +4493,7 @@
                 </a:solidFill>
                 <a:latin typeface="Arial"/>
               </a:rPr>
-              <a:t>•  read failure trajectories → diagnose the pattern → author a processor → re-eval → keep if it gates</a:t>
+              <a:t>•  1. Run the vanilla baseline → watch a frozen model FAIL a real benchmark task.</a:t>
             </a:r>
           </a:p>
           <a:p>
@@ -4506,7 +4509,55 @@
                 </a:solidFill>
                 <a:latin typeface="Arial"/>
               </a:rPr>
-              <a:t>•  No RL training. No GPU. The loop runs on a laptop.</a:t>
+              <a:t>•  2. Read the trace frontmatter → feel it's a harness failure, not a reasoning one.</a:t>
+            </a:r>
+          </a:p>
+          <a:p>
+            <a:pPr algn="l">
+              <a:spcAft>
+                <a:spcPts val="1000"/>
+              </a:spcAft>
+            </a:pPr>
+            <a:r>
+              <a:rPr sz="1800" b="0" i="0">
+                <a:solidFill>
+                  <a:srgbClr val="141824"/>
+                </a:solidFill>
+                <a:latin typeface="Arial"/>
+              </a:rPr>
+              <a:t>•  3. Invoke the harness-evolver skill → YOUR Claude Code diagnoses + authors a fix.</a:t>
+            </a:r>
+          </a:p>
+          <a:p>
+            <a:pPr algn="l">
+              <a:spcAft>
+                <a:spcPts val="1000"/>
+              </a:spcAft>
+            </a:pPr>
+            <a:r>
+              <a:rPr sz="1800" b="0" i="0">
+                <a:solidFill>
+                  <a:srgbClr val="141824"/>
+                </a:solidFill>
+                <a:latin typeface="Arial"/>
+              </a:rPr>
+              <a:t>•  4. make eval → see the number move. Loop until it lifts.</a:t>
+            </a:r>
+          </a:p>
+          <a:p>
+            <a:pPr algn="l">
+              <a:spcAft>
+                <a:spcPts val="600"/>
+              </a:spcAft>
+            </a:pPr>
+            <a:r>
+              <a:rPr sz="2000" b="1" i="0">
+                <a:solidFill>
+                  <a:srgbClr val="141824"/>
+                </a:solidFill>
+                <a:latin typeface="Arial"/>
+              </a:rPr>
+              <a:t>A reference solution is shipped — but try your own lever first.</a:t>
             </a:r>
           </a:p>
         </p:txBody>
@@ -4571,7 +4622,7 @@
                 </a:solidFill>
                 <a:latin typeface="Arial"/>
               </a:rPr>
-              <a:t>Reproduce it</a:t>
+              <a:t>The meta-agent is YOU (Claude Code)</a:t>
             </a:r>
           </a:p>
         </p:txBody>
@@ -4610,7 +4661,7 @@
                 </a:solidFill>
                 <a:latin typeface="Arial"/>
               </a:rPr>
-              <a:t>uv + Ollama + one fork.  make baseline → (Claude Code evolves) → make eval</a:t>
+              <a:t>evolve() = an agent that reads traces and writes config. We used Claude Code directly.</a:t>
             </a:r>
           </a:p>
           <a:p>
@@ -4626,7 +4677,7 @@
                 </a:solidFill>
                 <a:latin typeface="Arial"/>
               </a:rPr>
-              <a:t>•  Gotcha we hit: LLAMA_API_KEY in your shell 401s all local inference — unset it.</a:t>
+              <a:t>•  read failure trajectories → diagnose the pattern → author a processor → re-eval → keep if it gates</a:t>
             </a:r>
           </a:p>
           <a:p>
@@ -4642,7 +4693,7 @@
                 </a:solidFill>
                 <a:latin typeface="Arial"/>
               </a:rPr>
-              <a:t>•  Fork: github.com/epuerta9/HarnessX  (branch workshop/harness-evolution)</a:t>
+              <a:t>•  No RL training. No GPU. The loop runs on a laptop.</a:t>
             </a:r>
           </a:p>
         </p:txBody>
@@ -4707,7 +4758,7 @@
                 </a:solidFill>
                 <a:latin typeface="Arial"/>
               </a:rPr>
-              <a:t>Harness evolution IS reinforcement learning</a:t>
+              <a:t>Reproduce it</a:t>
             </a:r>
           </a:p>
         </p:txBody>
@@ -4746,7 +4797,7 @@
                 </a:solidFill>
                 <a:latin typeface="Arial"/>
               </a:rPr>
-              <a:t>The “operational mirror” — with the model FROZEN:</a:t>
+              <a:t>uv + Ollama + one fork.  make baseline → (Claude Code evolves) → make eval</a:t>
             </a:r>
           </a:p>
           <a:p>
@@ -4762,7 +4813,7 @@
                 </a:solidFill>
                 <a:latin typeface="Arial"/>
               </a:rPr>
-              <a:t>•  State = the HarnessConfig   ·   Action = pull one of the 4 levers</a:t>
+              <a:t>•  Gotcha we hit: LLAMA_API_KEY in your shell 401s all local inference — unset it.</a:t>
             </a:r>
           </a:p>
           <a:p>
@@ -4778,39 +4829,7 @@
                 </a:solidFill>
                 <a:latin typeface="Arial"/>
               </a:rPr>
-              <a:t>•  Policy = a stronger model reading the traces (that's Claude Code)</a:t>
-            </a:r>
-          </a:p>
-          <a:p>
-            <a:pPr algn="l">
-              <a:spcAft>
-                <a:spcPts val="1000"/>
-              </a:spcAft>
-            </a:pPr>
-            <a:r>
-              <a:rPr sz="1800" b="0" i="0">
-                <a:solidFill>
-                  <a:srgbClr val="141824"/>
-                </a:solidFill>
-                <a:latin typeface="Arial"/>
-              </a:rPr>
-              <a:t>•  Reward = the benchmark score   ·   Rollout = re-run the task set   ·   Gate = keep if reward↑</a:t>
-            </a:r>
-          </a:p>
-          <a:p>
-            <a:pPr algn="l">
-              <a:spcAft>
-                <a:spcPts val="600"/>
-              </a:spcAft>
-            </a:pPr>
-            <a:r>
-              <a:rPr sz="2000" b="1" i="0">
-                <a:solidFill>
-                  <a:srgbClr val="141824"/>
-                </a:solidFill>
-                <a:latin typeface="Arial"/>
-              </a:rPr>
-              <a:t>Agentic RL = use a stronger model to read traces, pick the lever, re-run, keep what improves.</a:t>
+              <a:t>•  Fork: github.com/epuerta9/HarnessX  (branch workshop/harness-evolution)</a:t>
             </a:r>
           </a:p>
         </p:txBody>
@@ -5001,8 +5020,8 @@
         </p:nvSpPr>
         <p:spPr>
           <a:xfrm>
-            <a:off x="822960" y="502920"/>
-            <a:ext cx="10515600" cy="914400"/>
+            <a:off x="822960" y="640080"/>
+            <a:ext cx="10515600" cy="1188720"/>
           </a:xfrm>
           <a:prstGeom prst="rect">
             <a:avLst/>
@@ -5021,51 +5040,27 @@
               </a:spcAft>
             </a:pPr>
             <a:r>
-              <a:rPr sz="3000" b="1" i="0">
-                <a:solidFill>
-                  <a:srgbClr val="141824"/>
-                </a:solidFill>
-                <a:latin typeface="Arial"/>
-              </a:rPr>
-              <a:t>Which lever moved the number</a:t>
-            </a:r>
-          </a:p>
-        </p:txBody>
-      </p:sp>
-      <p:pic>
-        <p:nvPicPr>
-          <p:cNvPr id="3" name="Picture 2" descr="lever-result-chart.png"/>
-          <p:cNvPicPr>
-            <a:picLocks noChangeAspect="1"/>
-          </p:cNvPicPr>
-          <p:nvPr/>
-        </p:nvPicPr>
-        <p:blipFill>
-          <a:blip r:embed="rId2"/>
-          <a:stretch>
-            <a:fillRect/>
-          </a:stretch>
-        </p:blipFill>
-        <p:spPr>
-          <a:xfrm>
-            <a:off x="1249527" y="1737360"/>
-            <a:ext cx="9692640" cy="3673000"/>
-          </a:xfrm>
-          <a:prstGeom prst="rect">
-            <a:avLst/>
-          </a:prstGeom>
-        </p:spPr>
-      </p:pic>
-      <p:sp>
-        <p:nvSpPr>
-          <p:cNvPr id="4" name="TextBox 3"/>
+              <a:rPr sz="3400" b="1" i="0">
+                <a:solidFill>
+                  <a:srgbClr val="141824"/>
+                </a:solidFill>
+                <a:latin typeface="Arial"/>
+              </a:rPr>
+              <a:t>Harness evolution IS reinforcement learning</a:t>
+            </a:r>
+          </a:p>
+        </p:txBody>
+      </p:sp>
+      <p:sp>
+        <p:nvSpPr>
+          <p:cNvPr id="3" name="TextBox 2"/>
           <p:cNvSpPr txBox="1"/>
           <p:nvPr/>
         </p:nvSpPr>
         <p:spPr>
           <a:xfrm>
-            <a:off x="822960" y="6126480"/>
-            <a:ext cx="10515600" cy="548640"/>
+            <a:off x="868680" y="2148840"/>
+            <a:ext cx="10424160" cy="4297680"/>
           </a:xfrm>
           <a:prstGeom prst="rect">
             <a:avLst/>
@@ -5078,19 +5073,83 @@
           </a:bodyPr>
           <a:lstStyle/>
           <a:p>
-            <a:pPr algn="ctr">
-              <a:spcAft>
-                <a:spcPts val="800"/>
-              </a:spcAft>
-            </a:pPr>
-            <a:r>
-              <a:rPr sz="1300" b="0" i="0">
-                <a:solidFill>
-                  <a:srgbClr val="666C7A"/>
-                </a:solidFill>
-                <a:latin typeface="Arial"/>
-              </a:rPr>
-              <a:t>Same frozen model. The lever lifts the score only when the benchmark gives a signal AND the failure matches the lever.</a:t>
+            <a:pPr algn="l">
+              <a:spcAft>
+                <a:spcPts val="600"/>
+              </a:spcAft>
+            </a:pPr>
+            <a:r>
+              <a:rPr sz="2000" b="1" i="0">
+                <a:solidFill>
+                  <a:srgbClr val="141824"/>
+                </a:solidFill>
+                <a:latin typeface="Arial"/>
+              </a:rPr>
+              <a:t>The “operational mirror” — with the model FROZEN:</a:t>
+            </a:r>
+          </a:p>
+          <a:p>
+            <a:pPr algn="l">
+              <a:spcAft>
+                <a:spcPts val="1000"/>
+              </a:spcAft>
+            </a:pPr>
+            <a:r>
+              <a:rPr sz="1800" b="0" i="0">
+                <a:solidFill>
+                  <a:srgbClr val="141824"/>
+                </a:solidFill>
+                <a:latin typeface="Arial"/>
+              </a:rPr>
+              <a:t>•  State = the HarnessConfig   ·   Action = pull one of the 4 levers</a:t>
+            </a:r>
+          </a:p>
+          <a:p>
+            <a:pPr algn="l">
+              <a:spcAft>
+                <a:spcPts val="1000"/>
+              </a:spcAft>
+            </a:pPr>
+            <a:r>
+              <a:rPr sz="1800" b="0" i="0">
+                <a:solidFill>
+                  <a:srgbClr val="141824"/>
+                </a:solidFill>
+                <a:latin typeface="Arial"/>
+              </a:rPr>
+              <a:t>•  Policy = a stronger model reading the traces (that's Claude Code)</a:t>
+            </a:r>
+          </a:p>
+          <a:p>
+            <a:pPr algn="l">
+              <a:spcAft>
+                <a:spcPts val="1000"/>
+              </a:spcAft>
+            </a:pPr>
+            <a:r>
+              <a:rPr sz="1800" b="0" i="0">
+                <a:solidFill>
+                  <a:srgbClr val="141824"/>
+                </a:solidFill>
+                <a:latin typeface="Arial"/>
+              </a:rPr>
+              <a:t>•  Reward = the benchmark score   ·   Rollout = re-run the task set   ·   Gate = keep if reward↑</a:t>
+            </a:r>
+          </a:p>
+          <a:p>
+            <a:pPr algn="l">
+              <a:spcAft>
+                <a:spcPts val="600"/>
+              </a:spcAft>
+            </a:pPr>
+            <a:r>
+              <a:rPr sz="2000" b="1" i="0">
+                <a:solidFill>
+                  <a:srgbClr val="141824"/>
+                </a:solidFill>
+                <a:latin typeface="Arial"/>
+              </a:rPr>
+              <a:t>Agentic RL = use a stronger model to read traces, pick the lever, re-run, keep what improves.</a:t>
             </a:r>
           </a:p>
         </p:txBody>
@@ -5129,8 +5188,8 @@
         </p:nvSpPr>
         <p:spPr>
           <a:xfrm>
-            <a:off x="822960" y="640080"/>
-            <a:ext cx="10515600" cy="1188720"/>
+            <a:off x="822960" y="502920"/>
+            <a:ext cx="10515600" cy="914400"/>
           </a:xfrm>
           <a:prstGeom prst="rect">
             <a:avLst/>
@@ -5149,27 +5208,51 @@
               </a:spcAft>
             </a:pPr>
             <a:r>
-              <a:rPr sz="3400" b="1" i="0">
-                <a:solidFill>
-                  <a:srgbClr val="141824"/>
-                </a:solidFill>
-                <a:latin typeface="Arial"/>
-              </a:rPr>
-              <a:t>Which component makes the biggest difference?</a:t>
-            </a:r>
-          </a:p>
-        </p:txBody>
-      </p:sp>
-      <p:sp>
-        <p:nvSpPr>
-          <p:cNvPr id="3" name="TextBox 2"/>
+              <a:rPr sz="3000" b="1" i="0">
+                <a:solidFill>
+                  <a:srgbClr val="141824"/>
+                </a:solidFill>
+                <a:latin typeface="Arial"/>
+              </a:rPr>
+              <a:t>Which lever moved the number</a:t>
+            </a:r>
+          </a:p>
+        </p:txBody>
+      </p:sp>
+      <p:pic>
+        <p:nvPicPr>
+          <p:cNvPr id="3" name="Picture 2" descr="lever-result-chart.png"/>
+          <p:cNvPicPr>
+            <a:picLocks noChangeAspect="1"/>
+          </p:cNvPicPr>
+          <p:nvPr/>
+        </p:nvPicPr>
+        <p:blipFill>
+          <a:blip r:embed="rId2"/>
+          <a:stretch>
+            <a:fillRect/>
+          </a:stretch>
+        </p:blipFill>
+        <p:spPr>
+          <a:xfrm>
+            <a:off x="1249527" y="1737360"/>
+            <a:ext cx="9692640" cy="3673000"/>
+          </a:xfrm>
+          <a:prstGeom prst="rect">
+            <a:avLst/>
+          </a:prstGeom>
+        </p:spPr>
+      </p:pic>
+      <p:sp>
+        <p:nvSpPr>
+          <p:cNvPr id="4" name="TextBox 3"/>
           <p:cNvSpPr txBox="1"/>
           <p:nvPr/>
         </p:nvSpPr>
         <p:spPr>
           <a:xfrm>
-            <a:off x="868680" y="2148840"/>
-            <a:ext cx="10424160" cy="4297680"/>
+            <a:off x="822960" y="6126480"/>
+            <a:ext cx="10515600" cy="548640"/>
           </a:xfrm>
           <a:prstGeom prst="rect">
             <a:avLst/>
@@ -5182,99 +5265,19 @@
           </a:bodyPr>
           <a:lstStyle/>
           <a:p>
-            <a:pPr algn="l">
-              <a:spcAft>
-                <a:spcPts val="600"/>
-              </a:spcAft>
-            </a:pPr>
-            <a:r>
-              <a:rPr sz="2000" b="1" i="0">
-                <a:solidFill>
-                  <a:srgbClr val="141824"/>
-                </a:solidFill>
-                <a:latin typeface="Arial"/>
-              </a:rPr>
-              <a:t>Ablation: run vanilla / control-only / IRMA-only / full on the SAME tasks.</a:t>
-            </a:r>
-          </a:p>
-          <a:p>
-            <a:pPr algn="l">
-              <a:spcAft>
-                <a:spcPts val="1000"/>
-              </a:spcAft>
-            </a:pPr>
-            <a:r>
-              <a:rPr sz="1800" b="0" i="0">
-                <a:solidFill>
-                  <a:srgbClr val="141824"/>
-                </a:solidFill>
-                <a:latin typeface="Arial"/>
-              </a:rPr>
-              <a:t>•  Single-trial trap: variance (±0.25) is as big as the effect — the same config scores 0.50 OR 0.75 by luck.</a:t>
-            </a:r>
-          </a:p>
-          <a:p>
-            <a:pPr algn="l">
-              <a:spcAft>
-                <a:spcPts val="1000"/>
-              </a:spcAft>
-            </a:pPr>
-            <a:r>
-              <a:rPr sz="1800" b="0" i="0">
-                <a:solidFill>
-                  <a:srgbClr val="141824"/>
-                </a:solidFill>
-                <a:latin typeface="Arial"/>
-              </a:rPr>
-              <a:t>•  So you CANNOT rank components from one run. Attribution is statistical, not anecdotal.</a:t>
-            </a:r>
-          </a:p>
-          <a:p>
-            <a:pPr algn="l">
-              <a:spcAft>
-                <a:spcPts val="1000"/>
-              </a:spcAft>
-            </a:pPr>
-            <a:r>
-              <a:rPr sz="1800" b="0" i="0">
-                <a:solidFill>
-                  <a:srgbClr val="141824"/>
-                </a:solidFill>
-                <a:latin typeface="Arial"/>
-              </a:rPr>
-              <a:t>•  Fix: multiple trials (pass^k) + task-level check + leave-one-out to kill inert processors.</a:t>
-            </a:r>
-          </a:p>
-          <a:p>
-            <a:pPr algn="l">
-              <a:spcAft>
-                <a:spcPts val="600"/>
-              </a:spcAft>
-            </a:pPr>
-            <a:r>
-              <a:rPr sz="2000" b="1" i="0">
-                <a:solidFill>
-                  <a:srgbClr val="141824"/>
-                </a:solidFill>
-                <a:latin typeface="Arial"/>
-              </a:rPr>
-              <a:t>Task-level signal: IRMA's roaming alert rescues the roaming task; control processors are inert here.</a:t>
-            </a:r>
-          </a:p>
-          <a:p>
-            <a:pPr algn="l">
-              <a:spcAft>
-                <a:spcPts val="1000"/>
-              </a:spcAft>
-            </a:pPr>
-            <a:r>
-              <a:rPr sz="1800" b="0" i="0">
-                <a:solidFill>
-                  <a:srgbClr val="141824"/>
-                </a:solidFill>
-                <a:latin typeface="Arial"/>
-              </a:rPr>
-              <a:t>•  Reproducible in one command:  bash workshop/ablate.sh</a:t>
+            <a:pPr algn="ctr">
+              <a:spcAft>
+                <a:spcPts val="800"/>
+              </a:spcAft>
+            </a:pPr>
+            <a:r>
+              <a:rPr sz="1300" b="0" i="0">
+                <a:solidFill>
+                  <a:srgbClr val="666C7A"/>
+                </a:solidFill>
+                <a:latin typeface="Arial"/>
+              </a:rPr>
+              <a:t>Same frozen model. The lever lifts the score only when the benchmark gives a signal AND the failure matches the lever.</a:t>
             </a:r>
           </a:p>
         </p:txBody>
@@ -5313,8 +5316,8 @@
         </p:nvSpPr>
         <p:spPr>
           <a:xfrm>
-            <a:off x="822960" y="502920"/>
-            <a:ext cx="10515600" cy="914400"/>
+            <a:off x="822960" y="640080"/>
+            <a:ext cx="10515600" cy="1188720"/>
           </a:xfrm>
           <a:prstGeom prst="rect">
             <a:avLst/>
@@ -5333,51 +5336,27 @@
               </a:spcAft>
             </a:pPr>
             <a:r>
-              <a:rPr sz="3000" b="1" i="0">
-                <a:solidFill>
-                  <a:srgbClr val="141824"/>
-                </a:solidFill>
-                <a:latin typeface="Arial"/>
-              </a:rPr>
-              <a:t>Attribution (3 trials): one component did the work</a:t>
-            </a:r>
-          </a:p>
-        </p:txBody>
-      </p:sp>
-      <p:pic>
-        <p:nvPicPr>
-          <p:cNvPr id="3" name="Picture 2" descr="attribution-chart.png"/>
-          <p:cNvPicPr>
-            <a:picLocks noChangeAspect="1"/>
-          </p:cNvPicPr>
-          <p:nvPr/>
-        </p:nvPicPr>
-        <p:blipFill>
-          <a:blip r:embed="rId2"/>
-          <a:stretch>
-            <a:fillRect/>
-          </a:stretch>
-        </p:blipFill>
-        <p:spPr>
-          <a:xfrm>
-            <a:off x="1249527" y="1737360"/>
-            <a:ext cx="9692640" cy="3264889"/>
-          </a:xfrm>
-          <a:prstGeom prst="rect">
-            <a:avLst/>
-          </a:prstGeom>
-        </p:spPr>
-      </p:pic>
-      <p:sp>
-        <p:nvSpPr>
-          <p:cNvPr id="4" name="TextBox 3"/>
+              <a:rPr sz="3400" b="1" i="0">
+                <a:solidFill>
+                  <a:srgbClr val="141824"/>
+                </a:solidFill>
+                <a:latin typeface="Arial"/>
+              </a:rPr>
+              <a:t>Which component makes the biggest difference?</a:t>
+            </a:r>
+          </a:p>
+        </p:txBody>
+      </p:sp>
+      <p:sp>
+        <p:nvSpPr>
+          <p:cNvPr id="3" name="TextBox 2"/>
           <p:cNvSpPr txBox="1"/>
           <p:nvPr/>
         </p:nvSpPr>
         <p:spPr>
           <a:xfrm>
-            <a:off x="822960" y="6126480"/>
-            <a:ext cx="10515600" cy="548640"/>
+            <a:off x="868680" y="2148840"/>
+            <a:ext cx="10424160" cy="4297680"/>
           </a:xfrm>
           <a:prstGeom prst="rect">
             <a:avLst/>
@@ -5390,19 +5369,99 @@
           </a:bodyPr>
           <a:lstStyle/>
           <a:p>
-            <a:pPr algn="ctr">
-              <a:spcAft>
-                <a:spcPts val="800"/>
-              </a:spcAft>
-            </a:pPr>
-            <a:r>
-              <a:rPr sz="1300" b="0" i="0">
-                <a:solidFill>
-                  <a:srgbClr val="666C7A"/>
-                </a:solidFill>
-                <a:latin typeface="Arial"/>
-              </a:rPr>
-              <a:t>Multi-trial averaging clears the noise: IRMA (+0.167) drives the lift; the 5 control processors are inert (−0.083). Leave-one-out would drop them.</a:t>
+            <a:pPr algn="l">
+              <a:spcAft>
+                <a:spcPts val="600"/>
+              </a:spcAft>
+            </a:pPr>
+            <a:r>
+              <a:rPr sz="2000" b="1" i="0">
+                <a:solidFill>
+                  <a:srgbClr val="141824"/>
+                </a:solidFill>
+                <a:latin typeface="Arial"/>
+              </a:rPr>
+              <a:t>Ablation: run vanilla / control-only / IRMA-only / full on the SAME tasks.</a:t>
+            </a:r>
+          </a:p>
+          <a:p>
+            <a:pPr algn="l">
+              <a:spcAft>
+                <a:spcPts val="1000"/>
+              </a:spcAft>
+            </a:pPr>
+            <a:r>
+              <a:rPr sz="1800" b="0" i="0">
+                <a:solidFill>
+                  <a:srgbClr val="141824"/>
+                </a:solidFill>
+                <a:latin typeface="Arial"/>
+              </a:rPr>
+              <a:t>•  Single-trial trap: variance (±0.25) is as big as the effect — the same config scores 0.50 OR 0.75 by luck.</a:t>
+            </a:r>
+          </a:p>
+          <a:p>
+            <a:pPr algn="l">
+              <a:spcAft>
+                <a:spcPts val="1000"/>
+              </a:spcAft>
+            </a:pPr>
+            <a:r>
+              <a:rPr sz="1800" b="0" i="0">
+                <a:solidFill>
+                  <a:srgbClr val="141824"/>
+                </a:solidFill>
+                <a:latin typeface="Arial"/>
+              </a:rPr>
+              <a:t>•  So you CANNOT rank components from one run. Attribution is statistical, not anecdotal.</a:t>
+            </a:r>
+          </a:p>
+          <a:p>
+            <a:pPr algn="l">
+              <a:spcAft>
+                <a:spcPts val="1000"/>
+              </a:spcAft>
+            </a:pPr>
+            <a:r>
+              <a:rPr sz="1800" b="0" i="0">
+                <a:solidFill>
+                  <a:srgbClr val="141824"/>
+                </a:solidFill>
+                <a:latin typeface="Arial"/>
+              </a:rPr>
+              <a:t>•  Fix: multiple trials (pass^k) + task-level check + leave-one-out to kill inert processors.</a:t>
+            </a:r>
+          </a:p>
+          <a:p>
+            <a:pPr algn="l">
+              <a:spcAft>
+                <a:spcPts val="600"/>
+              </a:spcAft>
+            </a:pPr>
+            <a:r>
+              <a:rPr sz="2000" b="1" i="0">
+                <a:solidFill>
+                  <a:srgbClr val="141824"/>
+                </a:solidFill>
+                <a:latin typeface="Arial"/>
+              </a:rPr>
+              <a:t>Task-level signal: IRMA's roaming alert rescues the roaming task; control processors are inert here.</a:t>
+            </a:r>
+          </a:p>
+          <a:p>
+            <a:pPr algn="l">
+              <a:spcAft>
+                <a:spcPts val="1000"/>
+              </a:spcAft>
+            </a:pPr>
+            <a:r>
+              <a:rPr sz="1800" b="0" i="0">
+                <a:solidFill>
+                  <a:srgbClr val="141824"/>
+                </a:solidFill>
+                <a:latin typeface="Arial"/>
+              </a:rPr>
+              <a:t>•  Reproducible in one command:  bash workshop/ablate.sh</a:t>
             </a:r>
           </a:p>
         </p:txBody>
@@ -5441,8 +5500,8 @@
         </p:nvSpPr>
         <p:spPr>
           <a:xfrm>
-            <a:off x="822960" y="640080"/>
-            <a:ext cx="10515600" cy="1188720"/>
+            <a:off x="822960" y="502920"/>
+            <a:ext cx="10515600" cy="914400"/>
           </a:xfrm>
           <a:prstGeom prst="rect">
             <a:avLst/>
@@ -5461,27 +5520,51 @@
               </a:spcAft>
             </a:pPr>
             <a:r>
-              <a:rPr sz="3400" b="1" i="0">
-                <a:solidFill>
-                  <a:srgbClr val="141824"/>
-                </a:solidFill>
-                <a:latin typeface="Arial"/>
-              </a:rPr>
-              <a:t>Did we prove the paper? (partly — yes)</a:t>
-            </a:r>
-          </a:p>
-        </p:txBody>
-      </p:sp>
-      <p:sp>
-        <p:nvSpPr>
-          <p:cNvPr id="3" name="TextBox 2"/>
+              <a:rPr sz="3000" b="1" i="0">
+                <a:solidFill>
+                  <a:srgbClr val="141824"/>
+                </a:solidFill>
+                <a:latin typeface="Arial"/>
+              </a:rPr>
+              <a:t>Attribution (3 trials): one component did the work</a:t>
+            </a:r>
+          </a:p>
+        </p:txBody>
+      </p:sp>
+      <p:pic>
+        <p:nvPicPr>
+          <p:cNvPr id="3" name="Picture 2" descr="attribution-chart.png"/>
+          <p:cNvPicPr>
+            <a:picLocks noChangeAspect="1"/>
+          </p:cNvPicPr>
+          <p:nvPr/>
+        </p:nvPicPr>
+        <p:blipFill>
+          <a:blip r:embed="rId2"/>
+          <a:stretch>
+            <a:fillRect/>
+          </a:stretch>
+        </p:blipFill>
+        <p:spPr>
+          <a:xfrm>
+            <a:off x="1249527" y="1737360"/>
+            <a:ext cx="9692640" cy="3264889"/>
+          </a:xfrm>
+          <a:prstGeom prst="rect">
+            <a:avLst/>
+          </a:prstGeom>
+        </p:spPr>
+      </p:pic>
+      <p:sp>
+        <p:nvSpPr>
+          <p:cNvPr id="4" name="TextBox 3"/>
           <p:cNvSpPr txBox="1"/>
           <p:nvPr/>
         </p:nvSpPr>
         <p:spPr>
           <a:xfrm>
-            <a:off x="868680" y="2148840"/>
-            <a:ext cx="10424160" cy="4297680"/>
+            <a:off x="822960" y="6126480"/>
+            <a:ext cx="10515600" cy="548640"/>
           </a:xfrm>
           <a:prstGeom prst="rect">
             <a:avLst/>
@@ -5494,83 +5577,19 @@
           </a:bodyPr>
           <a:lstStyle/>
           <a:p>
-            <a:pPr algn="l">
-              <a:spcAft>
-                <a:spcPts val="1000"/>
-              </a:spcAft>
-            </a:pPr>
-            <a:r>
-              <a:rPr sz="1800" b="0" i="0">
-                <a:solidFill>
-                  <a:srgbClr val="141824"/>
-                </a:solidFill>
-                <a:latin typeface="Arial"/>
-              </a:rPr>
-              <a:t>•  ✓ A FROZEN model's benchmark score rose via a harness edit alone (telecom 0.50 → 0.75).</a:t>
-            </a:r>
-          </a:p>
-          <a:p>
-            <a:pPr algn="l">
-              <a:spcAft>
-                <a:spcPts val="1000"/>
-              </a:spcAft>
-            </a:pPr>
-            <a:r>
-              <a:rPr sz="1800" b="0" i="0">
-                <a:solidFill>
-                  <a:srgbClr val="141824"/>
-                </a:solidFill>
-                <a:latin typeface="Arial"/>
-              </a:rPr>
-              <a:t>•  ✓ The moat is the infrastructure — we diagnosed + evolved purely off typed processors + structured traces.</a:t>
-            </a:r>
-          </a:p>
-          <a:p>
-            <a:pPr algn="l">
-              <a:spcAft>
-                <a:spcPts val="1000"/>
-              </a:spcAft>
-            </a:pPr>
-            <a:r>
-              <a:rPr sz="1800" b="0" i="0">
-                <a:solidFill>
-                  <a:srgbClr val="141824"/>
-                </a:solidFill>
-                <a:latin typeface="Arial"/>
-              </a:rPr>
-              <a:t>•  ✓ Lever mix is context-dependent — IRMA worked on telecom, did nothing on retail (grading mismatch).</a:t>
-            </a:r>
-          </a:p>
-          <a:p>
-            <a:pPr algn="l">
-              <a:spcAft>
-                <a:spcPts val="1000"/>
-              </a:spcAft>
-            </a:pPr>
-            <a:r>
-              <a:rPr sz="1800" b="0" i="0">
-                <a:solidFill>
-                  <a:srgbClr val="141824"/>
-                </a:solidFill>
-                <a:latin typeface="Arial"/>
-              </a:rPr>
-              <a:t>•  ✓ Ceiling/floor effects — 32B at ceiling on easy tasks; strict retail grading = effective floor.</a:t>
-            </a:r>
-          </a:p>
-          <a:p>
-            <a:pPr algn="l">
-              <a:spcAft>
-                <a:spcPts val="600"/>
-              </a:spcAft>
-            </a:pPr>
-            <a:r>
-              <a:rPr sz="2000" b="1" i="0">
-                <a:solidFill>
-                  <a:srgbClr val="141824"/>
-                </a:solidFill>
-                <a:latin typeface="Arial"/>
-              </a:rPr>
-              <a:t>Not reproduced (needs scale): +14.5% magnitudes, multi-round + the 3 RL pathologies, AEGIS, co-evolution.</a:t>
+            <a:pPr algn="ctr">
+              <a:spcAft>
+                <a:spcPts val="800"/>
+              </a:spcAft>
+            </a:pPr>
+            <a:r>
+              <a:rPr sz="1300" b="0" i="0">
+                <a:solidFill>
+                  <a:srgbClr val="666C7A"/>
+                </a:solidFill>
+                <a:latin typeface="Arial"/>
+              </a:rPr>
+              <a:t>Multi-trial averaging clears the noise: IRMA (+0.167) drives the lift; the 5 control processors are inert (−0.083). Leave-one-out would drop them.</a:t>
             </a:r>
           </a:p>
         </p:txBody>
@@ -5635,7 +5654,7 @@
                 </a:solidFill>
                 <a:latin typeface="Arial"/>
               </a:rPr>
-              <a:t>Crutch or capability? Two value props</a:t>
+              <a:t>Did we prove the paper? (partly — yes)</a:t>
             </a:r>
           </a:p>
         </p:txBody>
@@ -5674,7 +5693,7 @@
                 </a:solidFill>
                 <a:latin typeface="Arial"/>
               </a:rPr>
-              <a:t>•  Deterministic Control fixes (roaming alert, ParseRetry) are a CRUTCH — they recover latent</a:t>
+              <a:t>•  ✓ A FROZEN model's benchmark score rose via a harness edit alone (telecom 0.50 → 0.75).</a:t>
             </a:r>
           </a:p>
           <a:p>
@@ -5690,7 +5709,39 @@
                 </a:solidFill>
                 <a:latin typeface="Arial"/>
               </a:rPr>
-              <a:t>•  capability a frozen model failed to apply. Real, but capped at the model's ceiling.</a:t>
+              <a:t>•  ✓ The moat is the infrastructure — we diagnosed + evolved purely off typed processors + structured traces.</a:t>
+            </a:r>
+          </a:p>
+          <a:p>
+            <a:pPr algn="l">
+              <a:spcAft>
+                <a:spcPts val="1000"/>
+              </a:spcAft>
+            </a:pPr>
+            <a:r>
+              <a:rPr sz="1800" b="0" i="0">
+                <a:solidFill>
+                  <a:srgbClr val="141824"/>
+                </a:solidFill>
+                <a:latin typeface="Arial"/>
+              </a:rPr>
+              <a:t>•  ✓ Lever mix is context-dependent — IRMA worked on telecom, did nothing on retail (grading mismatch).</a:t>
+            </a:r>
+          </a:p>
+          <a:p>
+            <a:pPr algn="l">
+              <a:spcAft>
+                <a:spcPts val="1000"/>
+              </a:spcAft>
+            </a:pPr>
+            <a:r>
+              <a:rPr sz="1800" b="0" i="0">
+                <a:solidFill>
+                  <a:srgbClr val="141824"/>
+                </a:solidFill>
+                <a:latin typeface="Arial"/>
+              </a:rPr>
+              <a:t>•  ✓ Ceiling/floor effects — 32B at ceiling on easy tasks; strict retail grading = effective floor.</a:t>
             </a:r>
           </a:p>
           <a:p>
@@ -5706,39 +5757,7 @@
                 </a:solidFill>
                 <a:latin typeface="Arial"/>
               </a:rPr>
-              <a:t>Instruction (reasoning scaffolds) + Action (tools/skills) ADD realized capability — not plumbing.</a:t>
-            </a:r>
-          </a:p>
-          <a:p>
-            <a:pPr algn="l">
-              <a:spcAft>
-                <a:spcPts val="1000"/>
-              </a:spcAft>
-            </a:pPr>
-            <a:r>
-              <a:rPr sz="1800" b="0" i="0">
-                <a:solidFill>
-                  <a:srgbClr val="141824"/>
-                </a:solidFill>
-                <a:latin typeface="Arial"/>
-              </a:rPr>
-              <a:t>•  To raise the ceiling itself, you need loop 2: RL on the weights (co-evolution). Different game.</a:t>
-            </a:r>
-          </a:p>
-          <a:p>
-            <a:pPr algn="l">
-              <a:spcAft>
-                <a:spcPts val="600"/>
-              </a:spcAft>
-            </a:pPr>
-            <a:r>
-              <a:rPr sz="2000" b="1" i="0">
-                <a:solidFill>
-                  <a:srgbClr val="141824"/>
-                </a:solidFill>
-                <a:latin typeface="Arial"/>
-              </a:rPr>
-              <a:t>On a frozen model, the most capability-like levers are reasoning scaffolds + new tools.</a:t>
+              <a:t>Not reproduced (needs scale): +14.5% magnitudes, multi-round + the 3 RL pathologies, AEGIS, co-evolution.</a:t>
             </a:r>
           </a:p>
         </p:txBody>
@@ -5777,6 +5796,174 @@
         </p:nvSpPr>
         <p:spPr>
           <a:xfrm>
+            <a:off x="822960" y="640080"/>
+            <a:ext cx="10515600" cy="1188720"/>
+          </a:xfrm>
+          <a:prstGeom prst="rect">
+            <a:avLst/>
+          </a:prstGeom>
+          <a:noFill/>
+        </p:spPr>
+        <p:txBody>
+          <a:bodyPr wrap="square">
+            <a:spAutoFit/>
+          </a:bodyPr>
+          <a:lstStyle/>
+          <a:p>
+            <a:pPr algn="l">
+              <a:spcAft>
+                <a:spcPts val="800"/>
+              </a:spcAft>
+            </a:pPr>
+            <a:r>
+              <a:rPr sz="3400" b="1" i="0">
+                <a:solidFill>
+                  <a:srgbClr val="141824"/>
+                </a:solidFill>
+                <a:latin typeface="Arial"/>
+              </a:rPr>
+              <a:t>Crutch or capability? Two value props</a:t>
+            </a:r>
+          </a:p>
+        </p:txBody>
+      </p:sp>
+      <p:sp>
+        <p:nvSpPr>
+          <p:cNvPr id="3" name="TextBox 2"/>
+          <p:cNvSpPr txBox="1"/>
+          <p:nvPr/>
+        </p:nvSpPr>
+        <p:spPr>
+          <a:xfrm>
+            <a:off x="868680" y="2148840"/>
+            <a:ext cx="10424160" cy="4297680"/>
+          </a:xfrm>
+          <a:prstGeom prst="rect">
+            <a:avLst/>
+          </a:prstGeom>
+          <a:noFill/>
+        </p:spPr>
+        <p:txBody>
+          <a:bodyPr wrap="square">
+            <a:spAutoFit/>
+          </a:bodyPr>
+          <a:lstStyle/>
+          <a:p>
+            <a:pPr algn="l">
+              <a:spcAft>
+                <a:spcPts val="1000"/>
+              </a:spcAft>
+            </a:pPr>
+            <a:r>
+              <a:rPr sz="1800" b="0" i="0">
+                <a:solidFill>
+                  <a:srgbClr val="141824"/>
+                </a:solidFill>
+                <a:latin typeface="Arial"/>
+              </a:rPr>
+              <a:t>•  Deterministic Control fixes (roaming alert, ParseRetry) are a CRUTCH — they recover latent</a:t>
+            </a:r>
+          </a:p>
+          <a:p>
+            <a:pPr algn="l">
+              <a:spcAft>
+                <a:spcPts val="1000"/>
+              </a:spcAft>
+            </a:pPr>
+            <a:r>
+              <a:rPr sz="1800" b="0" i="0">
+                <a:solidFill>
+                  <a:srgbClr val="141824"/>
+                </a:solidFill>
+                <a:latin typeface="Arial"/>
+              </a:rPr>
+              <a:t>•  capability a frozen model failed to apply. Real, but capped at the model's ceiling.</a:t>
+            </a:r>
+          </a:p>
+          <a:p>
+            <a:pPr algn="l">
+              <a:spcAft>
+                <a:spcPts val="600"/>
+              </a:spcAft>
+            </a:pPr>
+            <a:r>
+              <a:rPr sz="2000" b="1" i="0">
+                <a:solidFill>
+                  <a:srgbClr val="141824"/>
+                </a:solidFill>
+                <a:latin typeface="Arial"/>
+              </a:rPr>
+              <a:t>Instruction (reasoning scaffolds) + Action (tools/skills) ADD realized capability — not plumbing.</a:t>
+            </a:r>
+          </a:p>
+          <a:p>
+            <a:pPr algn="l">
+              <a:spcAft>
+                <a:spcPts val="1000"/>
+              </a:spcAft>
+            </a:pPr>
+            <a:r>
+              <a:rPr sz="1800" b="0" i="0">
+                <a:solidFill>
+                  <a:srgbClr val="141824"/>
+                </a:solidFill>
+                <a:latin typeface="Arial"/>
+              </a:rPr>
+              <a:t>•  To raise the ceiling itself, you need loop 2: RL on the weights (co-evolution). Different game.</a:t>
+            </a:r>
+          </a:p>
+          <a:p>
+            <a:pPr algn="l">
+              <a:spcAft>
+                <a:spcPts val="600"/>
+              </a:spcAft>
+            </a:pPr>
+            <a:r>
+              <a:rPr sz="2000" b="1" i="0">
+                <a:solidFill>
+                  <a:srgbClr val="141824"/>
+                </a:solidFill>
+                <a:latin typeface="Arial"/>
+              </a:rPr>
+              <a:t>On a frozen model, the most capability-like levers are reasoning scaffolds + new tools.</a:t>
+            </a:r>
+          </a:p>
+        </p:txBody>
+      </p:sp>
+    </p:spTree>
+  </p:cSld>
+  <p:clrMapOvr>
+    <a:masterClrMapping/>
+  </p:clrMapOvr>
+</p:sld>
+</file>
+
+<file path=ppt/slides/slide26.xml><?xml version="1.0" encoding="utf-8"?>
+<p:sld xmlns:a="http://schemas.openxmlformats.org/drawingml/2006/main" xmlns:p="http://schemas.openxmlformats.org/presentationml/2006/main" xmlns:r="http://schemas.openxmlformats.org/officeDocument/2006/relationships">
+  <p:cSld>
+    <p:bg>
+      <p:bgPr>
+        <a:solidFill>
+          <a:srgbClr val="F7F7FB"/>
+        </a:solidFill>
+        <a:effectLst/>
+      </p:bgPr>
+    </p:bg>
+    <p:spTree>
+      <p:nvGrpSpPr>
+        <p:cNvPr id="1" name=""/>
+        <p:cNvGrpSpPr/>
+        <p:nvPr/>
+      </p:nvGrpSpPr>
+      <p:grpSpPr/>
+      <p:sp>
+        <p:nvSpPr>
+          <p:cNvPr id="2" name="TextBox 1"/>
+          <p:cNvSpPr txBox="1"/>
+          <p:nvPr/>
+        </p:nvSpPr>
+        <p:spPr>
+          <a:xfrm>
             <a:off x="822960" y="502920"/>
             <a:ext cx="10515600" cy="914400"/>
           </a:xfrm>
@@ -5879,7 +6066,303 @@
 </p:sld>
 </file>
 
-<file path=ppt/slides/slide26.xml><?xml version="1.0" encoding="utf-8"?>
+<file path=ppt/slides/slide27.xml><?xml version="1.0" encoding="utf-8"?>
+<p:sld xmlns:a="http://schemas.openxmlformats.org/drawingml/2006/main" xmlns:p="http://schemas.openxmlformats.org/presentationml/2006/main" xmlns:r="http://schemas.openxmlformats.org/officeDocument/2006/relationships">
+  <p:cSld>
+    <p:bg>
+      <p:bgPr>
+        <a:solidFill>
+          <a:srgbClr val="F7F7FB"/>
+        </a:solidFill>
+        <a:effectLst/>
+      </p:bgPr>
+    </p:bg>
+    <p:spTree>
+      <p:nvGrpSpPr>
+        <p:cNvPr id="1" name=""/>
+        <p:cNvGrpSpPr/>
+        <p:nvPr/>
+      </p:nvGrpSpPr>
+      <p:grpSpPr/>
+      <p:sp>
+        <p:nvSpPr>
+          <p:cNvPr id="2" name="TextBox 1"/>
+          <p:cNvSpPr txBox="1"/>
+          <p:nvPr/>
+        </p:nvSpPr>
+        <p:spPr>
+          <a:xfrm>
+            <a:off x="822960" y="502920"/>
+            <a:ext cx="10515600" cy="914400"/>
+          </a:xfrm>
+          <a:prstGeom prst="rect">
+            <a:avLst/>
+          </a:prstGeom>
+          <a:noFill/>
+        </p:spPr>
+        <p:txBody>
+          <a:bodyPr wrap="square">
+            <a:spAutoFit/>
+          </a:bodyPr>
+          <a:lstStyle/>
+          <a:p>
+            <a:pPr algn="l">
+              <a:spcAft>
+                <a:spcPts val="800"/>
+              </a:spcAft>
+            </a:pPr>
+            <a:r>
+              <a:rPr sz="3000" b="1" i="0">
+                <a:solidFill>
+                  <a:srgbClr val="141824"/>
+                </a:solidFill>
+                <a:latin typeface="Arial"/>
+              </a:rPr>
+              <a:t>The spectrum of harness value (all 3 levers, real numbers)</a:t>
+            </a:r>
+          </a:p>
+        </p:txBody>
+      </p:sp>
+      <p:pic>
+        <p:nvPicPr>
+          <p:cNvPr id="3" name="Picture 2" descr="levers-spectrum-chart.png"/>
+          <p:cNvPicPr>
+            <a:picLocks noChangeAspect="1"/>
+          </p:cNvPicPr>
+          <p:nvPr/>
+        </p:nvPicPr>
+        <p:blipFill>
+          <a:blip r:embed="rId2"/>
+          <a:stretch>
+            <a:fillRect/>
+          </a:stretch>
+        </p:blipFill>
+        <p:spPr>
+          <a:xfrm>
+            <a:off x="1249527" y="1737360"/>
+            <a:ext cx="9692640" cy="3415501"/>
+          </a:xfrm>
+          <a:prstGeom prst="rect">
+            <a:avLst/>
+          </a:prstGeom>
+        </p:spPr>
+      </p:pic>
+      <p:sp>
+        <p:nvSpPr>
+          <p:cNvPr id="4" name="TextBox 3"/>
+          <p:cNvSpPr txBox="1"/>
+          <p:nvPr/>
+        </p:nvSpPr>
+        <p:spPr>
+          <a:xfrm>
+            <a:off x="822960" y="6126480"/>
+            <a:ext cx="10515600" cy="548640"/>
+          </a:xfrm>
+          <a:prstGeom prst="rect">
+            <a:avLst/>
+          </a:prstGeom>
+          <a:noFill/>
+        </p:spPr>
+        <p:txBody>
+          <a:bodyPr wrap="square">
+            <a:spAutoFit/>
+          </a:bodyPr>
+          <a:lstStyle/>
+          <a:p>
+            <a:pPr algn="ctr">
+              <a:spcAft>
+                <a:spcPts val="800"/>
+              </a:spcAft>
+            </a:pPr>
+            <a:r>
+              <a:rPr sz="1300" b="0" i="0">
+                <a:solidFill>
+                  <a:srgbClr val="666C7A"/>
+                </a:solidFill>
+                <a:latin typeface="Arial"/>
+              </a:rPr>
+              <a:t>Action ADDS capability (private KB 0.00 → 1.00, can't → can). Instruction reshapes reasoning (GSM8K 0.65 → 0.97). Control recovers latent (telecom 0.50 → 0.75, a crutch). Same frozen model throughout.</a:t>
+            </a:r>
+          </a:p>
+        </p:txBody>
+      </p:sp>
+    </p:spTree>
+  </p:cSld>
+  <p:clrMapOvr>
+    <a:masterClrMapping/>
+  </p:clrMapOvr>
+</p:sld>
+</file>
+
+<file path=ppt/slides/slide28.xml><?xml version="1.0" encoding="utf-8"?>
+<p:sld xmlns:a="http://schemas.openxmlformats.org/drawingml/2006/main" xmlns:p="http://schemas.openxmlformats.org/presentationml/2006/main" xmlns:r="http://schemas.openxmlformats.org/officeDocument/2006/relationships">
+  <p:cSld>
+    <p:bg>
+      <p:bgPr>
+        <a:solidFill>
+          <a:srgbClr val="F7F7FB"/>
+        </a:solidFill>
+        <a:effectLst/>
+      </p:bgPr>
+    </p:bg>
+    <p:spTree>
+      <p:nvGrpSpPr>
+        <p:cNvPr id="1" name=""/>
+        <p:cNvGrpSpPr/>
+        <p:nvPr/>
+      </p:nvGrpSpPr>
+      <p:grpSpPr/>
+      <p:sp>
+        <p:nvSpPr>
+          <p:cNvPr id="2" name="TextBox 1"/>
+          <p:cNvSpPr txBox="1"/>
+          <p:nvPr/>
+        </p:nvSpPr>
+        <p:spPr>
+          <a:xfrm>
+            <a:off x="822960" y="640080"/>
+            <a:ext cx="10515600" cy="1188720"/>
+          </a:xfrm>
+          <a:prstGeom prst="rect">
+            <a:avLst/>
+          </a:prstGeom>
+          <a:noFill/>
+        </p:spPr>
+        <p:txBody>
+          <a:bodyPr wrap="square">
+            <a:spAutoFit/>
+          </a:bodyPr>
+          <a:lstStyle/>
+          <a:p>
+            <a:pPr algn="l">
+              <a:spcAft>
+                <a:spcPts val="800"/>
+              </a:spcAft>
+            </a:pPr>
+            <a:r>
+              <a:rPr sz="3400" b="1" i="0">
+                <a:solidFill>
+                  <a:srgbClr val="141824"/>
+                </a:solidFill>
+                <a:latin typeface="Arial"/>
+              </a:rPr>
+              <a:t>The Action lever — genuine capability (can't → can)</a:t>
+            </a:r>
+          </a:p>
+        </p:txBody>
+      </p:sp>
+      <p:sp>
+        <p:nvSpPr>
+          <p:cNvPr id="3" name="TextBox 2"/>
+          <p:cNvSpPr txBox="1"/>
+          <p:nvPr/>
+        </p:nvSpPr>
+        <p:spPr>
+          <a:xfrm>
+            <a:off x="868680" y="2148840"/>
+            <a:ext cx="10424160" cy="4297680"/>
+          </a:xfrm>
+          <a:prstGeom prst="rect">
+            <a:avLst/>
+          </a:prstGeom>
+          <a:noFill/>
+        </p:spPr>
+        <p:txBody>
+          <a:bodyPr wrap="square">
+            <a:spAutoFit/>
+          </a:bodyPr>
+          <a:lstStyle/>
+          <a:p>
+            <a:pPr algn="l">
+              <a:spcAft>
+                <a:spcPts val="600"/>
+              </a:spcAft>
+            </a:pPr>
+            <a:r>
+              <a:rPr sz="2000" b="1" i="0">
+                <a:solidFill>
+                  <a:srgbClr val="141824"/>
+                </a:solidFill>
+                <a:latin typeface="Arial"/>
+              </a:rPr>
+              <a:t>A frozen model CANNOT know your private data — it's not in the weights.</a:t>
+            </a:r>
+          </a:p>
+          <a:p>
+            <a:pPr algn="l">
+              <a:spcAft>
+                <a:spcPts val="1000"/>
+              </a:spcAft>
+            </a:pPr>
+            <a:r>
+              <a:rPr sz="1800" b="0" i="0">
+                <a:solidFill>
+                  <a:srgbClr val="141824"/>
+                </a:solidFill>
+                <a:latin typeface="Arial"/>
+              </a:rPr>
+              <a:t>•  Vanilla on a private company KB: 0/12 — every fact hallucinated (Sentinel Arm → $12,500, not $8,450).</a:t>
+            </a:r>
+          </a:p>
+          <a:p>
+            <a:pPr algn="l">
+              <a:spcAft>
+                <a:spcPts val="1000"/>
+              </a:spcAft>
+            </a:pPr>
+            <a:r>
+              <a:rPr sz="1800" b="0" i="0">
+                <a:solidFill>
+                  <a:srgbClr val="141824"/>
+                </a:solidFill>
+                <a:latin typeface="Arial"/>
+              </a:rPr>
+              <a:t>•  Add a kb_search tool (Action lever): 12/12 — it retrieves the fact and answers.</a:t>
+            </a:r>
+          </a:p>
+          <a:p>
+            <a:pPr algn="l">
+              <a:spcAft>
+                <a:spcPts val="600"/>
+              </a:spcAft>
+            </a:pPr>
+            <a:r>
+              <a:rPr sz="2000" b="1" i="0">
+                <a:solidFill>
+                  <a:srgbClr val="141824"/>
+                </a:solidFill>
+                <a:latin typeface="Arial"/>
+              </a:rPr>
+              <a:t>That's NEW capability, not a crutch — and it's the whole reason vertical agents exist:</a:t>
+            </a:r>
+          </a:p>
+          <a:p>
+            <a:pPr algn="l">
+              <a:spcAft>
+                <a:spcPts val="1000"/>
+              </a:spcAft>
+            </a:pPr>
+            <a:r>
+              <a:rPr sz="1800" b="0" i="0">
+                <a:solidFill>
+                  <a:srgbClr val="141824"/>
+                </a:solidFill>
+                <a:latin typeface="Arial"/>
+              </a:rPr>
+              <a:t>•  proprietary knowledge, tools, and APIs the base model will never have.</a:t>
+            </a:r>
+          </a:p>
+        </p:txBody>
+      </p:sp>
+    </p:spTree>
+  </p:cSld>
+  <p:clrMapOvr>
+    <a:masterClrMapping/>
+  </p:clrMapOvr>
+</p:sld>
+</file>
+
+<file path=ppt/slides/slide29.xml><?xml version="1.0" encoding="utf-8"?>
 <p:sld xmlns:a="http://schemas.openxmlformats.org/drawingml/2006/main" xmlns:p="http://schemas.openxmlformats.org/presentationml/2006/main" xmlns:r="http://schemas.openxmlformats.org/officeDocument/2006/relationships">
   <p:cSld>
     <p:bg>

</xml_diff>

<commit_message>
workshop: reframe on the closed loop — evolve from traces (the point, not the technique)
Add deck slide 'The technique is basic. The closed LOOP is the point' + lead
takeaway on the run->read-trace->pick-lever->re-run cycle; every lever we pulled
was chosen FROM a trace. HANDS-ON: add the Action-lever (kb_search) step so
attendees build their own tool and drive the loop end to end.

Co-Authored-By: Claude Opus 4.8 (1M context) <noreply@anthropic.com>
</commit_message>
<xml_diff>
--- a/workshop/harness-evolution-workshop.pptx
+++ b/workshop/harness-evolution-workshop.pptx
@@ -34,6 +34,7 @@
     <p:sldId id="282" r:id="rId33"/>
     <p:sldId id="283" r:id="rId34"/>
     <p:sldId id="284" r:id="rId35"/>
+    <p:sldId id="285" r:id="rId36"/>
   </p:sldIdLst>
   <p:sldSz cx="12191695" cy="6858000" type="screen4x3"/>
   <p:notesSz cx="6858000" cy="9144000"/>
@@ -5046,7 +5047,7 @@
                 </a:solidFill>
                 <a:latin typeface="Arial"/>
               </a:rPr>
-              <a:t>Harness evolution IS reinforcement learning</a:t>
+              <a:t>The technique is basic. The closed LOOP is the point.</a:t>
             </a:r>
           </a:p>
         </p:txBody>
@@ -5085,7 +5086,7 @@
                 </a:solidFill>
                 <a:latin typeface="Arial"/>
               </a:rPr>
-              <a:t>The “operational mirror” — with the model FROZEN:</a:t>
+              <a:t>Reflect, tools, retries, policy hints — all well-known. We're NOT teaching those.</a:t>
             </a:r>
           </a:p>
           <a:p>
@@ -5101,7 +5102,7 @@
                 </a:solidFill>
                 <a:latin typeface="Arial"/>
               </a:rPr>
-              <a:t>•  State = the HarnessConfig   ·   Action = pull one of the 4 levers</a:t>
+              <a:t>•  The skill is the loop: run → READ THE TRACE → the trace names the failure → pick the matching</a:t>
             </a:r>
           </a:p>
           <a:p>
@@ -5117,7 +5118,23 @@
                 </a:solidFill>
                 <a:latin typeface="Arial"/>
               </a:rPr>
-              <a:t>•  Policy = a stronger model reading the traces (that's Claude Code)</a:t>
+              <a:t>•  lever → evolve → re-run → new trace → repeat. Driven by evidence, not guesswork.</a:t>
+            </a:r>
+          </a:p>
+          <a:p>
+            <a:pPr algn="l">
+              <a:spcAft>
+                <a:spcPts val="600"/>
+              </a:spcAft>
+            </a:pPr>
+            <a:r>
+              <a:rPr sz="2000" b="1" i="0">
+                <a:solidFill>
+                  <a:srgbClr val="141824"/>
+                </a:solidFill>
+                <a:latin typeface="Arial"/>
+              </a:rPr>
+              <a:t>Every lever we pulled was chosen FROM a trace:</a:t>
             </a:r>
           </a:p>
           <a:p>
@@ -5133,23 +5150,23 @@
                 </a:solidFill>
                 <a:latin typeface="Arial"/>
               </a:rPr>
-              <a:t>•  Reward = the benchmark score   ·   Rollout = re-run the task set   ·   Gate = keep if reward↑</a:t>
-            </a:r>
-          </a:p>
-          <a:p>
-            <a:pPr algn="l">
-              <a:spcAft>
-                <a:spcPts val="600"/>
-              </a:spcAft>
-            </a:pPr>
-            <a:r>
-              <a:rPr sz="2000" b="1" i="0">
-                <a:solidFill>
-                  <a:srgbClr val="141824"/>
-                </a:solidFill>
-                <a:latin typeface="Arial"/>
-              </a:rPr>
-              <a:t>Agentic RL = use a stronger model to read traces, pick the lever, re-run, keep what improves.</a:t>
+              <a:t>•  telecom trace 'never called enable_roaming' → IRMA (0.50→0.75)</a:t>
+            </a:r>
+          </a:p>
+          <a:p>
+            <a:pPr algn="l">
+              <a:spcAft>
+                <a:spcPts val="1000"/>
+              </a:spcAft>
+            </a:pPr>
+            <a:r>
+              <a:rPr sz="1800" b="0" i="0">
+                <a:solidFill>
+                  <a:srgbClr val="141824"/>
+                </a:solidFill>
+                <a:latin typeface="Arial"/>
+              </a:rPr>
+              <a:t>•  GSM8K trace 'fast, wrong' → reflect (0.65→0.97) · KB trace 'hallucinated facts, no tool call' → kb_search (0→1.0)</a:t>
             </a:r>
           </a:p>
         </p:txBody>
@@ -5188,8 +5205,8 @@
         </p:nvSpPr>
         <p:spPr>
           <a:xfrm>
-            <a:off x="822960" y="502920"/>
-            <a:ext cx="10515600" cy="914400"/>
+            <a:off x="822960" y="640080"/>
+            <a:ext cx="10515600" cy="1188720"/>
           </a:xfrm>
           <a:prstGeom prst="rect">
             <a:avLst/>
@@ -5208,51 +5225,27 @@
               </a:spcAft>
             </a:pPr>
             <a:r>
-              <a:rPr sz="3000" b="1" i="0">
-                <a:solidFill>
-                  <a:srgbClr val="141824"/>
-                </a:solidFill>
-                <a:latin typeface="Arial"/>
-              </a:rPr>
-              <a:t>Which lever moved the number</a:t>
-            </a:r>
-          </a:p>
-        </p:txBody>
-      </p:sp>
-      <p:pic>
-        <p:nvPicPr>
-          <p:cNvPr id="3" name="Picture 2" descr="lever-result-chart.png"/>
-          <p:cNvPicPr>
-            <a:picLocks noChangeAspect="1"/>
-          </p:cNvPicPr>
-          <p:nvPr/>
-        </p:nvPicPr>
-        <p:blipFill>
-          <a:blip r:embed="rId2"/>
-          <a:stretch>
-            <a:fillRect/>
-          </a:stretch>
-        </p:blipFill>
-        <p:spPr>
-          <a:xfrm>
-            <a:off x="1249527" y="1737360"/>
-            <a:ext cx="9692640" cy="3673000"/>
-          </a:xfrm>
-          <a:prstGeom prst="rect">
-            <a:avLst/>
-          </a:prstGeom>
-        </p:spPr>
-      </p:pic>
-      <p:sp>
-        <p:nvSpPr>
-          <p:cNvPr id="4" name="TextBox 3"/>
+              <a:rPr sz="3400" b="1" i="0">
+                <a:solidFill>
+                  <a:srgbClr val="141824"/>
+                </a:solidFill>
+                <a:latin typeface="Arial"/>
+              </a:rPr>
+              <a:t>Harness evolution IS reinforcement learning</a:t>
+            </a:r>
+          </a:p>
+        </p:txBody>
+      </p:sp>
+      <p:sp>
+        <p:nvSpPr>
+          <p:cNvPr id="3" name="TextBox 2"/>
           <p:cNvSpPr txBox="1"/>
           <p:nvPr/>
         </p:nvSpPr>
         <p:spPr>
           <a:xfrm>
-            <a:off x="822960" y="6126480"/>
-            <a:ext cx="10515600" cy="548640"/>
+            <a:off x="868680" y="2148840"/>
+            <a:ext cx="10424160" cy="4297680"/>
           </a:xfrm>
           <a:prstGeom prst="rect">
             <a:avLst/>
@@ -5265,19 +5258,83 @@
           </a:bodyPr>
           <a:lstStyle/>
           <a:p>
-            <a:pPr algn="ctr">
-              <a:spcAft>
-                <a:spcPts val="800"/>
-              </a:spcAft>
-            </a:pPr>
-            <a:r>
-              <a:rPr sz="1300" b="0" i="0">
-                <a:solidFill>
-                  <a:srgbClr val="666C7A"/>
-                </a:solidFill>
-                <a:latin typeface="Arial"/>
-              </a:rPr>
-              <a:t>Same frozen model. The lever lifts the score only when the benchmark gives a signal AND the failure matches the lever.</a:t>
+            <a:pPr algn="l">
+              <a:spcAft>
+                <a:spcPts val="600"/>
+              </a:spcAft>
+            </a:pPr>
+            <a:r>
+              <a:rPr sz="2000" b="1" i="0">
+                <a:solidFill>
+                  <a:srgbClr val="141824"/>
+                </a:solidFill>
+                <a:latin typeface="Arial"/>
+              </a:rPr>
+              <a:t>The “operational mirror” — with the model FROZEN:</a:t>
+            </a:r>
+          </a:p>
+          <a:p>
+            <a:pPr algn="l">
+              <a:spcAft>
+                <a:spcPts val="1000"/>
+              </a:spcAft>
+            </a:pPr>
+            <a:r>
+              <a:rPr sz="1800" b="0" i="0">
+                <a:solidFill>
+                  <a:srgbClr val="141824"/>
+                </a:solidFill>
+                <a:latin typeface="Arial"/>
+              </a:rPr>
+              <a:t>•  State = the HarnessConfig   ·   Action = pull one of the 4 levers</a:t>
+            </a:r>
+          </a:p>
+          <a:p>
+            <a:pPr algn="l">
+              <a:spcAft>
+                <a:spcPts val="1000"/>
+              </a:spcAft>
+            </a:pPr>
+            <a:r>
+              <a:rPr sz="1800" b="0" i="0">
+                <a:solidFill>
+                  <a:srgbClr val="141824"/>
+                </a:solidFill>
+                <a:latin typeface="Arial"/>
+              </a:rPr>
+              <a:t>•  Policy = a stronger model reading the traces (that's Claude Code)</a:t>
+            </a:r>
+          </a:p>
+          <a:p>
+            <a:pPr algn="l">
+              <a:spcAft>
+                <a:spcPts val="1000"/>
+              </a:spcAft>
+            </a:pPr>
+            <a:r>
+              <a:rPr sz="1800" b="0" i="0">
+                <a:solidFill>
+                  <a:srgbClr val="141824"/>
+                </a:solidFill>
+                <a:latin typeface="Arial"/>
+              </a:rPr>
+              <a:t>•  Reward = the benchmark score   ·   Rollout = re-run the task set   ·   Gate = keep if reward↑</a:t>
+            </a:r>
+          </a:p>
+          <a:p>
+            <a:pPr algn="l">
+              <a:spcAft>
+                <a:spcPts val="600"/>
+              </a:spcAft>
+            </a:pPr>
+            <a:r>
+              <a:rPr sz="2000" b="1" i="0">
+                <a:solidFill>
+                  <a:srgbClr val="141824"/>
+                </a:solidFill>
+                <a:latin typeface="Arial"/>
+              </a:rPr>
+              <a:t>Agentic RL = use a stronger model to read traces, pick the lever, re-run, keep what improves.</a:t>
             </a:r>
           </a:p>
         </p:txBody>
@@ -5316,8 +5373,8 @@
         </p:nvSpPr>
         <p:spPr>
           <a:xfrm>
-            <a:off x="822960" y="640080"/>
-            <a:ext cx="10515600" cy="1188720"/>
+            <a:off x="822960" y="502920"/>
+            <a:ext cx="10515600" cy="914400"/>
           </a:xfrm>
           <a:prstGeom prst="rect">
             <a:avLst/>
@@ -5336,27 +5393,51 @@
               </a:spcAft>
             </a:pPr>
             <a:r>
-              <a:rPr sz="3400" b="1" i="0">
-                <a:solidFill>
-                  <a:srgbClr val="141824"/>
-                </a:solidFill>
-                <a:latin typeface="Arial"/>
-              </a:rPr>
-              <a:t>Which component makes the biggest difference?</a:t>
-            </a:r>
-          </a:p>
-        </p:txBody>
-      </p:sp>
-      <p:sp>
-        <p:nvSpPr>
-          <p:cNvPr id="3" name="TextBox 2"/>
+              <a:rPr sz="3000" b="1" i="0">
+                <a:solidFill>
+                  <a:srgbClr val="141824"/>
+                </a:solidFill>
+                <a:latin typeface="Arial"/>
+              </a:rPr>
+              <a:t>Which lever moved the number</a:t>
+            </a:r>
+          </a:p>
+        </p:txBody>
+      </p:sp>
+      <p:pic>
+        <p:nvPicPr>
+          <p:cNvPr id="3" name="Picture 2" descr="lever-result-chart.png"/>
+          <p:cNvPicPr>
+            <a:picLocks noChangeAspect="1"/>
+          </p:cNvPicPr>
+          <p:nvPr/>
+        </p:nvPicPr>
+        <p:blipFill>
+          <a:blip r:embed="rId2"/>
+          <a:stretch>
+            <a:fillRect/>
+          </a:stretch>
+        </p:blipFill>
+        <p:spPr>
+          <a:xfrm>
+            <a:off x="1249527" y="1737360"/>
+            <a:ext cx="9692640" cy="3673000"/>
+          </a:xfrm>
+          <a:prstGeom prst="rect">
+            <a:avLst/>
+          </a:prstGeom>
+        </p:spPr>
+      </p:pic>
+      <p:sp>
+        <p:nvSpPr>
+          <p:cNvPr id="4" name="TextBox 3"/>
           <p:cNvSpPr txBox="1"/>
           <p:nvPr/>
         </p:nvSpPr>
         <p:spPr>
           <a:xfrm>
-            <a:off x="868680" y="2148840"/>
-            <a:ext cx="10424160" cy="4297680"/>
+            <a:off x="822960" y="6126480"/>
+            <a:ext cx="10515600" cy="548640"/>
           </a:xfrm>
           <a:prstGeom prst="rect">
             <a:avLst/>
@@ -5369,99 +5450,19 @@
           </a:bodyPr>
           <a:lstStyle/>
           <a:p>
-            <a:pPr algn="l">
-              <a:spcAft>
-                <a:spcPts val="600"/>
-              </a:spcAft>
-            </a:pPr>
-            <a:r>
-              <a:rPr sz="2000" b="1" i="0">
-                <a:solidFill>
-                  <a:srgbClr val="141824"/>
-                </a:solidFill>
-                <a:latin typeface="Arial"/>
-              </a:rPr>
-              <a:t>Ablation: run vanilla / control-only / IRMA-only / full on the SAME tasks.</a:t>
-            </a:r>
-          </a:p>
-          <a:p>
-            <a:pPr algn="l">
-              <a:spcAft>
-                <a:spcPts val="1000"/>
-              </a:spcAft>
-            </a:pPr>
-            <a:r>
-              <a:rPr sz="1800" b="0" i="0">
-                <a:solidFill>
-                  <a:srgbClr val="141824"/>
-                </a:solidFill>
-                <a:latin typeface="Arial"/>
-              </a:rPr>
-              <a:t>•  Single-trial trap: variance (±0.25) is as big as the effect — the same config scores 0.50 OR 0.75 by luck.</a:t>
-            </a:r>
-          </a:p>
-          <a:p>
-            <a:pPr algn="l">
-              <a:spcAft>
-                <a:spcPts val="1000"/>
-              </a:spcAft>
-            </a:pPr>
-            <a:r>
-              <a:rPr sz="1800" b="0" i="0">
-                <a:solidFill>
-                  <a:srgbClr val="141824"/>
-                </a:solidFill>
-                <a:latin typeface="Arial"/>
-              </a:rPr>
-              <a:t>•  So you CANNOT rank components from one run. Attribution is statistical, not anecdotal.</a:t>
-            </a:r>
-          </a:p>
-          <a:p>
-            <a:pPr algn="l">
-              <a:spcAft>
-                <a:spcPts val="1000"/>
-              </a:spcAft>
-            </a:pPr>
-            <a:r>
-              <a:rPr sz="1800" b="0" i="0">
-                <a:solidFill>
-                  <a:srgbClr val="141824"/>
-                </a:solidFill>
-                <a:latin typeface="Arial"/>
-              </a:rPr>
-              <a:t>•  Fix: multiple trials (pass^k) + task-level check + leave-one-out to kill inert processors.</a:t>
-            </a:r>
-          </a:p>
-          <a:p>
-            <a:pPr algn="l">
-              <a:spcAft>
-                <a:spcPts val="600"/>
-              </a:spcAft>
-            </a:pPr>
-            <a:r>
-              <a:rPr sz="2000" b="1" i="0">
-                <a:solidFill>
-                  <a:srgbClr val="141824"/>
-                </a:solidFill>
-                <a:latin typeface="Arial"/>
-              </a:rPr>
-              <a:t>Task-level signal: IRMA's roaming alert rescues the roaming task; control processors are inert here.</a:t>
-            </a:r>
-          </a:p>
-          <a:p>
-            <a:pPr algn="l">
-              <a:spcAft>
-                <a:spcPts val="1000"/>
-              </a:spcAft>
-            </a:pPr>
-            <a:r>
-              <a:rPr sz="1800" b="0" i="0">
-                <a:solidFill>
-                  <a:srgbClr val="141824"/>
-                </a:solidFill>
-                <a:latin typeface="Arial"/>
-              </a:rPr>
-              <a:t>•  Reproducible in one command:  bash workshop/ablate.sh</a:t>
+            <a:pPr algn="ctr">
+              <a:spcAft>
+                <a:spcPts val="800"/>
+              </a:spcAft>
+            </a:pPr>
+            <a:r>
+              <a:rPr sz="1300" b="0" i="0">
+                <a:solidFill>
+                  <a:srgbClr val="666C7A"/>
+                </a:solidFill>
+                <a:latin typeface="Arial"/>
+              </a:rPr>
+              <a:t>Same frozen model. The lever lifts the score only when the benchmark gives a signal AND the failure matches the lever.</a:t>
             </a:r>
           </a:p>
         </p:txBody>
@@ -5500,8 +5501,8 @@
         </p:nvSpPr>
         <p:spPr>
           <a:xfrm>
-            <a:off x="822960" y="502920"/>
-            <a:ext cx="10515600" cy="914400"/>
+            <a:off x="822960" y="640080"/>
+            <a:ext cx="10515600" cy="1188720"/>
           </a:xfrm>
           <a:prstGeom prst="rect">
             <a:avLst/>
@@ -5520,51 +5521,27 @@
               </a:spcAft>
             </a:pPr>
             <a:r>
-              <a:rPr sz="3000" b="1" i="0">
-                <a:solidFill>
-                  <a:srgbClr val="141824"/>
-                </a:solidFill>
-                <a:latin typeface="Arial"/>
-              </a:rPr>
-              <a:t>Attribution (3 trials): one component did the work</a:t>
-            </a:r>
-          </a:p>
-        </p:txBody>
-      </p:sp>
-      <p:pic>
-        <p:nvPicPr>
-          <p:cNvPr id="3" name="Picture 2" descr="attribution-chart.png"/>
-          <p:cNvPicPr>
-            <a:picLocks noChangeAspect="1"/>
-          </p:cNvPicPr>
-          <p:nvPr/>
-        </p:nvPicPr>
-        <p:blipFill>
-          <a:blip r:embed="rId2"/>
-          <a:stretch>
-            <a:fillRect/>
-          </a:stretch>
-        </p:blipFill>
-        <p:spPr>
-          <a:xfrm>
-            <a:off x="1249527" y="1737360"/>
-            <a:ext cx="9692640" cy="3264889"/>
-          </a:xfrm>
-          <a:prstGeom prst="rect">
-            <a:avLst/>
-          </a:prstGeom>
-        </p:spPr>
-      </p:pic>
-      <p:sp>
-        <p:nvSpPr>
-          <p:cNvPr id="4" name="TextBox 3"/>
+              <a:rPr sz="3400" b="1" i="0">
+                <a:solidFill>
+                  <a:srgbClr val="141824"/>
+                </a:solidFill>
+                <a:latin typeface="Arial"/>
+              </a:rPr>
+              <a:t>Which component makes the biggest difference?</a:t>
+            </a:r>
+          </a:p>
+        </p:txBody>
+      </p:sp>
+      <p:sp>
+        <p:nvSpPr>
+          <p:cNvPr id="3" name="TextBox 2"/>
           <p:cNvSpPr txBox="1"/>
           <p:nvPr/>
         </p:nvSpPr>
         <p:spPr>
           <a:xfrm>
-            <a:off x="822960" y="6126480"/>
-            <a:ext cx="10515600" cy="548640"/>
+            <a:off x="868680" y="2148840"/>
+            <a:ext cx="10424160" cy="4297680"/>
           </a:xfrm>
           <a:prstGeom prst="rect">
             <a:avLst/>
@@ -5577,19 +5554,99 @@
           </a:bodyPr>
           <a:lstStyle/>
           <a:p>
-            <a:pPr algn="ctr">
-              <a:spcAft>
-                <a:spcPts val="800"/>
-              </a:spcAft>
-            </a:pPr>
-            <a:r>
-              <a:rPr sz="1300" b="0" i="0">
-                <a:solidFill>
-                  <a:srgbClr val="666C7A"/>
-                </a:solidFill>
-                <a:latin typeface="Arial"/>
-              </a:rPr>
-              <a:t>Multi-trial averaging clears the noise: IRMA (+0.167) drives the lift; the 5 control processors are inert (−0.083). Leave-one-out would drop them.</a:t>
+            <a:pPr algn="l">
+              <a:spcAft>
+                <a:spcPts val="600"/>
+              </a:spcAft>
+            </a:pPr>
+            <a:r>
+              <a:rPr sz="2000" b="1" i="0">
+                <a:solidFill>
+                  <a:srgbClr val="141824"/>
+                </a:solidFill>
+                <a:latin typeface="Arial"/>
+              </a:rPr>
+              <a:t>Ablation: run vanilla / control-only / IRMA-only / full on the SAME tasks.</a:t>
+            </a:r>
+          </a:p>
+          <a:p>
+            <a:pPr algn="l">
+              <a:spcAft>
+                <a:spcPts val="1000"/>
+              </a:spcAft>
+            </a:pPr>
+            <a:r>
+              <a:rPr sz="1800" b="0" i="0">
+                <a:solidFill>
+                  <a:srgbClr val="141824"/>
+                </a:solidFill>
+                <a:latin typeface="Arial"/>
+              </a:rPr>
+              <a:t>•  Single-trial trap: variance (±0.25) is as big as the effect — the same config scores 0.50 OR 0.75 by luck.</a:t>
+            </a:r>
+          </a:p>
+          <a:p>
+            <a:pPr algn="l">
+              <a:spcAft>
+                <a:spcPts val="1000"/>
+              </a:spcAft>
+            </a:pPr>
+            <a:r>
+              <a:rPr sz="1800" b="0" i="0">
+                <a:solidFill>
+                  <a:srgbClr val="141824"/>
+                </a:solidFill>
+                <a:latin typeface="Arial"/>
+              </a:rPr>
+              <a:t>•  So you CANNOT rank components from one run. Attribution is statistical, not anecdotal.</a:t>
+            </a:r>
+          </a:p>
+          <a:p>
+            <a:pPr algn="l">
+              <a:spcAft>
+                <a:spcPts val="1000"/>
+              </a:spcAft>
+            </a:pPr>
+            <a:r>
+              <a:rPr sz="1800" b="0" i="0">
+                <a:solidFill>
+                  <a:srgbClr val="141824"/>
+                </a:solidFill>
+                <a:latin typeface="Arial"/>
+              </a:rPr>
+              <a:t>•  Fix: multiple trials (pass^k) + task-level check + leave-one-out to kill inert processors.</a:t>
+            </a:r>
+          </a:p>
+          <a:p>
+            <a:pPr algn="l">
+              <a:spcAft>
+                <a:spcPts val="600"/>
+              </a:spcAft>
+            </a:pPr>
+            <a:r>
+              <a:rPr sz="2000" b="1" i="0">
+                <a:solidFill>
+                  <a:srgbClr val="141824"/>
+                </a:solidFill>
+                <a:latin typeface="Arial"/>
+              </a:rPr>
+              <a:t>Task-level signal: IRMA's roaming alert rescues the roaming task; control processors are inert here.</a:t>
+            </a:r>
+          </a:p>
+          <a:p>
+            <a:pPr algn="l">
+              <a:spcAft>
+                <a:spcPts val="1000"/>
+              </a:spcAft>
+            </a:pPr>
+            <a:r>
+              <a:rPr sz="1800" b="0" i="0">
+                <a:solidFill>
+                  <a:srgbClr val="141824"/>
+                </a:solidFill>
+                <a:latin typeface="Arial"/>
+              </a:rPr>
+              <a:t>•  Reproducible in one command:  bash workshop/ablate.sh</a:t>
             </a:r>
           </a:p>
         </p:txBody>
@@ -5628,8 +5685,8 @@
         </p:nvSpPr>
         <p:spPr>
           <a:xfrm>
-            <a:off x="822960" y="640080"/>
-            <a:ext cx="10515600" cy="1188720"/>
+            <a:off x="822960" y="502920"/>
+            <a:ext cx="10515600" cy="914400"/>
           </a:xfrm>
           <a:prstGeom prst="rect">
             <a:avLst/>
@@ -5648,27 +5705,51 @@
               </a:spcAft>
             </a:pPr>
             <a:r>
-              <a:rPr sz="3400" b="1" i="0">
-                <a:solidFill>
-                  <a:srgbClr val="141824"/>
-                </a:solidFill>
-                <a:latin typeface="Arial"/>
-              </a:rPr>
-              <a:t>Did we prove the paper? (partly — yes)</a:t>
-            </a:r>
-          </a:p>
-        </p:txBody>
-      </p:sp>
-      <p:sp>
-        <p:nvSpPr>
-          <p:cNvPr id="3" name="TextBox 2"/>
+              <a:rPr sz="3000" b="1" i="0">
+                <a:solidFill>
+                  <a:srgbClr val="141824"/>
+                </a:solidFill>
+                <a:latin typeface="Arial"/>
+              </a:rPr>
+              <a:t>Attribution (3 trials): one component did the work</a:t>
+            </a:r>
+          </a:p>
+        </p:txBody>
+      </p:sp>
+      <p:pic>
+        <p:nvPicPr>
+          <p:cNvPr id="3" name="Picture 2" descr="attribution-chart.png"/>
+          <p:cNvPicPr>
+            <a:picLocks noChangeAspect="1"/>
+          </p:cNvPicPr>
+          <p:nvPr/>
+        </p:nvPicPr>
+        <p:blipFill>
+          <a:blip r:embed="rId2"/>
+          <a:stretch>
+            <a:fillRect/>
+          </a:stretch>
+        </p:blipFill>
+        <p:spPr>
+          <a:xfrm>
+            <a:off x="1249527" y="1737360"/>
+            <a:ext cx="9692640" cy="3264889"/>
+          </a:xfrm>
+          <a:prstGeom prst="rect">
+            <a:avLst/>
+          </a:prstGeom>
+        </p:spPr>
+      </p:pic>
+      <p:sp>
+        <p:nvSpPr>
+          <p:cNvPr id="4" name="TextBox 3"/>
           <p:cNvSpPr txBox="1"/>
           <p:nvPr/>
         </p:nvSpPr>
         <p:spPr>
           <a:xfrm>
-            <a:off x="868680" y="2148840"/>
-            <a:ext cx="10424160" cy="4297680"/>
+            <a:off x="822960" y="6126480"/>
+            <a:ext cx="10515600" cy="548640"/>
           </a:xfrm>
           <a:prstGeom prst="rect">
             <a:avLst/>
@@ -5681,83 +5762,19 @@
           </a:bodyPr>
           <a:lstStyle/>
           <a:p>
-            <a:pPr algn="l">
-              <a:spcAft>
-                <a:spcPts val="1000"/>
-              </a:spcAft>
-            </a:pPr>
-            <a:r>
-              <a:rPr sz="1800" b="0" i="0">
-                <a:solidFill>
-                  <a:srgbClr val="141824"/>
-                </a:solidFill>
-                <a:latin typeface="Arial"/>
-              </a:rPr>
-              <a:t>•  ✓ A FROZEN model's benchmark score rose via a harness edit alone (telecom 0.50 → 0.75).</a:t>
-            </a:r>
-          </a:p>
-          <a:p>
-            <a:pPr algn="l">
-              <a:spcAft>
-                <a:spcPts val="1000"/>
-              </a:spcAft>
-            </a:pPr>
-            <a:r>
-              <a:rPr sz="1800" b="0" i="0">
-                <a:solidFill>
-                  <a:srgbClr val="141824"/>
-                </a:solidFill>
-                <a:latin typeface="Arial"/>
-              </a:rPr>
-              <a:t>•  ✓ The moat is the infrastructure — we diagnosed + evolved purely off typed processors + structured traces.</a:t>
-            </a:r>
-          </a:p>
-          <a:p>
-            <a:pPr algn="l">
-              <a:spcAft>
-                <a:spcPts val="1000"/>
-              </a:spcAft>
-            </a:pPr>
-            <a:r>
-              <a:rPr sz="1800" b="0" i="0">
-                <a:solidFill>
-                  <a:srgbClr val="141824"/>
-                </a:solidFill>
-                <a:latin typeface="Arial"/>
-              </a:rPr>
-              <a:t>•  ✓ Lever mix is context-dependent — IRMA worked on telecom, did nothing on retail (grading mismatch).</a:t>
-            </a:r>
-          </a:p>
-          <a:p>
-            <a:pPr algn="l">
-              <a:spcAft>
-                <a:spcPts val="1000"/>
-              </a:spcAft>
-            </a:pPr>
-            <a:r>
-              <a:rPr sz="1800" b="0" i="0">
-                <a:solidFill>
-                  <a:srgbClr val="141824"/>
-                </a:solidFill>
-                <a:latin typeface="Arial"/>
-              </a:rPr>
-              <a:t>•  ✓ Ceiling/floor effects — 32B at ceiling on easy tasks; strict retail grading = effective floor.</a:t>
-            </a:r>
-          </a:p>
-          <a:p>
-            <a:pPr algn="l">
-              <a:spcAft>
-                <a:spcPts val="600"/>
-              </a:spcAft>
-            </a:pPr>
-            <a:r>
-              <a:rPr sz="2000" b="1" i="0">
-                <a:solidFill>
-                  <a:srgbClr val="141824"/>
-                </a:solidFill>
-                <a:latin typeface="Arial"/>
-              </a:rPr>
-              <a:t>Not reproduced (needs scale): +14.5% magnitudes, multi-round + the 3 RL pathologies, AEGIS, co-evolution.</a:t>
+            <a:pPr algn="ctr">
+              <a:spcAft>
+                <a:spcPts val="800"/>
+              </a:spcAft>
+            </a:pPr>
+            <a:r>
+              <a:rPr sz="1300" b="0" i="0">
+                <a:solidFill>
+                  <a:srgbClr val="666C7A"/>
+                </a:solidFill>
+                <a:latin typeface="Arial"/>
+              </a:rPr>
+              <a:t>Multi-trial averaging clears the noise: IRMA (+0.167) drives the lift; the 5 control processors are inert (−0.083). Leave-one-out would drop them.</a:t>
             </a:r>
           </a:p>
         </p:txBody>
@@ -5822,7 +5839,7 @@
                 </a:solidFill>
                 <a:latin typeface="Arial"/>
               </a:rPr>
-              <a:t>Crutch or capability? Two value props</a:t>
+              <a:t>Did we prove the paper? (partly — yes)</a:t>
             </a:r>
           </a:p>
         </p:txBody>
@@ -5861,7 +5878,7 @@
                 </a:solidFill>
                 <a:latin typeface="Arial"/>
               </a:rPr>
-              <a:t>•  Deterministic Control fixes (roaming alert, ParseRetry) are a CRUTCH — they recover latent</a:t>
+              <a:t>•  ✓ A FROZEN model's benchmark score rose via a harness edit alone (telecom 0.50 → 0.75).</a:t>
             </a:r>
           </a:p>
           <a:p>
@@ -5877,7 +5894,39 @@
                 </a:solidFill>
                 <a:latin typeface="Arial"/>
               </a:rPr>
-              <a:t>•  capability a frozen model failed to apply. Real, but capped at the model's ceiling.</a:t>
+              <a:t>•  ✓ The moat is the infrastructure — we diagnosed + evolved purely off typed processors + structured traces.</a:t>
+            </a:r>
+          </a:p>
+          <a:p>
+            <a:pPr algn="l">
+              <a:spcAft>
+                <a:spcPts val="1000"/>
+              </a:spcAft>
+            </a:pPr>
+            <a:r>
+              <a:rPr sz="1800" b="0" i="0">
+                <a:solidFill>
+                  <a:srgbClr val="141824"/>
+                </a:solidFill>
+                <a:latin typeface="Arial"/>
+              </a:rPr>
+              <a:t>•  ✓ Lever mix is context-dependent — IRMA worked on telecom, did nothing on retail (grading mismatch).</a:t>
+            </a:r>
+          </a:p>
+          <a:p>
+            <a:pPr algn="l">
+              <a:spcAft>
+                <a:spcPts val="1000"/>
+              </a:spcAft>
+            </a:pPr>
+            <a:r>
+              <a:rPr sz="1800" b="0" i="0">
+                <a:solidFill>
+                  <a:srgbClr val="141824"/>
+                </a:solidFill>
+                <a:latin typeface="Arial"/>
+              </a:rPr>
+              <a:t>•  ✓ Ceiling/floor effects — 32B at ceiling on easy tasks; strict retail grading = effective floor.</a:t>
             </a:r>
           </a:p>
           <a:p>
@@ -5893,39 +5942,7 @@
                 </a:solidFill>
                 <a:latin typeface="Arial"/>
               </a:rPr>
-              <a:t>Instruction (reasoning scaffolds) + Action (tools/skills) ADD realized capability — not plumbing.</a:t>
-            </a:r>
-          </a:p>
-          <a:p>
-            <a:pPr algn="l">
-              <a:spcAft>
-                <a:spcPts val="1000"/>
-              </a:spcAft>
-            </a:pPr>
-            <a:r>
-              <a:rPr sz="1800" b="0" i="0">
-                <a:solidFill>
-                  <a:srgbClr val="141824"/>
-                </a:solidFill>
-                <a:latin typeface="Arial"/>
-              </a:rPr>
-              <a:t>•  To raise the ceiling itself, you need loop 2: RL on the weights (co-evolution). Different game.</a:t>
-            </a:r>
-          </a:p>
-          <a:p>
-            <a:pPr algn="l">
-              <a:spcAft>
-                <a:spcPts val="600"/>
-              </a:spcAft>
-            </a:pPr>
-            <a:r>
-              <a:rPr sz="2000" b="1" i="0">
-                <a:solidFill>
-                  <a:srgbClr val="141824"/>
-                </a:solidFill>
-                <a:latin typeface="Arial"/>
-              </a:rPr>
-              <a:t>On a frozen model, the most capability-like levers are reasoning scaffolds + new tools.</a:t>
+              <a:t>Not reproduced (needs scale): +14.5% magnitudes, multi-round + the 3 RL pathologies, AEGIS, co-evolution.</a:t>
             </a:r>
           </a:p>
         </p:txBody>
@@ -5964,8 +5981,8 @@
         </p:nvSpPr>
         <p:spPr>
           <a:xfrm>
-            <a:off x="822960" y="502920"/>
-            <a:ext cx="10515600" cy="914400"/>
+            <a:off x="822960" y="640080"/>
+            <a:ext cx="10515600" cy="1188720"/>
           </a:xfrm>
           <a:prstGeom prst="rect">
             <a:avLst/>
@@ -5984,51 +6001,27 @@
               </a:spcAft>
             </a:pPr>
             <a:r>
-              <a:rPr sz="3000" b="1" i="0">
-                <a:solidFill>
-                  <a:srgbClr val="141824"/>
-                </a:solidFill>
-                <a:latin typeface="Arial"/>
-              </a:rPr>
-              <a:t>The harness elicits latent reasoning (GSM8K)</a:t>
-            </a:r>
-          </a:p>
-        </p:txBody>
-      </p:sp>
-      <p:pic>
-        <p:nvPicPr>
-          <p:cNvPr id="3" name="Picture 2" descr="reasoning-chart.png"/>
-          <p:cNvPicPr>
-            <a:picLocks noChangeAspect="1"/>
-          </p:cNvPicPr>
-          <p:nvPr/>
-        </p:nvPicPr>
-        <p:blipFill>
-          <a:blip r:embed="rId2"/>
-          <a:stretch>
-            <a:fillRect/>
-          </a:stretch>
-        </p:blipFill>
-        <p:spPr>
-          <a:xfrm>
-            <a:off x="1249527" y="1737360"/>
-            <a:ext cx="9692640" cy="3060833"/>
-          </a:xfrm>
-          <a:prstGeom prst="rect">
-            <a:avLst/>
-          </a:prstGeom>
-        </p:spPr>
-      </p:pic>
-      <p:sp>
-        <p:nvSpPr>
-          <p:cNvPr id="4" name="TextBox 3"/>
+              <a:rPr sz="3400" b="1" i="0">
+                <a:solidFill>
+                  <a:srgbClr val="141824"/>
+                </a:solidFill>
+                <a:latin typeface="Arial"/>
+              </a:rPr>
+              <a:t>Crutch or capability? Two value props</a:t>
+            </a:r>
+          </a:p>
+        </p:txBody>
+      </p:sp>
+      <p:sp>
+        <p:nvSpPr>
+          <p:cNvPr id="3" name="TextBox 2"/>
           <p:cNvSpPr txBox="1"/>
           <p:nvPr/>
         </p:nvSpPr>
         <p:spPr>
           <a:xfrm>
-            <a:off x="822960" y="6126480"/>
-            <a:ext cx="10515600" cy="548640"/>
+            <a:off x="868680" y="2148840"/>
+            <a:ext cx="10424160" cy="4297680"/>
           </a:xfrm>
           <a:prstGeom prst="rect">
             <a:avLst/>
@@ -6041,19 +6034,83 @@
           </a:bodyPr>
           <a:lstStyle/>
           <a:p>
-            <a:pPr algn="ctr">
-              <a:spcAft>
-                <a:spcPts val="800"/>
-              </a:spcAft>
-            </a:pPr>
-            <a:r>
-              <a:rPr sz="1300" b="0" i="0">
-                <a:solidFill>
-                  <a:srgbClr val="666C7A"/>
-                </a:solidFill>
-                <a:latin typeface="Arial"/>
-              </a:rPr>
-              <a:t>Same frozen qwen3:8B. A reflect scaffold (re-derive + self-check) lifts GSM8K 0.65 → 0.97 and CRT 0.53 → 0.73. Realized reasoning, not I/O.</a:t>
+            <a:pPr algn="l">
+              <a:spcAft>
+                <a:spcPts val="1000"/>
+              </a:spcAft>
+            </a:pPr>
+            <a:r>
+              <a:rPr sz="1800" b="0" i="0">
+                <a:solidFill>
+                  <a:srgbClr val="141824"/>
+                </a:solidFill>
+                <a:latin typeface="Arial"/>
+              </a:rPr>
+              <a:t>•  Deterministic Control fixes (roaming alert, ParseRetry) are a CRUTCH — they recover latent</a:t>
+            </a:r>
+          </a:p>
+          <a:p>
+            <a:pPr algn="l">
+              <a:spcAft>
+                <a:spcPts val="1000"/>
+              </a:spcAft>
+            </a:pPr>
+            <a:r>
+              <a:rPr sz="1800" b="0" i="0">
+                <a:solidFill>
+                  <a:srgbClr val="141824"/>
+                </a:solidFill>
+                <a:latin typeface="Arial"/>
+              </a:rPr>
+              <a:t>•  capability a frozen model failed to apply. Real, but capped at the model's ceiling.</a:t>
+            </a:r>
+          </a:p>
+          <a:p>
+            <a:pPr algn="l">
+              <a:spcAft>
+                <a:spcPts val="600"/>
+              </a:spcAft>
+            </a:pPr>
+            <a:r>
+              <a:rPr sz="2000" b="1" i="0">
+                <a:solidFill>
+                  <a:srgbClr val="141824"/>
+                </a:solidFill>
+                <a:latin typeface="Arial"/>
+              </a:rPr>
+              <a:t>Instruction (reasoning scaffolds) + Action (tools/skills) ADD realized capability — not plumbing.</a:t>
+            </a:r>
+          </a:p>
+          <a:p>
+            <a:pPr algn="l">
+              <a:spcAft>
+                <a:spcPts val="1000"/>
+              </a:spcAft>
+            </a:pPr>
+            <a:r>
+              <a:rPr sz="1800" b="0" i="0">
+                <a:solidFill>
+                  <a:srgbClr val="141824"/>
+                </a:solidFill>
+                <a:latin typeface="Arial"/>
+              </a:rPr>
+              <a:t>•  To raise the ceiling itself, you need loop 2: RL on the weights (co-evolution). Different game.</a:t>
+            </a:r>
+          </a:p>
+          <a:p>
+            <a:pPr algn="l">
+              <a:spcAft>
+                <a:spcPts val="600"/>
+              </a:spcAft>
+            </a:pPr>
+            <a:r>
+              <a:rPr sz="2000" b="1" i="0">
+                <a:solidFill>
+                  <a:srgbClr val="141824"/>
+                </a:solidFill>
+                <a:latin typeface="Arial"/>
+              </a:rPr>
+              <a:t>On a frozen model, the most capability-like levers are reasoning scaffolds + new tools.</a:t>
             </a:r>
           </a:p>
         </p:txBody>
@@ -6118,14 +6175,14 @@
                 </a:solidFill>
                 <a:latin typeface="Arial"/>
               </a:rPr>
-              <a:t>The spectrum of harness value (all 3 levers, real numbers)</a:t>
+              <a:t>The harness elicits latent reasoning (GSM8K)</a:t>
             </a:r>
           </a:p>
         </p:txBody>
       </p:sp>
       <p:pic>
         <p:nvPicPr>
-          <p:cNvPr id="3" name="Picture 2" descr="levers-spectrum-chart.png"/>
+          <p:cNvPr id="3" name="Picture 2" descr="reasoning-chart.png"/>
           <p:cNvPicPr>
             <a:picLocks noChangeAspect="1"/>
           </p:cNvPicPr>
@@ -6140,7 +6197,7 @@
         <p:spPr>
           <a:xfrm>
             <a:off x="1249527" y="1737360"/>
-            <a:ext cx="9692640" cy="3415501"/>
+            <a:ext cx="9692640" cy="3060833"/>
           </a:xfrm>
           <a:prstGeom prst="rect">
             <a:avLst/>
@@ -6181,7 +6238,7 @@
                 </a:solidFill>
                 <a:latin typeface="Arial"/>
               </a:rPr>
-              <a:t>Action ADDS capability (private KB 0.00 → 1.00, can't → can). Instruction reshapes reasoning (GSM8K 0.65 → 0.97). Control recovers latent (telecom 0.50 → 0.75, a crutch). Same frozen model throughout.</a:t>
+              <a:t>Same frozen qwen3:8B. A reflect scaffold (re-derive + self-check) lifts GSM8K 0.65 → 0.97 and CRT 0.53 → 0.73. Realized reasoning, not I/O.</a:t>
             </a:r>
           </a:p>
         </p:txBody>
@@ -6220,8 +6277,8 @@
         </p:nvSpPr>
         <p:spPr>
           <a:xfrm>
-            <a:off x="822960" y="640080"/>
-            <a:ext cx="10515600" cy="1188720"/>
+            <a:off x="822960" y="502920"/>
+            <a:ext cx="10515600" cy="914400"/>
           </a:xfrm>
           <a:prstGeom prst="rect">
             <a:avLst/>
@@ -6240,27 +6297,51 @@
               </a:spcAft>
             </a:pPr>
             <a:r>
-              <a:rPr sz="3400" b="1" i="0">
-                <a:solidFill>
-                  <a:srgbClr val="141824"/>
-                </a:solidFill>
-                <a:latin typeface="Arial"/>
-              </a:rPr>
-              <a:t>The Action lever — genuine capability (can't → can)</a:t>
-            </a:r>
-          </a:p>
-        </p:txBody>
-      </p:sp>
-      <p:sp>
-        <p:nvSpPr>
-          <p:cNvPr id="3" name="TextBox 2"/>
+              <a:rPr sz="3000" b="1" i="0">
+                <a:solidFill>
+                  <a:srgbClr val="141824"/>
+                </a:solidFill>
+                <a:latin typeface="Arial"/>
+              </a:rPr>
+              <a:t>The spectrum of harness value (all 3 levers, real numbers)</a:t>
+            </a:r>
+          </a:p>
+        </p:txBody>
+      </p:sp>
+      <p:pic>
+        <p:nvPicPr>
+          <p:cNvPr id="3" name="Picture 2" descr="levers-spectrum-chart.png"/>
+          <p:cNvPicPr>
+            <a:picLocks noChangeAspect="1"/>
+          </p:cNvPicPr>
+          <p:nvPr/>
+        </p:nvPicPr>
+        <p:blipFill>
+          <a:blip r:embed="rId2"/>
+          <a:stretch>
+            <a:fillRect/>
+          </a:stretch>
+        </p:blipFill>
+        <p:spPr>
+          <a:xfrm>
+            <a:off x="1249527" y="1737360"/>
+            <a:ext cx="9692640" cy="3415501"/>
+          </a:xfrm>
+          <a:prstGeom prst="rect">
+            <a:avLst/>
+          </a:prstGeom>
+        </p:spPr>
+      </p:pic>
+      <p:sp>
+        <p:nvSpPr>
+          <p:cNvPr id="4" name="TextBox 3"/>
           <p:cNvSpPr txBox="1"/>
           <p:nvPr/>
         </p:nvSpPr>
         <p:spPr>
           <a:xfrm>
-            <a:off x="868680" y="2148840"/>
-            <a:ext cx="10424160" cy="4297680"/>
+            <a:off x="822960" y="6126480"/>
+            <a:ext cx="10515600" cy="548640"/>
           </a:xfrm>
           <a:prstGeom prst="rect">
             <a:avLst/>
@@ -6273,83 +6354,19 @@
           </a:bodyPr>
           <a:lstStyle/>
           <a:p>
-            <a:pPr algn="l">
-              <a:spcAft>
-                <a:spcPts val="600"/>
-              </a:spcAft>
-            </a:pPr>
-            <a:r>
-              <a:rPr sz="2000" b="1" i="0">
-                <a:solidFill>
-                  <a:srgbClr val="141824"/>
-                </a:solidFill>
-                <a:latin typeface="Arial"/>
-              </a:rPr>
-              <a:t>A frozen model CANNOT know your private data — it's not in the weights.</a:t>
-            </a:r>
-          </a:p>
-          <a:p>
-            <a:pPr algn="l">
-              <a:spcAft>
-                <a:spcPts val="1000"/>
-              </a:spcAft>
-            </a:pPr>
-            <a:r>
-              <a:rPr sz="1800" b="0" i="0">
-                <a:solidFill>
-                  <a:srgbClr val="141824"/>
-                </a:solidFill>
-                <a:latin typeface="Arial"/>
-              </a:rPr>
-              <a:t>•  Vanilla on a private company KB: 0/12 — every fact hallucinated (Sentinel Arm → $12,500, not $8,450).</a:t>
-            </a:r>
-          </a:p>
-          <a:p>
-            <a:pPr algn="l">
-              <a:spcAft>
-                <a:spcPts val="1000"/>
-              </a:spcAft>
-            </a:pPr>
-            <a:r>
-              <a:rPr sz="1800" b="0" i="0">
-                <a:solidFill>
-                  <a:srgbClr val="141824"/>
-                </a:solidFill>
-                <a:latin typeface="Arial"/>
-              </a:rPr>
-              <a:t>•  Add a kb_search tool (Action lever): 12/12 — it retrieves the fact and answers.</a:t>
-            </a:r>
-          </a:p>
-          <a:p>
-            <a:pPr algn="l">
-              <a:spcAft>
-                <a:spcPts val="600"/>
-              </a:spcAft>
-            </a:pPr>
-            <a:r>
-              <a:rPr sz="2000" b="1" i="0">
-                <a:solidFill>
-                  <a:srgbClr val="141824"/>
-                </a:solidFill>
-                <a:latin typeface="Arial"/>
-              </a:rPr>
-              <a:t>That's NEW capability, not a crutch — and it's the whole reason vertical agents exist:</a:t>
-            </a:r>
-          </a:p>
-          <a:p>
-            <a:pPr algn="l">
-              <a:spcAft>
-                <a:spcPts val="1000"/>
-              </a:spcAft>
-            </a:pPr>
-            <a:r>
-              <a:rPr sz="1800" b="0" i="0">
-                <a:solidFill>
-                  <a:srgbClr val="141824"/>
-                </a:solidFill>
-                <a:latin typeface="Arial"/>
-              </a:rPr>
-              <a:t>•  proprietary knowledge, tools, and APIs the base model will never have.</a:t>
+            <a:pPr algn="ctr">
+              <a:spcAft>
+                <a:spcPts val="800"/>
+              </a:spcAft>
+            </a:pPr>
+            <a:r>
+              <a:rPr sz="1300" b="0" i="0">
+                <a:solidFill>
+                  <a:srgbClr val="666C7A"/>
+                </a:solidFill>
+                <a:latin typeface="Arial"/>
+              </a:rPr>
+              <a:t>Action ADDS capability (private KB 0.00 → 1.00, can't → can). Instruction reshapes reasoning (GSM8K 0.65 → 0.97). Control recovers latent (telecom 0.50 → 0.75, a crutch). Same frozen model throughout.</a:t>
             </a:r>
           </a:p>
         </p:txBody>
@@ -6368,7 +6385,7 @@
     <p:bg>
       <p:bgPr>
         <a:solidFill>
-          <a:srgbClr val="141824"/>
+          <a:srgbClr val="F7F7FB"/>
         </a:solidFill>
         <a:effectLst/>
       </p:bgPr>
@@ -6389,7 +6406,7 @@
         <p:spPr>
           <a:xfrm>
             <a:off x="822960" y="640080"/>
-            <a:ext cx="10515600" cy="914400"/>
+            <a:ext cx="10515600" cy="1188720"/>
           </a:xfrm>
           <a:prstGeom prst="rect">
             <a:avLst/>
@@ -6408,13 +6425,13 @@
               </a:spcAft>
             </a:pPr>
             <a:r>
-              <a:rPr sz="3600" b="1" i="0">
-                <a:solidFill>
-                  <a:srgbClr val="FFFFFF"/>
-                </a:solidFill>
-                <a:latin typeface="Arial"/>
-              </a:rPr>
-              <a:t>Takeaways</a:t>
+              <a:rPr sz="3400" b="1" i="0">
+                <a:solidFill>
+                  <a:srgbClr val="141824"/>
+                </a:solidFill>
+                <a:latin typeface="Arial"/>
+              </a:rPr>
+              <a:t>The Action lever — genuine capability (can't → can)</a:t>
             </a:r>
           </a:p>
         </p:txBody>
@@ -6427,8 +6444,8 @@
         </p:nvSpPr>
         <p:spPr>
           <a:xfrm>
-            <a:off x="868680" y="1828800"/>
-            <a:ext cx="10515600" cy="4572000"/>
+            <a:off x="868680" y="2148840"/>
+            <a:ext cx="10424160" cy="4297680"/>
           </a:xfrm>
           <a:prstGeom prst="rect">
             <a:avLst/>
@@ -6443,97 +6460,81 @@
           <a:p>
             <a:pPr algn="l">
               <a:spcAft>
-                <a:spcPts val="1600"/>
+                <a:spcPts val="600"/>
               </a:spcAft>
             </a:pPr>
             <a:r>
               <a:rPr sz="2000" b="1" i="0">
                 <a:solidFill>
-                  <a:srgbClr val="22C55E"/>
-                </a:solidFill>
-                <a:latin typeface="Arial"/>
-              </a:rPr>
-              <a:t>1.  The harness, not just the model, determines REALIZED agent performance.</a:t>
-            </a:r>
-          </a:p>
-          <a:p>
-            <a:pPr algn="l">
-              <a:spcAft>
-                <a:spcPts val="1600"/>
-              </a:spcAft>
-            </a:pPr>
-            <a:r>
-              <a:rPr sz="2000" b="0" i="0">
-                <a:solidFill>
-                  <a:srgbClr val="FFFFFF"/>
-                </a:solidFill>
-                <a:latin typeface="Arial"/>
-              </a:rPr>
-              <a:t>2.  We improved a frozen model's benchmark score by evolving the harness alone (0.50 → 0.75).</a:t>
-            </a:r>
-          </a:p>
-          <a:p>
-            <a:pPr algn="l">
-              <a:spcAft>
-                <a:spcPts val="1600"/>
-              </a:spcAft>
-            </a:pPr>
-            <a:r>
-              <a:rPr sz="2000" b="0" i="0">
-                <a:solidFill>
-                  <a:srgbClr val="22C55E"/>
-                </a:solidFill>
-                <a:latin typeface="Arial"/>
-              </a:rPr>
-              <a:t>3.  Vertical agents need a STRONG BENCHMARK to evolve against — it's the reward signal.</a:t>
-            </a:r>
-          </a:p>
-          <a:p>
-            <a:pPr algn="l">
-              <a:spcAft>
-                <a:spcPts val="1600"/>
-              </a:spcAft>
-            </a:pPr>
-            <a:r>
-              <a:rPr sz="2000" b="0" i="0">
-                <a:solidFill>
-                  <a:srgbClr val="FFFFFF"/>
-                </a:solidFill>
-                <a:latin typeface="Arial"/>
-              </a:rPr>
-              <a:t>4.  Off-the-shelf model + off-the-shelf harness plateaus: nothing tells you which lever to move.</a:t>
-            </a:r>
-          </a:p>
-          <a:p>
-            <a:pPr algn="l">
-              <a:spcAft>
-                <a:spcPts val="1600"/>
-              </a:spcAft>
-            </a:pPr>
-            <a:r>
-              <a:rPr sz="2000" b="0" i="0">
-                <a:solidFill>
-                  <a:srgbClr val="22C55E"/>
-                </a:solidFill>
-                <a:latin typeface="Arial"/>
-              </a:rPr>
-              <a:t>5.  Agentic RL: a stronger model reads traces → picks the lever → re-runs → keeps what improves.</a:t>
-            </a:r>
-          </a:p>
-          <a:p>
-            <a:pPr algn="l">
-              <a:spcAft>
-                <a:spcPts val="1600"/>
-              </a:spcAft>
-            </a:pPr>
-            <a:r>
-              <a:rPr sz="2000" b="0" i="0">
-                <a:solidFill>
-                  <a:srgbClr val="FFFFFF"/>
-                </a:solidFill>
-                <a:latin typeface="Arial"/>
-              </a:rPr>
-              <a:t>6.  This is how you squeeze a cheap, frozen model to punch up on YOUR problem.</a:t>
+                  <a:srgbClr val="141824"/>
+                </a:solidFill>
+                <a:latin typeface="Arial"/>
+              </a:rPr>
+              <a:t>A frozen model CANNOT know your private data — it's not in the weights.</a:t>
+            </a:r>
+          </a:p>
+          <a:p>
+            <a:pPr algn="l">
+              <a:spcAft>
+                <a:spcPts val="1000"/>
+              </a:spcAft>
+            </a:pPr>
+            <a:r>
+              <a:rPr sz="1800" b="0" i="0">
+                <a:solidFill>
+                  <a:srgbClr val="141824"/>
+                </a:solidFill>
+                <a:latin typeface="Arial"/>
+              </a:rPr>
+              <a:t>•  Vanilla on a private company KB: 0/12 — every fact hallucinated (Sentinel Arm → $12,500, not $8,450).</a:t>
+            </a:r>
+          </a:p>
+          <a:p>
+            <a:pPr algn="l">
+              <a:spcAft>
+                <a:spcPts val="1000"/>
+              </a:spcAft>
+            </a:pPr>
+            <a:r>
+              <a:rPr sz="1800" b="0" i="0">
+                <a:solidFill>
+                  <a:srgbClr val="141824"/>
+                </a:solidFill>
+                <a:latin typeface="Arial"/>
+              </a:rPr>
+              <a:t>•  Add a kb_search tool (Action lever): 12/12 — it retrieves the fact and answers.</a:t>
+            </a:r>
+          </a:p>
+          <a:p>
+            <a:pPr algn="l">
+              <a:spcAft>
+                <a:spcPts val="600"/>
+              </a:spcAft>
+            </a:pPr>
+            <a:r>
+              <a:rPr sz="2000" b="1" i="0">
+                <a:solidFill>
+                  <a:srgbClr val="141824"/>
+                </a:solidFill>
+                <a:latin typeface="Arial"/>
+              </a:rPr>
+              <a:t>That's NEW capability, not a crutch — and it's the whole reason vertical agents exist:</a:t>
+            </a:r>
+          </a:p>
+          <a:p>
+            <a:pPr algn="l">
+              <a:spcAft>
+                <a:spcPts val="1000"/>
+              </a:spcAft>
+            </a:pPr>
+            <a:r>
+              <a:rPr sz="1800" b="0" i="0">
+                <a:solidFill>
+                  <a:srgbClr val="141824"/>
+                </a:solidFill>
+                <a:latin typeface="Arial"/>
+              </a:rPr>
+              <a:t>•  proprietary knowledge, tools, and APIs the base model will never have.</a:t>
             </a:r>
           </a:p>
         </p:txBody>
@@ -6702,6 +6703,190 @@
                 <a:latin typeface="Arial"/>
               </a:rPr>
               <a:t>•  Harness = how much of that ceiling you actually realize.</a:t>
+            </a:r>
+          </a:p>
+        </p:txBody>
+      </p:sp>
+    </p:spTree>
+  </p:cSld>
+  <p:clrMapOvr>
+    <a:masterClrMapping/>
+  </p:clrMapOvr>
+</p:sld>
+</file>
+
+<file path=ppt/slides/slide30.xml><?xml version="1.0" encoding="utf-8"?>
+<p:sld xmlns:a="http://schemas.openxmlformats.org/drawingml/2006/main" xmlns:p="http://schemas.openxmlformats.org/presentationml/2006/main" xmlns:r="http://schemas.openxmlformats.org/officeDocument/2006/relationships">
+  <p:cSld>
+    <p:bg>
+      <p:bgPr>
+        <a:solidFill>
+          <a:srgbClr val="141824"/>
+        </a:solidFill>
+        <a:effectLst/>
+      </p:bgPr>
+    </p:bg>
+    <p:spTree>
+      <p:nvGrpSpPr>
+        <p:cNvPr id="1" name=""/>
+        <p:cNvGrpSpPr/>
+        <p:nvPr/>
+      </p:nvGrpSpPr>
+      <p:grpSpPr/>
+      <p:sp>
+        <p:nvSpPr>
+          <p:cNvPr id="2" name="TextBox 1"/>
+          <p:cNvSpPr txBox="1"/>
+          <p:nvPr/>
+        </p:nvSpPr>
+        <p:spPr>
+          <a:xfrm>
+            <a:off x="822960" y="640080"/>
+            <a:ext cx="10515600" cy="914400"/>
+          </a:xfrm>
+          <a:prstGeom prst="rect">
+            <a:avLst/>
+          </a:prstGeom>
+          <a:noFill/>
+        </p:spPr>
+        <p:txBody>
+          <a:bodyPr wrap="square">
+            <a:spAutoFit/>
+          </a:bodyPr>
+          <a:lstStyle/>
+          <a:p>
+            <a:pPr algn="l">
+              <a:spcAft>
+                <a:spcPts val="800"/>
+              </a:spcAft>
+            </a:pPr>
+            <a:r>
+              <a:rPr sz="3600" b="1" i="0">
+                <a:solidFill>
+                  <a:srgbClr val="FFFFFF"/>
+                </a:solidFill>
+                <a:latin typeface="Arial"/>
+              </a:rPr>
+              <a:t>Takeaways</a:t>
+            </a:r>
+          </a:p>
+        </p:txBody>
+      </p:sp>
+      <p:sp>
+        <p:nvSpPr>
+          <p:cNvPr id="3" name="TextBox 2"/>
+          <p:cNvSpPr txBox="1"/>
+          <p:nvPr/>
+        </p:nvSpPr>
+        <p:spPr>
+          <a:xfrm>
+            <a:off x="868680" y="1828800"/>
+            <a:ext cx="10515600" cy="4572000"/>
+          </a:xfrm>
+          <a:prstGeom prst="rect">
+            <a:avLst/>
+          </a:prstGeom>
+          <a:noFill/>
+        </p:spPr>
+        <p:txBody>
+          <a:bodyPr wrap="square">
+            <a:spAutoFit/>
+          </a:bodyPr>
+          <a:lstStyle/>
+          <a:p>
+            <a:pPr algn="l">
+              <a:spcAft>
+                <a:spcPts val="1600"/>
+              </a:spcAft>
+            </a:pPr>
+            <a:r>
+              <a:rPr sz="2000" b="1" i="0">
+                <a:solidFill>
+                  <a:srgbClr val="22C55E"/>
+                </a:solidFill>
+                <a:latin typeface="Arial"/>
+              </a:rPr>
+              <a:t>1.  The deliverable is the LOOP: run → read traces → pick the lever → evolve → re-run. Not the technique.</a:t>
+            </a:r>
+          </a:p>
+          <a:p>
+            <a:pPr algn="l">
+              <a:spcAft>
+                <a:spcPts val="1600"/>
+              </a:spcAft>
+            </a:pPr>
+            <a:r>
+              <a:rPr sz="2000" b="0" i="0">
+                <a:solidFill>
+                  <a:srgbClr val="FFFFFF"/>
+                </a:solidFill>
+                <a:latin typeface="Arial"/>
+              </a:rPr>
+              <a:t>2.  Every lever is chosen FROM a trace — the trace names the failure; you match a lever to it.</a:t>
+            </a:r>
+          </a:p>
+          <a:p>
+            <a:pPr algn="l">
+              <a:spcAft>
+                <a:spcPts val="1600"/>
+              </a:spcAft>
+            </a:pPr>
+            <a:r>
+              <a:rPr sz="2000" b="0" i="0">
+                <a:solidFill>
+                  <a:srgbClr val="22C55E"/>
+                </a:solidFill>
+                <a:latin typeface="Arial"/>
+              </a:rPr>
+              <a:t>3.  The harness, not the weights, sets REALIZED performance — proven across 3 levers, frozen model.</a:t>
+            </a:r>
+          </a:p>
+          <a:p>
+            <a:pPr algn="l">
+              <a:spcAft>
+                <a:spcPts val="1600"/>
+              </a:spcAft>
+            </a:pPr>
+            <a:r>
+              <a:rPr sz="2000" b="0" i="0">
+                <a:solidFill>
+                  <a:srgbClr val="FFFFFF"/>
+                </a:solidFill>
+                <a:latin typeface="Arial"/>
+              </a:rPr>
+              <a:t>4.  Vertical agents need a STRONG BENCHMARK to evolve against — it's the reward signal in the loop.</a:t>
+            </a:r>
+          </a:p>
+          <a:p>
+            <a:pPr algn="l">
+              <a:spcAft>
+                <a:spcPts val="1600"/>
+              </a:spcAft>
+            </a:pPr>
+            <a:r>
+              <a:rPr sz="2000" b="0" i="0">
+                <a:solidFill>
+                  <a:srgbClr val="22C55E"/>
+                </a:solidFill>
+                <a:latin typeface="Arial"/>
+              </a:rPr>
+              <a:t>5.  Off-the-shelf model + off-the-shelf harness plateaus: no trace signal → nothing to evolve on.</a:t>
+            </a:r>
+          </a:p>
+          <a:p>
+            <a:pPr algn="l">
+              <a:spcAft>
+                <a:spcPts val="1600"/>
+              </a:spcAft>
+            </a:pPr>
+            <a:r>
+              <a:rPr sz="2000" b="0" i="0">
+                <a:solidFill>
+                  <a:srgbClr val="FFFFFF"/>
+                </a:solidFill>
+                <a:latin typeface="Arial"/>
+              </a:rPr>
+              <a:t>6.  This is how you squeeze a cheap, frozen model to punch up on YOUR vertical.</a:t>
             </a:r>
           </a:p>
         </p:txBody>

</xml_diff>